<commit_message>
Update the design of the IoT simulator.
</commit_message>
<xml_diff>
--- a/2_SystemDesign_Doc/6_Thermal_State_Monitor_Desgin_Img/designDoc.pptx
+++ b/2_SystemDesign_Doc/6_Thermal_State_Monitor_Desgin_Img/designDoc.pptx
@@ -5,11 +5,13 @@
     <p:sldMasterId id="2147483648" r:id="rId1"/>
   </p:sldMasterIdLst>
   <p:notesMasterIdLst>
-    <p:notesMasterId r:id="rId4"/>
+    <p:notesMasterId r:id="rId6"/>
   </p:notesMasterIdLst>
   <p:sldIdLst>
     <p:sldId id="256" r:id="rId2"/>
     <p:sldId id="269" r:id="rId3"/>
+    <p:sldId id="270" r:id="rId4"/>
+    <p:sldId id="259" r:id="rId5"/>
   </p:sldIdLst>
   <p:sldSz cx="12192000" cy="6858000"/>
   <p:notesSz cx="6858000" cy="9144000"/>
@@ -108,6 +110,11 @@
       </a:defRPr>
     </a:lvl9pPr>
   </p:defaultTextStyle>
+  <p:extLst>
+    <p:ext uri="{EFAFB233-063F-42B5-8137-9DF3F51BA10A}">
+      <p15:sldGuideLst xmlns:p15="http://schemas.microsoft.com/office/powerpoint/2012/main"/>
+    </p:ext>
+  </p:extLst>
 </p:presentation>
 </file>
 
@@ -193,7 +200,7 @@
           <a:p>
             <a:fld id="{BF2FBF22-D265-4007-B382-98D1AEF44D2E}" type="datetimeFigureOut">
               <a:rPr lang="en-SG" smtClean="0"/>
-              <a:t>19/6/2026</a:t>
+              <a:t>20/6/2026</a:t>
             </a:fld>
             <a:endParaRPr lang="en-SG"/>
           </a:p>
@@ -569,6 +576,90 @@
 </p:notes>
 </file>
 
+<file path=ppt/notesSlides/notesSlide2.xml><?xml version="1.0" encoding="utf-8"?>
+<p:notes xmlns:a="http://schemas.openxmlformats.org/drawingml/2006/main" xmlns:r="http://schemas.openxmlformats.org/officeDocument/2006/relationships" xmlns:p="http://schemas.openxmlformats.org/presentationml/2006/main">
+  <p:cSld>
+    <p:spTree>
+      <p:nvGrpSpPr>
+        <p:cNvPr id="1" name=""/>
+        <p:cNvGrpSpPr/>
+        <p:nvPr/>
+      </p:nvGrpSpPr>
+      <p:grpSpPr>
+        <a:xfrm>
+          <a:off x="0" y="0"/>
+          <a:ext cx="0" cy="0"/>
+          <a:chOff x="0" y="0"/>
+          <a:chExt cx="0" cy="0"/>
+        </a:xfrm>
+      </p:grpSpPr>
+      <p:sp>
+        <p:nvSpPr>
+          <p:cNvPr id="2" name="Slide Image Placeholder 1"/>
+          <p:cNvSpPr>
+            <a:spLocks noGrp="1" noRot="1" noChangeAspect="1"/>
+          </p:cNvSpPr>
+          <p:nvPr>
+            <p:ph type="sldImg"/>
+          </p:nvPr>
+        </p:nvSpPr>
+        <p:spPr/>
+      </p:sp>
+      <p:sp>
+        <p:nvSpPr>
+          <p:cNvPr id="3" name="Notes Placeholder 2"/>
+          <p:cNvSpPr>
+            <a:spLocks noGrp="1"/>
+          </p:cNvSpPr>
+          <p:nvPr>
+            <p:ph type="body" idx="1"/>
+          </p:nvPr>
+        </p:nvSpPr>
+        <p:spPr/>
+        <p:txBody>
+          <a:bodyPr/>
+          <a:lstStyle/>
+          <a:p>
+            <a:endParaRPr lang="en-SG"/>
+          </a:p>
+        </p:txBody>
+      </p:sp>
+      <p:sp>
+        <p:nvSpPr>
+          <p:cNvPr id="4" name="Slide Number Placeholder 3"/>
+          <p:cNvSpPr>
+            <a:spLocks noGrp="1"/>
+          </p:cNvSpPr>
+          <p:nvPr>
+            <p:ph type="sldNum" sz="quarter" idx="5"/>
+          </p:nvPr>
+        </p:nvSpPr>
+        <p:spPr/>
+        <p:txBody>
+          <a:bodyPr/>
+          <a:lstStyle/>
+          <a:p>
+            <a:fld id="{EBF6B7D6-7851-49B5-BE5D-D00B7BAA4937}" type="slidenum">
+              <a:rPr lang="en-SG" smtClean="0"/>
+              <a:t>4</a:t>
+            </a:fld>
+            <a:endParaRPr lang="en-SG"/>
+          </a:p>
+        </p:txBody>
+      </p:sp>
+    </p:spTree>
+    <p:extLst>
+      <p:ext uri="{BB962C8B-B14F-4D97-AF65-F5344CB8AC3E}">
+        <p14:creationId xmlns:p14="http://schemas.microsoft.com/office/powerpoint/2010/main" val="3907934090"/>
+      </p:ext>
+    </p:extLst>
+  </p:cSld>
+  <p:clrMapOvr>
+    <a:masterClrMapping/>
+  </p:clrMapOvr>
+</p:notes>
+</file>
+
 <file path=ppt/slideLayouts/slideLayout1.xml><?xml version="1.0" encoding="utf-8"?>
 <p:sldLayout xmlns:a="http://schemas.openxmlformats.org/drawingml/2006/main" xmlns:r="http://schemas.openxmlformats.org/officeDocument/2006/relationships" xmlns:p="http://schemas.openxmlformats.org/presentationml/2006/main" type="title" preserve="1">
   <p:cSld name="Title Slide">
@@ -718,7 +809,7 @@
           <a:p>
             <a:fld id="{236E59C2-7C94-434E-8336-162F25205750}" type="datetimeFigureOut">
               <a:rPr lang="en-SG" smtClean="0"/>
-              <a:t>19/6/2026</a:t>
+              <a:t>20/6/2026</a:t>
             </a:fld>
             <a:endParaRPr lang="en-SG"/>
           </a:p>
@@ -918,7 +1009,7 @@
           <a:p>
             <a:fld id="{236E59C2-7C94-434E-8336-162F25205750}" type="datetimeFigureOut">
               <a:rPr lang="en-SG" smtClean="0"/>
-              <a:t>19/6/2026</a:t>
+              <a:t>20/6/2026</a:t>
             </a:fld>
             <a:endParaRPr lang="en-SG"/>
           </a:p>
@@ -1128,7 +1219,7 @@
           <a:p>
             <a:fld id="{236E59C2-7C94-434E-8336-162F25205750}" type="datetimeFigureOut">
               <a:rPr lang="en-SG" smtClean="0"/>
-              <a:t>19/6/2026</a:t>
+              <a:t>20/6/2026</a:t>
             </a:fld>
             <a:endParaRPr lang="en-SG"/>
           </a:p>
@@ -1328,7 +1419,7 @@
           <a:p>
             <a:fld id="{236E59C2-7C94-434E-8336-162F25205750}" type="datetimeFigureOut">
               <a:rPr lang="en-SG" smtClean="0"/>
-              <a:t>19/6/2026</a:t>
+              <a:t>20/6/2026</a:t>
             </a:fld>
             <a:endParaRPr lang="en-SG"/>
           </a:p>
@@ -1604,7 +1695,7 @@
           <a:p>
             <a:fld id="{236E59C2-7C94-434E-8336-162F25205750}" type="datetimeFigureOut">
               <a:rPr lang="en-SG" smtClean="0"/>
-              <a:t>19/6/2026</a:t>
+              <a:t>20/6/2026</a:t>
             </a:fld>
             <a:endParaRPr lang="en-SG"/>
           </a:p>
@@ -1872,7 +1963,7 @@
           <a:p>
             <a:fld id="{236E59C2-7C94-434E-8336-162F25205750}" type="datetimeFigureOut">
               <a:rPr lang="en-SG" smtClean="0"/>
-              <a:t>19/6/2026</a:t>
+              <a:t>20/6/2026</a:t>
             </a:fld>
             <a:endParaRPr lang="en-SG"/>
           </a:p>
@@ -2287,7 +2378,7 @@
           <a:p>
             <a:fld id="{236E59C2-7C94-434E-8336-162F25205750}" type="datetimeFigureOut">
               <a:rPr lang="en-SG" smtClean="0"/>
-              <a:t>19/6/2026</a:t>
+              <a:t>20/6/2026</a:t>
             </a:fld>
             <a:endParaRPr lang="en-SG"/>
           </a:p>
@@ -2429,7 +2520,7 @@
           <a:p>
             <a:fld id="{236E59C2-7C94-434E-8336-162F25205750}" type="datetimeFigureOut">
               <a:rPr lang="en-SG" smtClean="0"/>
-              <a:t>19/6/2026</a:t>
+              <a:t>20/6/2026</a:t>
             </a:fld>
             <a:endParaRPr lang="en-SG"/>
           </a:p>
@@ -2542,7 +2633,7 @@
           <a:p>
             <a:fld id="{236E59C2-7C94-434E-8336-162F25205750}" type="datetimeFigureOut">
               <a:rPr lang="en-SG" smtClean="0"/>
-              <a:t>19/6/2026</a:t>
+              <a:t>20/6/2026</a:t>
             </a:fld>
             <a:endParaRPr lang="en-SG"/>
           </a:p>
@@ -2855,7 +2946,7 @@
           <a:p>
             <a:fld id="{236E59C2-7C94-434E-8336-162F25205750}" type="datetimeFigureOut">
               <a:rPr lang="en-SG" smtClean="0"/>
-              <a:t>19/6/2026</a:t>
+              <a:t>20/6/2026</a:t>
             </a:fld>
             <a:endParaRPr lang="en-SG"/>
           </a:p>
@@ -3144,7 +3235,7 @@
           <a:p>
             <a:fld id="{236E59C2-7C94-434E-8336-162F25205750}" type="datetimeFigureOut">
               <a:rPr lang="en-SG" smtClean="0"/>
-              <a:t>19/6/2026</a:t>
+              <a:t>20/6/2026</a:t>
             </a:fld>
             <a:endParaRPr lang="en-SG"/>
           </a:p>
@@ -3387,7 +3478,7 @@
           <a:p>
             <a:fld id="{236E59C2-7C94-434E-8336-162F25205750}" type="datetimeFigureOut">
               <a:rPr lang="en-SG" smtClean="0"/>
-              <a:t>19/6/2026</a:t>
+              <a:t>20/6/2026</a:t>
             </a:fld>
             <a:endParaRPr lang="en-SG"/>
           </a:p>
@@ -12609,6 +12700,2560 @@
     <p:extLst>
       <p:ext uri="{BB962C8B-B14F-4D97-AF65-F5344CB8AC3E}">
         <p14:creationId xmlns:p14="http://schemas.microsoft.com/office/powerpoint/2010/main" val="2095436408"/>
+      </p:ext>
+    </p:extLst>
+  </p:cSld>
+  <p:clrMapOvr>
+    <a:masterClrMapping/>
+  </p:clrMapOvr>
+</p:sld>
+</file>
+
+<file path=ppt/slides/slide3.xml><?xml version="1.0" encoding="utf-8"?>
+<p:sld xmlns:a="http://schemas.openxmlformats.org/drawingml/2006/main" xmlns:r="http://schemas.openxmlformats.org/officeDocument/2006/relationships" xmlns:p="http://schemas.openxmlformats.org/presentationml/2006/main">
+  <p:cSld>
+    <p:spTree>
+      <p:nvGrpSpPr>
+        <p:cNvPr id="1" name=""/>
+        <p:cNvGrpSpPr/>
+        <p:nvPr/>
+      </p:nvGrpSpPr>
+      <p:grpSpPr>
+        <a:xfrm>
+          <a:off x="0" y="0"/>
+          <a:ext cx="0" cy="0"/>
+          <a:chOff x="0" y="0"/>
+          <a:chExt cx="0" cy="0"/>
+        </a:xfrm>
+      </p:grpSpPr>
+      <p:sp>
+        <p:nvSpPr>
+          <p:cNvPr id="37" name="Rectangle 36">
+            <a:extLst>
+              <a:ext uri="{FF2B5EF4-FFF2-40B4-BE49-F238E27FC236}">
+                <a16:creationId xmlns:a16="http://schemas.microsoft.com/office/drawing/2014/main" id="{CFD8E9A1-5B0E-55B8-9D0F-D65BC9E11F24}"/>
+              </a:ext>
+            </a:extLst>
+          </p:cNvPr>
+          <p:cNvSpPr/>
+          <p:nvPr/>
+        </p:nvSpPr>
+        <p:spPr>
+          <a:xfrm>
+            <a:off x="9629041" y="1337328"/>
+            <a:ext cx="1499207" cy="1767848"/>
+          </a:xfrm>
+          <a:prstGeom prst="rect">
+            <a:avLst/>
+          </a:prstGeom>
+          <a:solidFill>
+            <a:schemeClr val="accent6">
+              <a:lumMod val="20000"/>
+              <a:lumOff val="80000"/>
+            </a:schemeClr>
+          </a:solidFill>
+        </p:spPr>
+        <p:style>
+          <a:lnRef idx="2">
+            <a:schemeClr val="accent1">
+              <a:shade val="15000"/>
+            </a:schemeClr>
+          </a:lnRef>
+          <a:fillRef idx="1">
+            <a:schemeClr val="accent1"/>
+          </a:fillRef>
+          <a:effectRef idx="0">
+            <a:schemeClr val="accent1"/>
+          </a:effectRef>
+          <a:fontRef idx="minor">
+            <a:schemeClr val="lt1"/>
+          </a:fontRef>
+        </p:style>
+        <p:txBody>
+          <a:bodyPr rtlCol="0" anchor="ctr"/>
+          <a:lstStyle/>
+          <a:p>
+            <a:pPr algn="ctr"/>
+            <a:endParaRPr lang="en-SG" dirty="0"/>
+          </a:p>
+        </p:txBody>
+      </p:sp>
+      <p:sp>
+        <p:nvSpPr>
+          <p:cNvPr id="12" name="Rectangle 11">
+            <a:extLst>
+              <a:ext uri="{FF2B5EF4-FFF2-40B4-BE49-F238E27FC236}">
+                <a16:creationId xmlns:a16="http://schemas.microsoft.com/office/drawing/2014/main" id="{08FFF0E2-0429-31BB-DD18-FDB034272E98}"/>
+              </a:ext>
+            </a:extLst>
+          </p:cNvPr>
+          <p:cNvSpPr/>
+          <p:nvPr/>
+        </p:nvSpPr>
+        <p:spPr>
+          <a:xfrm>
+            <a:off x="5202880" y="1337332"/>
+            <a:ext cx="2697536" cy="1854339"/>
+          </a:xfrm>
+          <a:prstGeom prst="rect">
+            <a:avLst/>
+          </a:prstGeom>
+          <a:solidFill>
+            <a:schemeClr val="accent1">
+              <a:lumMod val="20000"/>
+              <a:lumOff val="80000"/>
+            </a:schemeClr>
+          </a:solidFill>
+        </p:spPr>
+        <p:style>
+          <a:lnRef idx="2">
+            <a:schemeClr val="accent1">
+              <a:shade val="15000"/>
+            </a:schemeClr>
+          </a:lnRef>
+          <a:fillRef idx="1">
+            <a:schemeClr val="accent1"/>
+          </a:fillRef>
+          <a:effectRef idx="0">
+            <a:schemeClr val="accent1"/>
+          </a:effectRef>
+          <a:fontRef idx="minor">
+            <a:schemeClr val="lt1"/>
+          </a:fontRef>
+        </p:style>
+        <p:txBody>
+          <a:bodyPr rtlCol="0" anchor="ctr"/>
+          <a:lstStyle/>
+          <a:p>
+            <a:pPr algn="ctr"/>
+            <a:endParaRPr lang="en-SG" dirty="0"/>
+          </a:p>
+        </p:txBody>
+      </p:sp>
+      <p:pic>
+        <p:nvPicPr>
+          <p:cNvPr id="4" name="Picture 3">
+            <a:extLst>
+              <a:ext uri="{FF2B5EF4-FFF2-40B4-BE49-F238E27FC236}">
+                <a16:creationId xmlns:a16="http://schemas.microsoft.com/office/drawing/2014/main" id="{841E3549-1C70-A92A-3F42-EF53C0B6F56F}"/>
+              </a:ext>
+            </a:extLst>
+          </p:cNvPr>
+          <p:cNvPicPr>
+            <a:picLocks noChangeAspect="1"/>
+          </p:cNvPicPr>
+          <p:nvPr/>
+        </p:nvPicPr>
+        <p:blipFill>
+          <a:blip r:embed="rId2"/>
+          <a:stretch>
+            <a:fillRect/>
+          </a:stretch>
+        </p:blipFill>
+        <p:spPr>
+          <a:xfrm>
+            <a:off x="760294" y="1337328"/>
+            <a:ext cx="3449940" cy="1854343"/>
+          </a:xfrm>
+          <a:prstGeom prst="rect">
+            <a:avLst/>
+          </a:prstGeom>
+          <a:ln w="19050">
+            <a:solidFill>
+              <a:schemeClr val="tx1"/>
+            </a:solidFill>
+          </a:ln>
+        </p:spPr>
+      </p:pic>
+      <p:cxnSp>
+        <p:nvCxnSpPr>
+          <p:cNvPr id="7" name="Straight Arrow Connector 6">
+            <a:extLst>
+              <a:ext uri="{FF2B5EF4-FFF2-40B4-BE49-F238E27FC236}">
+                <a16:creationId xmlns:a16="http://schemas.microsoft.com/office/drawing/2014/main" id="{2DE70A2D-54D5-A495-B08C-95CA5D1986E2}"/>
+              </a:ext>
+            </a:extLst>
+          </p:cNvPr>
+          <p:cNvCxnSpPr>
+            <a:cxnSpLocks/>
+            <a:stCxn id="4" idx="3"/>
+            <a:endCxn id="16" idx="1"/>
+          </p:cNvCxnSpPr>
+          <p:nvPr/>
+        </p:nvCxnSpPr>
+        <p:spPr>
+          <a:xfrm>
+            <a:off x="4210234" y="2264500"/>
+            <a:ext cx="1161156" cy="959"/>
+          </a:xfrm>
+          <a:prstGeom prst="straightConnector1">
+            <a:avLst/>
+          </a:prstGeom>
+          <a:ln>
+            <a:tailEnd type="triangle"/>
+          </a:ln>
+        </p:spPr>
+        <p:style>
+          <a:lnRef idx="2">
+            <a:schemeClr val="accent1"/>
+          </a:lnRef>
+          <a:fillRef idx="0">
+            <a:schemeClr val="accent1"/>
+          </a:fillRef>
+          <a:effectRef idx="1">
+            <a:schemeClr val="accent1"/>
+          </a:effectRef>
+          <a:fontRef idx="minor">
+            <a:schemeClr val="tx1"/>
+          </a:fontRef>
+        </p:style>
+      </p:cxnSp>
+      <p:sp>
+        <p:nvSpPr>
+          <p:cNvPr id="13" name="TextBox 12">
+            <a:extLst>
+              <a:ext uri="{FF2B5EF4-FFF2-40B4-BE49-F238E27FC236}">
+                <a16:creationId xmlns:a16="http://schemas.microsoft.com/office/drawing/2014/main" id="{64D5EB3F-F99F-2E52-A121-06D83865A8E2}"/>
+              </a:ext>
+            </a:extLst>
+          </p:cNvPr>
+          <p:cNvSpPr txBox="1"/>
+          <p:nvPr/>
+        </p:nvSpPr>
+        <p:spPr>
+          <a:xfrm>
+            <a:off x="4152438" y="2277279"/>
+            <a:ext cx="1331611" cy="461665"/>
+          </a:xfrm>
+          <a:prstGeom prst="rect">
+            <a:avLst/>
+          </a:prstGeom>
+          <a:noFill/>
+        </p:spPr>
+        <p:txBody>
+          <a:bodyPr wrap="square" rtlCol="0">
+            <a:spAutoFit/>
+          </a:bodyPr>
+          <a:lstStyle/>
+          <a:p>
+            <a:r>
+              <a:rPr lang="en-US" sz="1200" b="1" dirty="0"/>
+              <a:t>Real Thermal State data </a:t>
+            </a:r>
+            <a:endParaRPr lang="en-SG" sz="1200" b="1" dirty="0"/>
+          </a:p>
+        </p:txBody>
+      </p:sp>
+      <p:sp>
+        <p:nvSpPr>
+          <p:cNvPr id="15" name="TextBox 14">
+            <a:extLst>
+              <a:ext uri="{FF2B5EF4-FFF2-40B4-BE49-F238E27FC236}">
+                <a16:creationId xmlns:a16="http://schemas.microsoft.com/office/drawing/2014/main" id="{F4E99981-B769-4146-7E39-1CCEF15DD573}"/>
+              </a:ext>
+            </a:extLst>
+          </p:cNvPr>
+          <p:cNvSpPr txBox="1"/>
+          <p:nvPr/>
+        </p:nvSpPr>
+        <p:spPr>
+          <a:xfrm>
+            <a:off x="4373654" y="1848041"/>
+            <a:ext cx="665806" cy="307777"/>
+          </a:xfrm>
+          <a:prstGeom prst="rect">
+            <a:avLst/>
+          </a:prstGeom>
+          <a:noFill/>
+        </p:spPr>
+        <p:txBody>
+          <a:bodyPr wrap="square" rtlCol="0">
+            <a:spAutoFit/>
+          </a:bodyPr>
+          <a:lstStyle/>
+          <a:p>
+            <a:r>
+              <a:rPr lang="en-US" sz="1400" b="1" dirty="0">
+                <a:solidFill>
+                  <a:schemeClr val="tx2">
+                    <a:lumMod val="75000"/>
+                    <a:lumOff val="25000"/>
+                  </a:schemeClr>
+                </a:solidFill>
+              </a:rPr>
+              <a:t>UDP</a:t>
+            </a:r>
+            <a:endParaRPr lang="en-SG" sz="1400" b="1" dirty="0">
+              <a:solidFill>
+                <a:schemeClr val="tx2">
+                  <a:lumMod val="75000"/>
+                  <a:lumOff val="25000"/>
+                </a:schemeClr>
+              </a:solidFill>
+            </a:endParaRPr>
+          </a:p>
+        </p:txBody>
+      </p:sp>
+      <p:sp>
+        <p:nvSpPr>
+          <p:cNvPr id="16" name="Rectangle 15">
+            <a:extLst>
+              <a:ext uri="{FF2B5EF4-FFF2-40B4-BE49-F238E27FC236}">
+                <a16:creationId xmlns:a16="http://schemas.microsoft.com/office/drawing/2014/main" id="{2B99600A-73CB-92FE-E4E9-F9CFB5E5B8AD}"/>
+              </a:ext>
+            </a:extLst>
+          </p:cNvPr>
+          <p:cNvSpPr/>
+          <p:nvPr/>
+        </p:nvSpPr>
+        <p:spPr>
+          <a:xfrm>
+            <a:off x="5371390" y="2094978"/>
+            <a:ext cx="924720" cy="340962"/>
+          </a:xfrm>
+          <a:prstGeom prst="rect">
+            <a:avLst/>
+          </a:prstGeom>
+          <a:solidFill>
+            <a:schemeClr val="accent2"/>
+          </a:solidFill>
+        </p:spPr>
+        <p:style>
+          <a:lnRef idx="2">
+            <a:schemeClr val="accent1">
+              <a:shade val="50000"/>
+            </a:schemeClr>
+          </a:lnRef>
+          <a:fillRef idx="1">
+            <a:schemeClr val="accent1"/>
+          </a:fillRef>
+          <a:effectRef idx="0">
+            <a:schemeClr val="accent1"/>
+          </a:effectRef>
+          <a:fontRef idx="minor">
+            <a:schemeClr val="lt1"/>
+          </a:fontRef>
+        </p:style>
+        <p:txBody>
+          <a:bodyPr rtlCol="0" anchor="ctr"/>
+          <a:lstStyle/>
+          <a:p>
+            <a:r>
+              <a:rPr lang="en-US" sz="1050" b="1" dirty="0"/>
+              <a:t>UDP Client</a:t>
+            </a:r>
+            <a:endParaRPr lang="en-SG" sz="1050" b="1" dirty="0"/>
+          </a:p>
+        </p:txBody>
+      </p:sp>
+      <p:sp>
+        <p:nvSpPr>
+          <p:cNvPr id="19" name="Rectangle 18">
+            <a:extLst>
+              <a:ext uri="{FF2B5EF4-FFF2-40B4-BE49-F238E27FC236}">
+                <a16:creationId xmlns:a16="http://schemas.microsoft.com/office/drawing/2014/main" id="{C02F5A03-AAE1-7142-E576-B6F2534795F4}"/>
+              </a:ext>
+            </a:extLst>
+          </p:cNvPr>
+          <p:cNvSpPr/>
+          <p:nvPr/>
+        </p:nvSpPr>
+        <p:spPr>
+          <a:xfrm>
+            <a:off x="6459530" y="1552314"/>
+            <a:ext cx="1291423" cy="295727"/>
+          </a:xfrm>
+          <a:prstGeom prst="rect">
+            <a:avLst/>
+          </a:prstGeom>
+          <a:solidFill>
+            <a:schemeClr val="bg2">
+              <a:lumMod val="25000"/>
+            </a:schemeClr>
+          </a:solidFill>
+          <a:ln>
+            <a:solidFill>
+              <a:schemeClr val="tx1"/>
+            </a:solidFill>
+          </a:ln>
+        </p:spPr>
+        <p:style>
+          <a:lnRef idx="2">
+            <a:schemeClr val="accent1">
+              <a:shade val="50000"/>
+            </a:schemeClr>
+          </a:lnRef>
+          <a:fillRef idx="1">
+            <a:schemeClr val="accent1"/>
+          </a:fillRef>
+          <a:effectRef idx="0">
+            <a:schemeClr val="accent1"/>
+          </a:effectRef>
+          <a:fontRef idx="minor">
+            <a:schemeClr val="lt1"/>
+          </a:fontRef>
+        </p:style>
+        <p:txBody>
+          <a:bodyPr rtlCol="0" anchor="ctr"/>
+          <a:lstStyle/>
+          <a:p>
+            <a:pPr algn="ctr"/>
+            <a:r>
+              <a:rPr lang="en-US" sz="1050" b="1" dirty="0" err="1"/>
+              <a:t>AES_Key</a:t>
+            </a:r>
+            <a:r>
+              <a:rPr lang="en-US" sz="1050" b="1" dirty="0"/>
+              <a:t> + </a:t>
+            </a:r>
+            <a:r>
+              <a:rPr lang="en-US" sz="1050" b="1" dirty="0" err="1"/>
+              <a:t>IoT_iv</a:t>
+            </a:r>
+            <a:endParaRPr lang="en-SG" sz="1050" b="1" dirty="0"/>
+          </a:p>
+        </p:txBody>
+      </p:sp>
+      <p:sp>
+        <p:nvSpPr>
+          <p:cNvPr id="20" name="Rectangle 19">
+            <a:extLst>
+              <a:ext uri="{FF2B5EF4-FFF2-40B4-BE49-F238E27FC236}">
+                <a16:creationId xmlns:a16="http://schemas.microsoft.com/office/drawing/2014/main" id="{983B69EC-B295-C280-5E58-E45D456C47E3}"/>
+              </a:ext>
+            </a:extLst>
+          </p:cNvPr>
+          <p:cNvSpPr/>
+          <p:nvPr/>
+        </p:nvSpPr>
+        <p:spPr>
+          <a:xfrm>
+            <a:off x="6477818" y="2094978"/>
+            <a:ext cx="1273135" cy="295727"/>
+          </a:xfrm>
+          <a:prstGeom prst="rect">
+            <a:avLst/>
+          </a:prstGeom>
+          <a:solidFill>
+            <a:schemeClr val="accent6">
+              <a:lumMod val="75000"/>
+            </a:schemeClr>
+          </a:solidFill>
+          <a:ln>
+            <a:solidFill>
+              <a:schemeClr val="tx1"/>
+            </a:solidFill>
+          </a:ln>
+        </p:spPr>
+        <p:style>
+          <a:lnRef idx="2">
+            <a:schemeClr val="accent1">
+              <a:shade val="50000"/>
+            </a:schemeClr>
+          </a:lnRef>
+          <a:fillRef idx="1">
+            <a:schemeClr val="accent1"/>
+          </a:fillRef>
+          <a:effectRef idx="0">
+            <a:schemeClr val="accent1"/>
+          </a:effectRef>
+          <a:fontRef idx="minor">
+            <a:schemeClr val="lt1"/>
+          </a:fontRef>
+        </p:style>
+        <p:txBody>
+          <a:bodyPr rtlCol="0" anchor="ctr"/>
+          <a:lstStyle/>
+          <a:p>
+            <a:pPr algn="ctr"/>
+            <a:r>
+              <a:rPr lang="en-US" sz="1050" b="1" dirty="0"/>
+              <a:t>Data Encryption</a:t>
+            </a:r>
+            <a:endParaRPr lang="en-SG" sz="1050" b="1" dirty="0"/>
+          </a:p>
+        </p:txBody>
+      </p:sp>
+      <p:cxnSp>
+        <p:nvCxnSpPr>
+          <p:cNvPr id="22" name="Straight Arrow Connector 21">
+            <a:extLst>
+              <a:ext uri="{FF2B5EF4-FFF2-40B4-BE49-F238E27FC236}">
+                <a16:creationId xmlns:a16="http://schemas.microsoft.com/office/drawing/2014/main" id="{C2F4EF31-54B6-D40E-F3B1-8096992492FC}"/>
+              </a:ext>
+            </a:extLst>
+          </p:cNvPr>
+          <p:cNvCxnSpPr>
+            <a:cxnSpLocks/>
+          </p:cNvCxnSpPr>
+          <p:nvPr/>
+        </p:nvCxnSpPr>
+        <p:spPr>
+          <a:xfrm flipV="1">
+            <a:off x="6296110" y="2251986"/>
+            <a:ext cx="181708" cy="0"/>
+          </a:xfrm>
+          <a:prstGeom prst="straightConnector1">
+            <a:avLst/>
+          </a:prstGeom>
+          <a:ln>
+            <a:tailEnd type="triangle"/>
+          </a:ln>
+        </p:spPr>
+        <p:style>
+          <a:lnRef idx="2">
+            <a:schemeClr val="accent1"/>
+          </a:lnRef>
+          <a:fillRef idx="0">
+            <a:schemeClr val="accent1"/>
+          </a:fillRef>
+          <a:effectRef idx="1">
+            <a:schemeClr val="accent1"/>
+          </a:effectRef>
+          <a:fontRef idx="minor">
+            <a:schemeClr val="tx1"/>
+          </a:fontRef>
+        </p:style>
+      </p:cxnSp>
+      <p:cxnSp>
+        <p:nvCxnSpPr>
+          <p:cNvPr id="23" name="Straight Arrow Connector 22">
+            <a:extLst>
+              <a:ext uri="{FF2B5EF4-FFF2-40B4-BE49-F238E27FC236}">
+                <a16:creationId xmlns:a16="http://schemas.microsoft.com/office/drawing/2014/main" id="{3E603D39-53BF-ABE5-A0AF-018D5B95A721}"/>
+              </a:ext>
+            </a:extLst>
+          </p:cNvPr>
+          <p:cNvCxnSpPr>
+            <a:cxnSpLocks/>
+          </p:cNvCxnSpPr>
+          <p:nvPr/>
+        </p:nvCxnSpPr>
+        <p:spPr>
+          <a:xfrm flipH="1">
+            <a:off x="6931505" y="1883212"/>
+            <a:ext cx="1" cy="189773"/>
+          </a:xfrm>
+          <a:prstGeom prst="straightConnector1">
+            <a:avLst/>
+          </a:prstGeom>
+          <a:ln>
+            <a:tailEnd type="triangle"/>
+          </a:ln>
+        </p:spPr>
+        <p:style>
+          <a:lnRef idx="2">
+            <a:schemeClr val="accent1"/>
+          </a:lnRef>
+          <a:fillRef idx="0">
+            <a:schemeClr val="accent1"/>
+          </a:fillRef>
+          <a:effectRef idx="1">
+            <a:schemeClr val="accent1"/>
+          </a:effectRef>
+          <a:fontRef idx="minor">
+            <a:schemeClr val="tx1"/>
+          </a:fontRef>
+        </p:style>
+      </p:cxnSp>
+      <p:sp>
+        <p:nvSpPr>
+          <p:cNvPr id="26" name="TextBox 25">
+            <a:extLst>
+              <a:ext uri="{FF2B5EF4-FFF2-40B4-BE49-F238E27FC236}">
+                <a16:creationId xmlns:a16="http://schemas.microsoft.com/office/drawing/2014/main" id="{C1639EB3-4B2E-B7BF-7EFE-282F305A3DF6}"/>
+              </a:ext>
+            </a:extLst>
+          </p:cNvPr>
+          <p:cNvSpPr txBox="1"/>
+          <p:nvPr/>
+        </p:nvSpPr>
+        <p:spPr>
+          <a:xfrm>
+            <a:off x="5183566" y="1348140"/>
+            <a:ext cx="1331611" cy="461665"/>
+          </a:xfrm>
+          <a:prstGeom prst="rect">
+            <a:avLst/>
+          </a:prstGeom>
+          <a:noFill/>
+        </p:spPr>
+        <p:txBody>
+          <a:bodyPr wrap="square" rtlCol="0">
+            <a:spAutoFit/>
+          </a:bodyPr>
+          <a:lstStyle/>
+          <a:p>
+            <a:r>
+              <a:rPr lang="en-US" sz="1200" b="1" dirty="0"/>
+              <a:t>ZBRTT1 Thermal IoT Simulator</a:t>
+            </a:r>
+            <a:endParaRPr lang="en-SG" sz="1200" b="1" dirty="0"/>
+          </a:p>
+        </p:txBody>
+      </p:sp>
+      <p:cxnSp>
+        <p:nvCxnSpPr>
+          <p:cNvPr id="27" name="Straight Arrow Connector 26">
+            <a:extLst>
+              <a:ext uri="{FF2B5EF4-FFF2-40B4-BE49-F238E27FC236}">
+                <a16:creationId xmlns:a16="http://schemas.microsoft.com/office/drawing/2014/main" id="{E4063F6F-763F-56AC-0D63-D0F69071BC6C}"/>
+              </a:ext>
+            </a:extLst>
+          </p:cNvPr>
+          <p:cNvCxnSpPr>
+            <a:cxnSpLocks/>
+          </p:cNvCxnSpPr>
+          <p:nvPr/>
+        </p:nvCxnSpPr>
+        <p:spPr>
+          <a:xfrm flipH="1">
+            <a:off x="6551648" y="2363528"/>
+            <a:ext cx="1" cy="254713"/>
+          </a:xfrm>
+          <a:prstGeom prst="straightConnector1">
+            <a:avLst/>
+          </a:prstGeom>
+          <a:ln>
+            <a:tailEnd type="triangle"/>
+          </a:ln>
+        </p:spPr>
+        <p:style>
+          <a:lnRef idx="2">
+            <a:schemeClr val="accent1"/>
+          </a:lnRef>
+          <a:fillRef idx="0">
+            <a:schemeClr val="accent1"/>
+          </a:fillRef>
+          <a:effectRef idx="1">
+            <a:schemeClr val="accent1"/>
+          </a:effectRef>
+          <a:fontRef idx="minor">
+            <a:schemeClr val="tx1"/>
+          </a:fontRef>
+        </p:style>
+      </p:cxnSp>
+      <p:sp>
+        <p:nvSpPr>
+          <p:cNvPr id="28" name="Rectangle 27">
+            <a:extLst>
+              <a:ext uri="{FF2B5EF4-FFF2-40B4-BE49-F238E27FC236}">
+                <a16:creationId xmlns:a16="http://schemas.microsoft.com/office/drawing/2014/main" id="{852BD3F4-483F-5C5B-5857-7F1E20991F47}"/>
+              </a:ext>
+            </a:extLst>
+          </p:cNvPr>
+          <p:cNvSpPr/>
+          <p:nvPr/>
+        </p:nvSpPr>
+        <p:spPr>
+          <a:xfrm>
+            <a:off x="5436540" y="2618241"/>
+            <a:ext cx="1494965" cy="295727"/>
+          </a:xfrm>
+          <a:prstGeom prst="rect">
+            <a:avLst/>
+          </a:prstGeom>
+          <a:solidFill>
+            <a:schemeClr val="accent6">
+              <a:lumMod val="75000"/>
+            </a:schemeClr>
+          </a:solidFill>
+          <a:ln>
+            <a:solidFill>
+              <a:schemeClr val="tx1"/>
+            </a:solidFill>
+          </a:ln>
+        </p:spPr>
+        <p:style>
+          <a:lnRef idx="2">
+            <a:schemeClr val="accent1">
+              <a:shade val="50000"/>
+            </a:schemeClr>
+          </a:lnRef>
+          <a:fillRef idx="1">
+            <a:schemeClr val="accent1"/>
+          </a:fillRef>
+          <a:effectRef idx="0">
+            <a:schemeClr val="accent1"/>
+          </a:effectRef>
+          <a:fontRef idx="minor">
+            <a:schemeClr val="lt1"/>
+          </a:fontRef>
+        </p:style>
+        <p:txBody>
+          <a:bodyPr rtlCol="0" anchor="ctr"/>
+          <a:lstStyle/>
+          <a:p>
+            <a:pPr algn="ctr"/>
+            <a:r>
+              <a:rPr lang="en-US" sz="1050" b="1" dirty="0"/>
+              <a:t>MQTT Data Structure</a:t>
+            </a:r>
+            <a:endParaRPr lang="en-SG" sz="1050" b="1" dirty="0"/>
+          </a:p>
+        </p:txBody>
+      </p:sp>
+      <p:sp>
+        <p:nvSpPr>
+          <p:cNvPr id="30" name="Rectangle 29">
+            <a:extLst>
+              <a:ext uri="{FF2B5EF4-FFF2-40B4-BE49-F238E27FC236}">
+                <a16:creationId xmlns:a16="http://schemas.microsoft.com/office/drawing/2014/main" id="{53C8DC80-D89F-ED40-D1D3-AE9F0601FC0D}"/>
+              </a:ext>
+            </a:extLst>
+          </p:cNvPr>
+          <p:cNvSpPr/>
+          <p:nvPr/>
+        </p:nvSpPr>
+        <p:spPr>
+          <a:xfrm>
+            <a:off x="7165624" y="2595623"/>
+            <a:ext cx="924720" cy="340962"/>
+          </a:xfrm>
+          <a:prstGeom prst="rect">
+            <a:avLst/>
+          </a:prstGeom>
+          <a:solidFill>
+            <a:schemeClr val="accent2"/>
+          </a:solidFill>
+        </p:spPr>
+        <p:style>
+          <a:lnRef idx="2">
+            <a:schemeClr val="accent1">
+              <a:shade val="50000"/>
+            </a:schemeClr>
+          </a:lnRef>
+          <a:fillRef idx="1">
+            <a:schemeClr val="accent1"/>
+          </a:fillRef>
+          <a:effectRef idx="0">
+            <a:schemeClr val="accent1"/>
+          </a:effectRef>
+          <a:fontRef idx="minor">
+            <a:schemeClr val="lt1"/>
+          </a:fontRef>
+        </p:style>
+        <p:txBody>
+          <a:bodyPr rtlCol="0" anchor="ctr"/>
+          <a:lstStyle/>
+          <a:p>
+            <a:r>
+              <a:rPr lang="en-US" sz="1050" b="1" dirty="0"/>
+              <a:t>MQTT Client</a:t>
+            </a:r>
+            <a:endParaRPr lang="en-SG" sz="1050" b="1" dirty="0"/>
+          </a:p>
+        </p:txBody>
+      </p:sp>
+      <p:cxnSp>
+        <p:nvCxnSpPr>
+          <p:cNvPr id="31" name="Straight Arrow Connector 30">
+            <a:extLst>
+              <a:ext uri="{FF2B5EF4-FFF2-40B4-BE49-F238E27FC236}">
+                <a16:creationId xmlns:a16="http://schemas.microsoft.com/office/drawing/2014/main" id="{F916C455-858A-23DE-2147-54C37C303D85}"/>
+              </a:ext>
+            </a:extLst>
+          </p:cNvPr>
+          <p:cNvCxnSpPr>
+            <a:cxnSpLocks/>
+            <a:stCxn id="28" idx="3"/>
+          </p:cNvCxnSpPr>
+          <p:nvPr/>
+        </p:nvCxnSpPr>
+        <p:spPr>
+          <a:xfrm flipV="1">
+            <a:off x="6931505" y="2738944"/>
+            <a:ext cx="224462" cy="0"/>
+          </a:xfrm>
+          <a:prstGeom prst="straightConnector1">
+            <a:avLst/>
+          </a:prstGeom>
+          <a:ln>
+            <a:tailEnd type="triangle"/>
+          </a:ln>
+        </p:spPr>
+        <p:style>
+          <a:lnRef idx="2">
+            <a:schemeClr val="accent1"/>
+          </a:lnRef>
+          <a:fillRef idx="0">
+            <a:schemeClr val="accent1"/>
+          </a:fillRef>
+          <a:effectRef idx="1">
+            <a:schemeClr val="accent1"/>
+          </a:effectRef>
+          <a:fontRef idx="minor">
+            <a:schemeClr val="tx1"/>
+          </a:fontRef>
+        </p:style>
+      </p:cxnSp>
+      <p:sp>
+        <p:nvSpPr>
+          <p:cNvPr id="34" name="Cloud 33">
+            <a:extLst>
+              <a:ext uri="{FF2B5EF4-FFF2-40B4-BE49-F238E27FC236}">
+                <a16:creationId xmlns:a16="http://schemas.microsoft.com/office/drawing/2014/main" id="{948B4C76-74E9-D7F0-6164-5E385EA91F09}"/>
+              </a:ext>
+            </a:extLst>
+          </p:cNvPr>
+          <p:cNvSpPr/>
+          <p:nvPr/>
+        </p:nvSpPr>
+        <p:spPr>
+          <a:xfrm>
+            <a:off x="8324463" y="2372712"/>
+            <a:ext cx="1185569" cy="732464"/>
+          </a:xfrm>
+          <a:prstGeom prst="cloud">
+            <a:avLst/>
+          </a:prstGeom>
+        </p:spPr>
+        <p:style>
+          <a:lnRef idx="2">
+            <a:schemeClr val="accent1">
+              <a:shade val="15000"/>
+            </a:schemeClr>
+          </a:lnRef>
+          <a:fillRef idx="1">
+            <a:schemeClr val="accent1"/>
+          </a:fillRef>
+          <a:effectRef idx="0">
+            <a:schemeClr val="accent1"/>
+          </a:effectRef>
+          <a:fontRef idx="minor">
+            <a:schemeClr val="lt1"/>
+          </a:fontRef>
+        </p:style>
+        <p:txBody>
+          <a:bodyPr rtlCol="0" anchor="ctr"/>
+          <a:lstStyle/>
+          <a:p>
+            <a:pPr algn="ctr"/>
+            <a:r>
+              <a:rPr lang="en-US" sz="1100" b="1" dirty="0"/>
+              <a:t>WIFI Network</a:t>
+            </a:r>
+            <a:endParaRPr lang="en-SG" sz="1100" b="1" dirty="0"/>
+          </a:p>
+        </p:txBody>
+      </p:sp>
+      <p:cxnSp>
+        <p:nvCxnSpPr>
+          <p:cNvPr id="35" name="Straight Arrow Connector 34">
+            <a:extLst>
+              <a:ext uri="{FF2B5EF4-FFF2-40B4-BE49-F238E27FC236}">
+                <a16:creationId xmlns:a16="http://schemas.microsoft.com/office/drawing/2014/main" id="{E3EC6B15-3A68-43D7-96E6-A56FCC517ECD}"/>
+              </a:ext>
+            </a:extLst>
+          </p:cNvPr>
+          <p:cNvCxnSpPr>
+            <a:cxnSpLocks/>
+          </p:cNvCxnSpPr>
+          <p:nvPr/>
+        </p:nvCxnSpPr>
+        <p:spPr>
+          <a:xfrm>
+            <a:off x="8100001" y="2766104"/>
+            <a:ext cx="1757430" cy="0"/>
+          </a:xfrm>
+          <a:prstGeom prst="straightConnector1">
+            <a:avLst/>
+          </a:prstGeom>
+          <a:ln>
+            <a:tailEnd type="triangle"/>
+          </a:ln>
+        </p:spPr>
+        <p:style>
+          <a:lnRef idx="2">
+            <a:schemeClr val="accent1"/>
+          </a:lnRef>
+          <a:fillRef idx="0">
+            <a:schemeClr val="accent1"/>
+          </a:fillRef>
+          <a:effectRef idx="1">
+            <a:schemeClr val="accent1"/>
+          </a:effectRef>
+          <a:fontRef idx="minor">
+            <a:schemeClr val="tx1"/>
+          </a:fontRef>
+        </p:style>
+      </p:cxnSp>
+      <p:sp>
+        <p:nvSpPr>
+          <p:cNvPr id="38" name="Rectangle 37">
+            <a:extLst>
+              <a:ext uri="{FF2B5EF4-FFF2-40B4-BE49-F238E27FC236}">
+                <a16:creationId xmlns:a16="http://schemas.microsoft.com/office/drawing/2014/main" id="{D0EA3AAE-4AC8-5951-9B83-825396CFCEF2}"/>
+              </a:ext>
+            </a:extLst>
+          </p:cNvPr>
+          <p:cNvSpPr/>
+          <p:nvPr/>
+        </p:nvSpPr>
+        <p:spPr>
+          <a:xfrm>
+            <a:off x="9867088" y="2568463"/>
+            <a:ext cx="1062441" cy="340962"/>
+          </a:xfrm>
+          <a:prstGeom prst="rect">
+            <a:avLst/>
+          </a:prstGeom>
+          <a:solidFill>
+            <a:schemeClr val="accent2"/>
+          </a:solidFill>
+        </p:spPr>
+        <p:style>
+          <a:lnRef idx="2">
+            <a:schemeClr val="accent1">
+              <a:shade val="50000"/>
+            </a:schemeClr>
+          </a:lnRef>
+          <a:fillRef idx="1">
+            <a:schemeClr val="accent1"/>
+          </a:fillRef>
+          <a:effectRef idx="0">
+            <a:schemeClr val="accent1"/>
+          </a:effectRef>
+          <a:fontRef idx="minor">
+            <a:schemeClr val="lt1"/>
+          </a:fontRef>
+        </p:style>
+        <p:txBody>
+          <a:bodyPr rtlCol="0" anchor="ctr"/>
+          <a:lstStyle/>
+          <a:p>
+            <a:r>
+              <a:rPr lang="en-US" sz="1050" b="1" dirty="0"/>
+              <a:t>MQTT Broker</a:t>
+            </a:r>
+            <a:endParaRPr lang="en-SG" sz="1050" b="1" dirty="0"/>
+          </a:p>
+        </p:txBody>
+      </p:sp>
+      <p:sp>
+        <p:nvSpPr>
+          <p:cNvPr id="39" name="TextBox 38">
+            <a:extLst>
+              <a:ext uri="{FF2B5EF4-FFF2-40B4-BE49-F238E27FC236}">
+                <a16:creationId xmlns:a16="http://schemas.microsoft.com/office/drawing/2014/main" id="{6A1217F0-9407-2836-320E-D63E83849B44}"/>
+              </a:ext>
+            </a:extLst>
+          </p:cNvPr>
+          <p:cNvSpPr txBox="1"/>
+          <p:nvPr/>
+        </p:nvSpPr>
+        <p:spPr>
+          <a:xfrm>
+            <a:off x="9668473" y="1386376"/>
+            <a:ext cx="1331611" cy="461665"/>
+          </a:xfrm>
+          <a:prstGeom prst="rect">
+            <a:avLst/>
+          </a:prstGeom>
+          <a:noFill/>
+        </p:spPr>
+        <p:txBody>
+          <a:bodyPr wrap="square" rtlCol="0">
+            <a:spAutoFit/>
+          </a:bodyPr>
+          <a:lstStyle/>
+          <a:p>
+            <a:r>
+              <a:rPr lang="en-US" sz="1200" b="1" dirty="0"/>
+              <a:t>IoT Gateway Simulator </a:t>
+            </a:r>
+            <a:endParaRPr lang="en-SG" sz="1200" b="1" dirty="0"/>
+          </a:p>
+        </p:txBody>
+      </p:sp>
+      <p:sp>
+        <p:nvSpPr>
+          <p:cNvPr id="40" name="TextBox 39">
+            <a:extLst>
+              <a:ext uri="{FF2B5EF4-FFF2-40B4-BE49-F238E27FC236}">
+                <a16:creationId xmlns:a16="http://schemas.microsoft.com/office/drawing/2014/main" id="{856853A5-878B-4CD2-6D99-065FE022294A}"/>
+              </a:ext>
+            </a:extLst>
+          </p:cNvPr>
+          <p:cNvSpPr txBox="1"/>
+          <p:nvPr/>
+        </p:nvSpPr>
+        <p:spPr>
+          <a:xfrm>
+            <a:off x="8242461" y="1974275"/>
+            <a:ext cx="1301201" cy="461665"/>
+          </a:xfrm>
+          <a:prstGeom prst="rect">
+            <a:avLst/>
+          </a:prstGeom>
+          <a:noFill/>
+        </p:spPr>
+        <p:txBody>
+          <a:bodyPr wrap="square" rtlCol="0">
+            <a:spAutoFit/>
+          </a:bodyPr>
+          <a:lstStyle/>
+          <a:p>
+            <a:r>
+              <a:rPr lang="en-US" sz="1200" b="1" dirty="0"/>
+              <a:t>MQTT Data Publish </a:t>
+            </a:r>
+            <a:endParaRPr lang="en-SG" sz="1200" b="1" dirty="0"/>
+          </a:p>
+        </p:txBody>
+      </p:sp>
+    </p:spTree>
+    <p:extLst>
+      <p:ext uri="{BB962C8B-B14F-4D97-AF65-F5344CB8AC3E}">
+        <p14:creationId xmlns:p14="http://schemas.microsoft.com/office/powerpoint/2010/main" val="3788668900"/>
+      </p:ext>
+    </p:extLst>
+  </p:cSld>
+  <p:clrMapOvr>
+    <a:masterClrMapping/>
+  </p:clrMapOvr>
+</p:sld>
+</file>
+
+<file path=ppt/slides/slide4.xml><?xml version="1.0" encoding="utf-8"?>
+<p:sld xmlns:a="http://schemas.openxmlformats.org/drawingml/2006/main" xmlns:r="http://schemas.openxmlformats.org/officeDocument/2006/relationships" xmlns:p="http://schemas.openxmlformats.org/presentationml/2006/main">
+  <p:cSld>
+    <p:spTree>
+      <p:nvGrpSpPr>
+        <p:cNvPr id="1" name=""/>
+        <p:cNvGrpSpPr/>
+        <p:nvPr/>
+      </p:nvGrpSpPr>
+      <p:grpSpPr>
+        <a:xfrm>
+          <a:off x="0" y="0"/>
+          <a:ext cx="0" cy="0"/>
+          <a:chOff x="0" y="0"/>
+          <a:chExt cx="0" cy="0"/>
+        </a:xfrm>
+      </p:grpSpPr>
+      <p:sp>
+        <p:nvSpPr>
+          <p:cNvPr id="78" name="Rectangle 77">
+            <a:extLst>
+              <a:ext uri="{FF2B5EF4-FFF2-40B4-BE49-F238E27FC236}">
+                <a16:creationId xmlns:a16="http://schemas.microsoft.com/office/drawing/2014/main" id="{A153CD48-D451-ADB0-EF08-EB3856D4FCCA}"/>
+              </a:ext>
+            </a:extLst>
+          </p:cNvPr>
+          <p:cNvSpPr/>
+          <p:nvPr/>
+        </p:nvSpPr>
+        <p:spPr>
+          <a:xfrm>
+            <a:off x="6139726" y="2228135"/>
+            <a:ext cx="2111994" cy="842526"/>
+          </a:xfrm>
+          <a:prstGeom prst="rect">
+            <a:avLst/>
+          </a:prstGeom>
+          <a:solidFill>
+            <a:schemeClr val="accent6">
+              <a:lumMod val="20000"/>
+              <a:lumOff val="80000"/>
+            </a:schemeClr>
+          </a:solidFill>
+        </p:spPr>
+        <p:style>
+          <a:lnRef idx="2">
+            <a:schemeClr val="accent1">
+              <a:shade val="15000"/>
+            </a:schemeClr>
+          </a:lnRef>
+          <a:fillRef idx="1">
+            <a:schemeClr val="accent1"/>
+          </a:fillRef>
+          <a:effectRef idx="0">
+            <a:schemeClr val="accent1"/>
+          </a:effectRef>
+          <a:fontRef idx="minor">
+            <a:schemeClr val="lt1"/>
+          </a:fontRef>
+        </p:style>
+        <p:txBody>
+          <a:bodyPr rtlCol="0" anchor="ctr"/>
+          <a:lstStyle/>
+          <a:p>
+            <a:pPr algn="ctr"/>
+            <a:endParaRPr lang="en-SG" dirty="0"/>
+          </a:p>
+        </p:txBody>
+      </p:sp>
+      <p:sp>
+        <p:nvSpPr>
+          <p:cNvPr id="66" name="Rectangle 65">
+            <a:extLst>
+              <a:ext uri="{FF2B5EF4-FFF2-40B4-BE49-F238E27FC236}">
+                <a16:creationId xmlns:a16="http://schemas.microsoft.com/office/drawing/2014/main" id="{837A8677-8040-C491-6D80-73149652E6CE}"/>
+              </a:ext>
+            </a:extLst>
+          </p:cNvPr>
+          <p:cNvSpPr/>
+          <p:nvPr/>
+        </p:nvSpPr>
+        <p:spPr>
+          <a:xfrm>
+            <a:off x="6153184" y="3343298"/>
+            <a:ext cx="2489871" cy="2995813"/>
+          </a:xfrm>
+          <a:prstGeom prst="rect">
+            <a:avLst/>
+          </a:prstGeom>
+          <a:solidFill>
+            <a:schemeClr val="accent6">
+              <a:lumMod val="20000"/>
+              <a:lumOff val="80000"/>
+            </a:schemeClr>
+          </a:solidFill>
+        </p:spPr>
+        <p:style>
+          <a:lnRef idx="2">
+            <a:schemeClr val="accent1">
+              <a:shade val="15000"/>
+            </a:schemeClr>
+          </a:lnRef>
+          <a:fillRef idx="1">
+            <a:schemeClr val="accent1"/>
+          </a:fillRef>
+          <a:effectRef idx="0">
+            <a:schemeClr val="accent1"/>
+          </a:effectRef>
+          <a:fontRef idx="minor">
+            <a:schemeClr val="lt1"/>
+          </a:fontRef>
+        </p:style>
+        <p:txBody>
+          <a:bodyPr rtlCol="0" anchor="ctr"/>
+          <a:lstStyle/>
+          <a:p>
+            <a:pPr algn="ctr"/>
+            <a:endParaRPr lang="en-SG" dirty="0"/>
+          </a:p>
+        </p:txBody>
+      </p:sp>
+      <p:sp>
+        <p:nvSpPr>
+          <p:cNvPr id="4" name="Rectangle 3">
+            <a:extLst>
+              <a:ext uri="{FF2B5EF4-FFF2-40B4-BE49-F238E27FC236}">
+                <a16:creationId xmlns:a16="http://schemas.microsoft.com/office/drawing/2014/main" id="{ED7DD3D4-6B5E-7CB5-E003-2C037546352E}"/>
+              </a:ext>
+            </a:extLst>
+          </p:cNvPr>
+          <p:cNvSpPr/>
+          <p:nvPr/>
+        </p:nvSpPr>
+        <p:spPr>
+          <a:xfrm>
+            <a:off x="548582" y="1775115"/>
+            <a:ext cx="3628752" cy="4609338"/>
+          </a:xfrm>
+          <a:prstGeom prst="rect">
+            <a:avLst/>
+          </a:prstGeom>
+          <a:solidFill>
+            <a:schemeClr val="accent1">
+              <a:lumMod val="20000"/>
+              <a:lumOff val="80000"/>
+            </a:schemeClr>
+          </a:solidFill>
+        </p:spPr>
+        <p:style>
+          <a:lnRef idx="2">
+            <a:schemeClr val="accent1">
+              <a:shade val="15000"/>
+            </a:schemeClr>
+          </a:lnRef>
+          <a:fillRef idx="1">
+            <a:schemeClr val="accent1"/>
+          </a:fillRef>
+          <a:effectRef idx="0">
+            <a:schemeClr val="accent1"/>
+          </a:effectRef>
+          <a:fontRef idx="minor">
+            <a:schemeClr val="lt1"/>
+          </a:fontRef>
+        </p:style>
+        <p:txBody>
+          <a:bodyPr rtlCol="0" anchor="ctr"/>
+          <a:lstStyle/>
+          <a:p>
+            <a:pPr algn="ctr"/>
+            <a:endParaRPr lang="en-SG" dirty="0"/>
+          </a:p>
+        </p:txBody>
+      </p:sp>
+      <p:sp>
+        <p:nvSpPr>
+          <p:cNvPr id="67" name="TextBox 66">
+            <a:extLst>
+              <a:ext uri="{FF2B5EF4-FFF2-40B4-BE49-F238E27FC236}">
+                <a16:creationId xmlns:a16="http://schemas.microsoft.com/office/drawing/2014/main" id="{E83D0994-FFC7-B371-BE19-4F804F4F3BC3}"/>
+              </a:ext>
+            </a:extLst>
+          </p:cNvPr>
+          <p:cNvSpPr txBox="1"/>
+          <p:nvPr/>
+        </p:nvSpPr>
+        <p:spPr>
+          <a:xfrm>
+            <a:off x="6139725" y="3435491"/>
+            <a:ext cx="2732878" cy="523220"/>
+          </a:xfrm>
+          <a:prstGeom prst="rect">
+            <a:avLst/>
+          </a:prstGeom>
+          <a:noFill/>
+        </p:spPr>
+        <p:txBody>
+          <a:bodyPr wrap="square" rtlCol="0">
+            <a:spAutoFit/>
+          </a:bodyPr>
+          <a:lstStyle/>
+          <a:p>
+            <a:r>
+              <a:rPr lang="en-US" sz="1400" b="1" dirty="0">
+                <a:solidFill>
+                  <a:schemeClr val="accent6">
+                    <a:lumMod val="50000"/>
+                  </a:schemeClr>
+                </a:solidFill>
+              </a:rPr>
+              <a:t>Air Vacuum System Control RTU Simulation Framework</a:t>
+            </a:r>
+            <a:endParaRPr lang="en-SG" sz="1400" b="1" dirty="0">
+              <a:solidFill>
+                <a:schemeClr val="accent6">
+                  <a:lumMod val="50000"/>
+                </a:schemeClr>
+              </a:solidFill>
+            </a:endParaRPr>
+          </a:p>
+        </p:txBody>
+      </p:sp>
+      <p:sp>
+        <p:nvSpPr>
+          <p:cNvPr id="68" name="TextBox 67">
+            <a:extLst>
+              <a:ext uri="{FF2B5EF4-FFF2-40B4-BE49-F238E27FC236}">
+                <a16:creationId xmlns:a16="http://schemas.microsoft.com/office/drawing/2014/main" id="{785B9271-91E4-96A0-FFD7-67E7E3B97AB1}"/>
+              </a:ext>
+            </a:extLst>
+          </p:cNvPr>
+          <p:cNvSpPr txBox="1"/>
+          <p:nvPr/>
+        </p:nvSpPr>
+        <p:spPr>
+          <a:xfrm>
+            <a:off x="4355376" y="1878787"/>
+            <a:ext cx="2884604" cy="307777"/>
+          </a:xfrm>
+          <a:prstGeom prst="rect">
+            <a:avLst/>
+          </a:prstGeom>
+          <a:noFill/>
+        </p:spPr>
+        <p:txBody>
+          <a:bodyPr wrap="square" rtlCol="0">
+            <a:spAutoFit/>
+          </a:bodyPr>
+          <a:lstStyle/>
+          <a:p>
+            <a:r>
+              <a:rPr lang="en-US" sz="1400" b="1" dirty="0"/>
+              <a:t>Level1 OT Controller Devices </a:t>
+            </a:r>
+            <a:endParaRPr lang="en-SG" sz="1400" b="1" dirty="0"/>
+          </a:p>
+        </p:txBody>
+      </p:sp>
+      <p:sp>
+        <p:nvSpPr>
+          <p:cNvPr id="80" name="Rectangle 79">
+            <a:extLst>
+              <a:ext uri="{FF2B5EF4-FFF2-40B4-BE49-F238E27FC236}">
+                <a16:creationId xmlns:a16="http://schemas.microsoft.com/office/drawing/2014/main" id="{410193F1-FCF7-0996-4AFD-5FEB7922A1DC}"/>
+              </a:ext>
+            </a:extLst>
+          </p:cNvPr>
+          <p:cNvSpPr/>
+          <p:nvPr/>
+        </p:nvSpPr>
+        <p:spPr>
+          <a:xfrm>
+            <a:off x="6828449" y="4216075"/>
+            <a:ext cx="1494965" cy="295727"/>
+          </a:xfrm>
+          <a:prstGeom prst="rect">
+            <a:avLst/>
+          </a:prstGeom>
+          <a:solidFill>
+            <a:schemeClr val="accent6">
+              <a:lumMod val="75000"/>
+            </a:schemeClr>
+          </a:solidFill>
+          <a:ln>
+            <a:solidFill>
+              <a:schemeClr val="tx1"/>
+            </a:solidFill>
+          </a:ln>
+        </p:spPr>
+        <p:style>
+          <a:lnRef idx="2">
+            <a:schemeClr val="accent1">
+              <a:shade val="50000"/>
+            </a:schemeClr>
+          </a:lnRef>
+          <a:fillRef idx="1">
+            <a:schemeClr val="accent1"/>
+          </a:fillRef>
+          <a:effectRef idx="0">
+            <a:schemeClr val="accent1"/>
+          </a:effectRef>
+          <a:fontRef idx="minor">
+            <a:schemeClr val="lt1"/>
+          </a:fontRef>
+        </p:style>
+        <p:txBody>
+          <a:bodyPr rtlCol="0" anchor="ctr"/>
+          <a:lstStyle/>
+          <a:p>
+            <a:pPr algn="ctr"/>
+            <a:r>
+              <a:rPr lang="en-US" sz="1050" b="1" dirty="0"/>
+              <a:t>Input Parameter </a:t>
+            </a:r>
+            <a:r>
+              <a:rPr lang="en-US" sz="1050" b="1" dirty="0" err="1"/>
+              <a:t>Dict</a:t>
+            </a:r>
+            <a:endParaRPr lang="en-SG" sz="1050" b="1" dirty="0"/>
+          </a:p>
+        </p:txBody>
+      </p:sp>
+      <p:pic>
+        <p:nvPicPr>
+          <p:cNvPr id="82" name="Picture 81">
+            <a:extLst>
+              <a:ext uri="{FF2B5EF4-FFF2-40B4-BE49-F238E27FC236}">
+                <a16:creationId xmlns:a16="http://schemas.microsoft.com/office/drawing/2014/main" id="{0C4944A4-AC6E-C358-AD9C-F8CDE9B6C9A5}"/>
+              </a:ext>
+            </a:extLst>
+          </p:cNvPr>
+          <p:cNvPicPr>
+            <a:picLocks noChangeAspect="1"/>
+          </p:cNvPicPr>
+          <p:nvPr/>
+        </p:nvPicPr>
+        <p:blipFill>
+          <a:blip r:embed="rId3"/>
+          <a:stretch>
+            <a:fillRect/>
+          </a:stretch>
+        </p:blipFill>
+        <p:spPr>
+          <a:xfrm>
+            <a:off x="7024487" y="4797562"/>
+            <a:ext cx="762864" cy="663898"/>
+          </a:xfrm>
+          <a:prstGeom prst="rect">
+            <a:avLst/>
+          </a:prstGeom>
+          <a:ln w="19050">
+            <a:solidFill>
+              <a:schemeClr val="tx1"/>
+            </a:solidFill>
+          </a:ln>
+        </p:spPr>
+      </p:pic>
+      <p:cxnSp>
+        <p:nvCxnSpPr>
+          <p:cNvPr id="84" name="Straight Arrow Connector 83">
+            <a:extLst>
+              <a:ext uri="{FF2B5EF4-FFF2-40B4-BE49-F238E27FC236}">
+                <a16:creationId xmlns:a16="http://schemas.microsoft.com/office/drawing/2014/main" id="{4D271E74-DEAC-DBC5-E155-98AC307DE59C}"/>
+              </a:ext>
+            </a:extLst>
+          </p:cNvPr>
+          <p:cNvCxnSpPr>
+            <a:cxnSpLocks/>
+          </p:cNvCxnSpPr>
+          <p:nvPr/>
+        </p:nvCxnSpPr>
+        <p:spPr>
+          <a:xfrm>
+            <a:off x="7405919" y="4503587"/>
+            <a:ext cx="0" cy="245081"/>
+          </a:xfrm>
+          <a:prstGeom prst="straightConnector1">
+            <a:avLst/>
+          </a:prstGeom>
+          <a:ln>
+            <a:prstDash val="sysDash"/>
+            <a:tailEnd type="triangle"/>
+          </a:ln>
+        </p:spPr>
+        <p:style>
+          <a:lnRef idx="2">
+            <a:schemeClr val="dk1"/>
+          </a:lnRef>
+          <a:fillRef idx="0">
+            <a:schemeClr val="dk1"/>
+          </a:fillRef>
+          <a:effectRef idx="1">
+            <a:schemeClr val="dk1"/>
+          </a:effectRef>
+          <a:fontRef idx="minor">
+            <a:schemeClr val="tx1"/>
+          </a:fontRef>
+        </p:style>
+      </p:cxnSp>
+      <p:sp>
+        <p:nvSpPr>
+          <p:cNvPr id="125" name="TextBox 124">
+            <a:extLst>
+              <a:ext uri="{FF2B5EF4-FFF2-40B4-BE49-F238E27FC236}">
+                <a16:creationId xmlns:a16="http://schemas.microsoft.com/office/drawing/2014/main" id="{587F13EF-BB40-8784-CA1E-3F7F9B4EDF0E}"/>
+              </a:ext>
+            </a:extLst>
+          </p:cNvPr>
+          <p:cNvSpPr txBox="1"/>
+          <p:nvPr/>
+        </p:nvSpPr>
+        <p:spPr>
+          <a:xfrm>
+            <a:off x="508106" y="1382385"/>
+            <a:ext cx="3211175" cy="307777"/>
+          </a:xfrm>
+          <a:prstGeom prst="rect">
+            <a:avLst/>
+          </a:prstGeom>
+          <a:noFill/>
+        </p:spPr>
+        <p:txBody>
+          <a:bodyPr wrap="square" rtlCol="0">
+            <a:spAutoFit/>
+          </a:bodyPr>
+          <a:lstStyle/>
+          <a:p>
+            <a:r>
+              <a:rPr lang="en-US" sz="1400" b="1" dirty="0"/>
+              <a:t>Level0 OT Physical Field I/O Devices </a:t>
+            </a:r>
+            <a:endParaRPr lang="en-SG" sz="1400" b="1" dirty="0"/>
+          </a:p>
+        </p:txBody>
+      </p:sp>
+      <p:sp>
+        <p:nvSpPr>
+          <p:cNvPr id="148" name="TextBox 147">
+            <a:extLst>
+              <a:ext uri="{FF2B5EF4-FFF2-40B4-BE49-F238E27FC236}">
+                <a16:creationId xmlns:a16="http://schemas.microsoft.com/office/drawing/2014/main" id="{C0089D7C-7E8D-AD1C-D162-A3C3BE67C8FF}"/>
+              </a:ext>
+            </a:extLst>
+          </p:cNvPr>
+          <p:cNvSpPr txBox="1"/>
+          <p:nvPr/>
+        </p:nvSpPr>
+        <p:spPr>
+          <a:xfrm>
+            <a:off x="6343070" y="4776248"/>
+            <a:ext cx="875441" cy="646331"/>
+          </a:xfrm>
+          <a:prstGeom prst="rect">
+            <a:avLst/>
+          </a:prstGeom>
+          <a:noFill/>
+        </p:spPr>
+        <p:txBody>
+          <a:bodyPr wrap="square" rtlCol="0">
+            <a:spAutoFit/>
+          </a:bodyPr>
+          <a:lstStyle/>
+          <a:p>
+            <a:r>
+              <a:rPr lang="en-US" sz="1200" b="1" dirty="0"/>
+              <a:t>Auto</a:t>
+            </a:r>
+          </a:p>
+          <a:p>
+            <a:r>
+              <a:rPr lang="en-US" sz="1200" b="1" dirty="0"/>
+              <a:t>Control </a:t>
+            </a:r>
+          </a:p>
+          <a:p>
+            <a:r>
+              <a:rPr lang="en-US" sz="1200" b="1" dirty="0"/>
+              <a:t>Logic</a:t>
+            </a:r>
+            <a:endParaRPr lang="en-SG" sz="1200" b="1" dirty="0"/>
+          </a:p>
+        </p:txBody>
+      </p:sp>
+      <p:sp>
+        <p:nvSpPr>
+          <p:cNvPr id="83" name="Rectangle 82">
+            <a:extLst>
+              <a:ext uri="{FF2B5EF4-FFF2-40B4-BE49-F238E27FC236}">
+                <a16:creationId xmlns:a16="http://schemas.microsoft.com/office/drawing/2014/main" id="{A2733834-1F35-5EC2-2694-CCCF1592DCF7}"/>
+              </a:ext>
+            </a:extLst>
+          </p:cNvPr>
+          <p:cNvSpPr/>
+          <p:nvPr/>
+        </p:nvSpPr>
+        <p:spPr>
+          <a:xfrm>
+            <a:off x="6856943" y="5779919"/>
+            <a:ext cx="1573581" cy="295727"/>
+          </a:xfrm>
+          <a:prstGeom prst="rect">
+            <a:avLst/>
+          </a:prstGeom>
+          <a:solidFill>
+            <a:schemeClr val="accent6">
+              <a:lumMod val="75000"/>
+            </a:schemeClr>
+          </a:solidFill>
+          <a:ln>
+            <a:solidFill>
+              <a:schemeClr val="tx1"/>
+            </a:solidFill>
+          </a:ln>
+        </p:spPr>
+        <p:style>
+          <a:lnRef idx="2">
+            <a:schemeClr val="accent1">
+              <a:shade val="50000"/>
+            </a:schemeClr>
+          </a:lnRef>
+          <a:fillRef idx="1">
+            <a:schemeClr val="accent1"/>
+          </a:fillRef>
+          <a:effectRef idx="0">
+            <a:schemeClr val="accent1"/>
+          </a:effectRef>
+          <a:fontRef idx="minor">
+            <a:schemeClr val="lt1"/>
+          </a:fontRef>
+        </p:style>
+        <p:txBody>
+          <a:bodyPr rtlCol="0" anchor="ctr"/>
+          <a:lstStyle/>
+          <a:p>
+            <a:pPr algn="ctr"/>
+            <a:r>
+              <a:rPr lang="en-US" sz="1050" b="1" dirty="0"/>
+              <a:t>Output Parameter </a:t>
+            </a:r>
+            <a:r>
+              <a:rPr lang="en-US" sz="1050" b="1" dirty="0" err="1"/>
+              <a:t>Dict</a:t>
+            </a:r>
+            <a:endParaRPr lang="en-SG" sz="1050" b="1" dirty="0"/>
+          </a:p>
+        </p:txBody>
+      </p:sp>
+      <p:sp>
+        <p:nvSpPr>
+          <p:cNvPr id="35" name="Rectangle 34">
+            <a:extLst>
+              <a:ext uri="{FF2B5EF4-FFF2-40B4-BE49-F238E27FC236}">
+                <a16:creationId xmlns:a16="http://schemas.microsoft.com/office/drawing/2014/main" id="{6CE8F210-3F43-6E6B-8F0E-548004A1C5B5}"/>
+              </a:ext>
+            </a:extLst>
+          </p:cNvPr>
+          <p:cNvSpPr/>
+          <p:nvPr/>
+        </p:nvSpPr>
+        <p:spPr>
+          <a:xfrm>
+            <a:off x="3710639" y="5549649"/>
+            <a:ext cx="1183100" cy="559160"/>
+          </a:xfrm>
+          <a:prstGeom prst="rect">
+            <a:avLst/>
+          </a:prstGeom>
+          <a:solidFill>
+            <a:schemeClr val="accent2"/>
+          </a:solidFill>
+        </p:spPr>
+        <p:style>
+          <a:lnRef idx="2">
+            <a:schemeClr val="accent1">
+              <a:shade val="50000"/>
+            </a:schemeClr>
+          </a:lnRef>
+          <a:fillRef idx="1">
+            <a:schemeClr val="accent1"/>
+          </a:fillRef>
+          <a:effectRef idx="0">
+            <a:schemeClr val="accent1"/>
+          </a:effectRef>
+          <a:fontRef idx="minor">
+            <a:schemeClr val="lt1"/>
+          </a:fontRef>
+        </p:style>
+        <p:txBody>
+          <a:bodyPr rtlCol="0" anchor="ctr"/>
+          <a:lstStyle/>
+          <a:p>
+            <a:r>
+              <a:rPr lang="en-US" sz="1050" b="1" dirty="0"/>
+              <a:t>UDP Simulated  Electrical Signal RTU Output</a:t>
+            </a:r>
+            <a:endParaRPr lang="en-SG" sz="1050" b="1" dirty="0"/>
+          </a:p>
+        </p:txBody>
+      </p:sp>
+      <p:cxnSp>
+        <p:nvCxnSpPr>
+          <p:cNvPr id="65" name="Straight Arrow Connector 64">
+            <a:extLst>
+              <a:ext uri="{FF2B5EF4-FFF2-40B4-BE49-F238E27FC236}">
+                <a16:creationId xmlns:a16="http://schemas.microsoft.com/office/drawing/2014/main" id="{D81C8210-C0E7-B3E4-859C-1F4918518F21}"/>
+              </a:ext>
+            </a:extLst>
+          </p:cNvPr>
+          <p:cNvCxnSpPr>
+            <a:cxnSpLocks/>
+          </p:cNvCxnSpPr>
+          <p:nvPr/>
+        </p:nvCxnSpPr>
+        <p:spPr>
+          <a:xfrm>
+            <a:off x="7389522" y="5450614"/>
+            <a:ext cx="0" cy="329305"/>
+          </a:xfrm>
+          <a:prstGeom prst="straightConnector1">
+            <a:avLst/>
+          </a:prstGeom>
+          <a:ln>
+            <a:prstDash val="sysDash"/>
+            <a:tailEnd type="triangle"/>
+          </a:ln>
+        </p:spPr>
+        <p:style>
+          <a:lnRef idx="2">
+            <a:schemeClr val="dk1"/>
+          </a:lnRef>
+          <a:fillRef idx="0">
+            <a:schemeClr val="dk1"/>
+          </a:fillRef>
+          <a:effectRef idx="1">
+            <a:schemeClr val="dk1"/>
+          </a:effectRef>
+          <a:fontRef idx="minor">
+            <a:schemeClr val="tx1"/>
+          </a:fontRef>
+        </p:style>
+      </p:cxnSp>
+      <p:cxnSp>
+        <p:nvCxnSpPr>
+          <p:cNvPr id="72" name="Straight Arrow Connector 71">
+            <a:extLst>
+              <a:ext uri="{FF2B5EF4-FFF2-40B4-BE49-F238E27FC236}">
+                <a16:creationId xmlns:a16="http://schemas.microsoft.com/office/drawing/2014/main" id="{58B4CEA2-012D-1E0A-676D-15BF8BE1A4D0}"/>
+              </a:ext>
+            </a:extLst>
+          </p:cNvPr>
+          <p:cNvCxnSpPr>
+            <a:cxnSpLocks/>
+            <a:endCxn id="80" idx="1"/>
+          </p:cNvCxnSpPr>
+          <p:nvPr/>
+        </p:nvCxnSpPr>
+        <p:spPr>
+          <a:xfrm>
+            <a:off x="6524657" y="4352544"/>
+            <a:ext cx="303792" cy="0"/>
+          </a:xfrm>
+          <a:prstGeom prst="straightConnector1">
+            <a:avLst/>
+          </a:prstGeom>
+          <a:ln>
+            <a:prstDash val="sysDash"/>
+            <a:tailEnd type="triangle"/>
+          </a:ln>
+        </p:spPr>
+        <p:style>
+          <a:lnRef idx="2">
+            <a:schemeClr val="dk1"/>
+          </a:lnRef>
+          <a:fillRef idx="0">
+            <a:schemeClr val="dk1"/>
+          </a:fillRef>
+          <a:effectRef idx="1">
+            <a:schemeClr val="dk1"/>
+          </a:effectRef>
+          <a:fontRef idx="minor">
+            <a:schemeClr val="tx1"/>
+          </a:fontRef>
+        </p:style>
+      </p:cxnSp>
+      <p:cxnSp>
+        <p:nvCxnSpPr>
+          <p:cNvPr id="75" name="Straight Arrow Connector 74">
+            <a:extLst>
+              <a:ext uri="{FF2B5EF4-FFF2-40B4-BE49-F238E27FC236}">
+                <a16:creationId xmlns:a16="http://schemas.microsoft.com/office/drawing/2014/main" id="{6D4977DE-76D9-A860-79E2-C07C7F2576C6}"/>
+              </a:ext>
+            </a:extLst>
+          </p:cNvPr>
+          <p:cNvCxnSpPr>
+            <a:cxnSpLocks/>
+          </p:cNvCxnSpPr>
+          <p:nvPr/>
+        </p:nvCxnSpPr>
+        <p:spPr>
+          <a:xfrm flipH="1" flipV="1">
+            <a:off x="6482118" y="5906414"/>
+            <a:ext cx="353860" cy="0"/>
+          </a:xfrm>
+          <a:prstGeom prst="straightConnector1">
+            <a:avLst/>
+          </a:prstGeom>
+          <a:ln>
+            <a:prstDash val="sysDash"/>
+            <a:tailEnd type="triangle"/>
+          </a:ln>
+        </p:spPr>
+        <p:style>
+          <a:lnRef idx="2">
+            <a:schemeClr val="dk1"/>
+          </a:lnRef>
+          <a:fillRef idx="0">
+            <a:schemeClr val="dk1"/>
+          </a:fillRef>
+          <a:effectRef idx="1">
+            <a:schemeClr val="dk1"/>
+          </a:effectRef>
+          <a:fontRef idx="minor">
+            <a:schemeClr val="tx1"/>
+          </a:fontRef>
+        </p:style>
+      </p:cxnSp>
+      <p:sp>
+        <p:nvSpPr>
+          <p:cNvPr id="79" name="TextBox 78">
+            <a:extLst>
+              <a:ext uri="{FF2B5EF4-FFF2-40B4-BE49-F238E27FC236}">
+                <a16:creationId xmlns:a16="http://schemas.microsoft.com/office/drawing/2014/main" id="{AFAAA84E-DCD0-D7B7-9C0E-9E1FF741C098}"/>
+              </a:ext>
+            </a:extLst>
+          </p:cNvPr>
+          <p:cNvSpPr txBox="1"/>
+          <p:nvPr/>
+        </p:nvSpPr>
+        <p:spPr>
+          <a:xfrm>
+            <a:off x="6236637" y="2217205"/>
+            <a:ext cx="1741925" cy="307777"/>
+          </a:xfrm>
+          <a:prstGeom prst="rect">
+            <a:avLst/>
+          </a:prstGeom>
+          <a:noFill/>
+        </p:spPr>
+        <p:txBody>
+          <a:bodyPr wrap="square" rtlCol="0">
+            <a:spAutoFit/>
+          </a:bodyPr>
+          <a:lstStyle/>
+          <a:p>
+            <a:r>
+              <a:rPr lang="en-SG" sz="1400" b="1" dirty="0">
+                <a:solidFill>
+                  <a:schemeClr val="accent6">
+                    <a:lumMod val="50000"/>
+                  </a:schemeClr>
+                </a:solidFill>
+              </a:rPr>
+              <a:t>IoT 5G Antenna </a:t>
+            </a:r>
+          </a:p>
+        </p:txBody>
+      </p:sp>
+      <p:sp>
+        <p:nvSpPr>
+          <p:cNvPr id="81" name="Rectangle 80">
+            <a:extLst>
+              <a:ext uri="{FF2B5EF4-FFF2-40B4-BE49-F238E27FC236}">
+                <a16:creationId xmlns:a16="http://schemas.microsoft.com/office/drawing/2014/main" id="{AEA0A740-926A-31A2-62D0-5B65F5211AC2}"/>
+              </a:ext>
+            </a:extLst>
+          </p:cNvPr>
+          <p:cNvSpPr/>
+          <p:nvPr/>
+        </p:nvSpPr>
+        <p:spPr>
+          <a:xfrm>
+            <a:off x="8118696" y="4779235"/>
+            <a:ext cx="965256" cy="340962"/>
+          </a:xfrm>
+          <a:prstGeom prst="rect">
+            <a:avLst/>
+          </a:prstGeom>
+          <a:solidFill>
+            <a:schemeClr val="accent2"/>
+          </a:solidFill>
+        </p:spPr>
+        <p:style>
+          <a:lnRef idx="2">
+            <a:schemeClr val="accent1">
+              <a:shade val="50000"/>
+            </a:schemeClr>
+          </a:lnRef>
+          <a:fillRef idx="1">
+            <a:schemeClr val="accent1"/>
+          </a:fillRef>
+          <a:effectRef idx="0">
+            <a:schemeClr val="accent1"/>
+          </a:effectRef>
+          <a:fontRef idx="minor">
+            <a:schemeClr val="lt1"/>
+          </a:fontRef>
+        </p:style>
+        <p:txBody>
+          <a:bodyPr rtlCol="0" anchor="ctr"/>
+          <a:lstStyle/>
+          <a:p>
+            <a:r>
+              <a:rPr lang="en-SG" sz="1050" b="1" dirty="0"/>
+              <a:t>MQTT Client</a:t>
+            </a:r>
+          </a:p>
+        </p:txBody>
+      </p:sp>
+      <p:cxnSp>
+        <p:nvCxnSpPr>
+          <p:cNvPr id="87" name="Straight Connector 86">
+            <a:extLst>
+              <a:ext uri="{FF2B5EF4-FFF2-40B4-BE49-F238E27FC236}">
+                <a16:creationId xmlns:a16="http://schemas.microsoft.com/office/drawing/2014/main" id="{525058C5-A339-2CFC-1C58-5CE6271AD8F4}"/>
+              </a:ext>
+            </a:extLst>
+          </p:cNvPr>
+          <p:cNvCxnSpPr>
+            <a:cxnSpLocks/>
+          </p:cNvCxnSpPr>
+          <p:nvPr/>
+        </p:nvCxnSpPr>
+        <p:spPr>
+          <a:xfrm>
+            <a:off x="8175929" y="4517566"/>
+            <a:ext cx="0" cy="258682"/>
+          </a:xfrm>
+          <a:prstGeom prst="line">
+            <a:avLst/>
+          </a:prstGeom>
+        </p:spPr>
+        <p:style>
+          <a:lnRef idx="2">
+            <a:schemeClr val="dk1"/>
+          </a:lnRef>
+          <a:fillRef idx="0">
+            <a:schemeClr val="dk1"/>
+          </a:fillRef>
+          <a:effectRef idx="1">
+            <a:schemeClr val="dk1"/>
+          </a:effectRef>
+          <a:fontRef idx="minor">
+            <a:schemeClr val="tx1"/>
+          </a:fontRef>
+        </p:style>
+      </p:cxnSp>
+      <p:cxnSp>
+        <p:nvCxnSpPr>
+          <p:cNvPr id="89" name="Straight Connector 88">
+            <a:extLst>
+              <a:ext uri="{FF2B5EF4-FFF2-40B4-BE49-F238E27FC236}">
+                <a16:creationId xmlns:a16="http://schemas.microsoft.com/office/drawing/2014/main" id="{1F028600-722A-7E17-3136-F930C49E08B3}"/>
+              </a:ext>
+            </a:extLst>
+          </p:cNvPr>
+          <p:cNvCxnSpPr>
+            <a:cxnSpLocks/>
+          </p:cNvCxnSpPr>
+          <p:nvPr/>
+        </p:nvCxnSpPr>
+        <p:spPr>
+          <a:xfrm>
+            <a:off x="8242022" y="5549649"/>
+            <a:ext cx="0" cy="230270"/>
+          </a:xfrm>
+          <a:prstGeom prst="line">
+            <a:avLst/>
+          </a:prstGeom>
+        </p:spPr>
+        <p:style>
+          <a:lnRef idx="2">
+            <a:schemeClr val="dk1"/>
+          </a:lnRef>
+          <a:fillRef idx="0">
+            <a:schemeClr val="dk1"/>
+          </a:fillRef>
+          <a:effectRef idx="1">
+            <a:schemeClr val="dk1"/>
+          </a:effectRef>
+          <a:fontRef idx="minor">
+            <a:schemeClr val="tx1"/>
+          </a:fontRef>
+        </p:style>
+      </p:cxnSp>
+      <p:cxnSp>
+        <p:nvCxnSpPr>
+          <p:cNvPr id="98" name="Straight Arrow Connector 97">
+            <a:extLst>
+              <a:ext uri="{FF2B5EF4-FFF2-40B4-BE49-F238E27FC236}">
+                <a16:creationId xmlns:a16="http://schemas.microsoft.com/office/drawing/2014/main" id="{B5E7F4B0-DED2-7A1B-F640-5CE78714CAD8}"/>
+              </a:ext>
+            </a:extLst>
+          </p:cNvPr>
+          <p:cNvCxnSpPr>
+            <a:cxnSpLocks/>
+          </p:cNvCxnSpPr>
+          <p:nvPr/>
+        </p:nvCxnSpPr>
+        <p:spPr>
+          <a:xfrm flipV="1">
+            <a:off x="6179331" y="2651652"/>
+            <a:ext cx="3326772" cy="0"/>
+          </a:xfrm>
+          <a:prstGeom prst="straightConnector1">
+            <a:avLst/>
+          </a:prstGeom>
+          <a:ln>
+            <a:solidFill>
+              <a:schemeClr val="accent2">
+                <a:lumMod val="75000"/>
+              </a:schemeClr>
+            </a:solidFill>
+            <a:prstDash val="sysDash"/>
+            <a:tailEnd type="triangle"/>
+          </a:ln>
+        </p:spPr>
+        <p:style>
+          <a:lnRef idx="2">
+            <a:schemeClr val="dk1"/>
+          </a:lnRef>
+          <a:fillRef idx="0">
+            <a:schemeClr val="dk1"/>
+          </a:fillRef>
+          <a:effectRef idx="1">
+            <a:schemeClr val="dk1"/>
+          </a:effectRef>
+          <a:fontRef idx="minor">
+            <a:schemeClr val="tx1"/>
+          </a:fontRef>
+        </p:style>
+      </p:cxnSp>
+      <p:sp>
+        <p:nvSpPr>
+          <p:cNvPr id="101" name="TextBox 100">
+            <a:extLst>
+              <a:ext uri="{FF2B5EF4-FFF2-40B4-BE49-F238E27FC236}">
+                <a16:creationId xmlns:a16="http://schemas.microsoft.com/office/drawing/2014/main" id="{C89FBE41-3283-2925-4DAA-C08C2D5F28AA}"/>
+              </a:ext>
+            </a:extLst>
+          </p:cNvPr>
+          <p:cNvSpPr txBox="1"/>
+          <p:nvPr/>
+        </p:nvSpPr>
+        <p:spPr>
+          <a:xfrm>
+            <a:off x="6273795" y="2636303"/>
+            <a:ext cx="2130235" cy="261610"/>
+          </a:xfrm>
+          <a:prstGeom prst="rect">
+            <a:avLst/>
+          </a:prstGeom>
+          <a:noFill/>
+        </p:spPr>
+        <p:txBody>
+          <a:bodyPr wrap="square" rtlCol="0">
+            <a:spAutoFit/>
+          </a:bodyPr>
+          <a:lstStyle/>
+          <a:p>
+            <a:r>
+              <a:rPr lang="en-SG" sz="1100" b="1" dirty="0">
+                <a:solidFill>
+                  <a:schemeClr val="accent2">
+                    <a:lumMod val="50000"/>
+                  </a:schemeClr>
+                </a:solidFill>
+              </a:rPr>
+              <a:t>Data Publish (Drone fly data</a:t>
+            </a:r>
+            <a:r>
+              <a:rPr lang="en-SG" sz="1100" b="1" dirty="0">
+                <a:solidFill>
+                  <a:schemeClr val="accent6">
+                    <a:lumMod val="50000"/>
+                  </a:schemeClr>
+                </a:solidFill>
+              </a:rPr>
+              <a:t>)</a:t>
+            </a:r>
+          </a:p>
+        </p:txBody>
+      </p:sp>
+      <p:cxnSp>
+        <p:nvCxnSpPr>
+          <p:cNvPr id="103" name="Connector: Elbow 102">
+            <a:extLst>
+              <a:ext uri="{FF2B5EF4-FFF2-40B4-BE49-F238E27FC236}">
+                <a16:creationId xmlns:a16="http://schemas.microsoft.com/office/drawing/2014/main" id="{5932A095-9191-172B-C9FE-AC4425BA43D9}"/>
+              </a:ext>
+            </a:extLst>
+          </p:cNvPr>
+          <p:cNvCxnSpPr/>
+          <p:nvPr/>
+        </p:nvCxnSpPr>
+        <p:spPr>
+          <a:xfrm rot="5400000" flipH="1" flipV="1">
+            <a:off x="8118493" y="3521219"/>
+            <a:ext cx="2141721" cy="633500"/>
+          </a:xfrm>
+          <a:prstGeom prst="bentConnector3">
+            <a:avLst>
+              <a:gd name="adj1" fmla="val 99607"/>
+            </a:avLst>
+          </a:prstGeom>
+          <a:ln>
+            <a:solidFill>
+              <a:schemeClr val="accent2">
+                <a:lumMod val="75000"/>
+              </a:schemeClr>
+            </a:solidFill>
+            <a:prstDash val="sysDash"/>
+            <a:tailEnd type="triangle"/>
+          </a:ln>
+        </p:spPr>
+        <p:style>
+          <a:lnRef idx="2">
+            <a:schemeClr val="dk1"/>
+          </a:lnRef>
+          <a:fillRef idx="0">
+            <a:schemeClr val="dk1"/>
+          </a:fillRef>
+          <a:effectRef idx="1">
+            <a:schemeClr val="dk1"/>
+          </a:effectRef>
+          <a:fontRef idx="minor">
+            <a:schemeClr val="tx1"/>
+          </a:fontRef>
+        </p:style>
+      </p:cxnSp>
+      <p:sp>
+        <p:nvSpPr>
+          <p:cNvPr id="105" name="TextBox 104">
+            <a:extLst>
+              <a:ext uri="{FF2B5EF4-FFF2-40B4-BE49-F238E27FC236}">
+                <a16:creationId xmlns:a16="http://schemas.microsoft.com/office/drawing/2014/main" id="{5F31E912-988C-98F9-A0F3-408D966AC1D7}"/>
+              </a:ext>
+            </a:extLst>
+          </p:cNvPr>
+          <p:cNvSpPr txBox="1"/>
+          <p:nvPr/>
+        </p:nvSpPr>
+        <p:spPr>
+          <a:xfrm>
+            <a:off x="8292078" y="3858927"/>
+            <a:ext cx="1133810" cy="600164"/>
+          </a:xfrm>
+          <a:prstGeom prst="rect">
+            <a:avLst/>
+          </a:prstGeom>
+          <a:noFill/>
+        </p:spPr>
+        <p:txBody>
+          <a:bodyPr wrap="square" rtlCol="0">
+            <a:spAutoFit/>
+          </a:bodyPr>
+          <a:lstStyle/>
+          <a:p>
+            <a:r>
+              <a:rPr lang="en-SG" sz="1100" b="1" dirty="0">
+                <a:solidFill>
+                  <a:schemeClr val="accent2">
+                    <a:lumMod val="50000"/>
+                  </a:schemeClr>
+                </a:solidFill>
+              </a:rPr>
+              <a:t>Data Publish ( temp and fan-speed data</a:t>
+            </a:r>
+            <a:r>
+              <a:rPr lang="en-SG" sz="1100" b="1" dirty="0">
+                <a:solidFill>
+                  <a:schemeClr val="accent6">
+                    <a:lumMod val="50000"/>
+                  </a:schemeClr>
+                </a:solidFill>
+              </a:rPr>
+              <a:t>)</a:t>
+            </a:r>
+          </a:p>
+        </p:txBody>
+      </p:sp>
+      <p:cxnSp>
+        <p:nvCxnSpPr>
+          <p:cNvPr id="107" name="Connector: Elbow 106">
+            <a:extLst>
+              <a:ext uri="{FF2B5EF4-FFF2-40B4-BE49-F238E27FC236}">
+                <a16:creationId xmlns:a16="http://schemas.microsoft.com/office/drawing/2014/main" id="{174AD778-74FB-B924-27B5-FFD874A5F6DD}"/>
+              </a:ext>
+            </a:extLst>
+          </p:cNvPr>
+          <p:cNvCxnSpPr>
+            <a:endCxn id="81" idx="3"/>
+          </p:cNvCxnSpPr>
+          <p:nvPr/>
+        </p:nvCxnSpPr>
+        <p:spPr>
+          <a:xfrm rot="5400000">
+            <a:off x="8209305" y="3527640"/>
+            <a:ext cx="2296723" cy="547428"/>
+          </a:xfrm>
+          <a:prstGeom prst="bentConnector2">
+            <a:avLst/>
+          </a:prstGeom>
+          <a:ln>
+            <a:solidFill>
+              <a:schemeClr val="accent6">
+                <a:lumMod val="75000"/>
+              </a:schemeClr>
+            </a:solidFill>
+            <a:prstDash val="sysDash"/>
+            <a:tailEnd type="triangle"/>
+          </a:ln>
+        </p:spPr>
+        <p:style>
+          <a:lnRef idx="2">
+            <a:schemeClr val="accent6"/>
+          </a:lnRef>
+          <a:fillRef idx="0">
+            <a:schemeClr val="accent6"/>
+          </a:fillRef>
+          <a:effectRef idx="1">
+            <a:schemeClr val="accent6"/>
+          </a:effectRef>
+          <a:fontRef idx="minor">
+            <a:schemeClr val="tx1"/>
+          </a:fontRef>
+        </p:style>
+      </p:cxnSp>
+      <p:cxnSp>
+        <p:nvCxnSpPr>
+          <p:cNvPr id="136" name="Straight Arrow Connector 135">
+            <a:extLst>
+              <a:ext uri="{FF2B5EF4-FFF2-40B4-BE49-F238E27FC236}">
+                <a16:creationId xmlns:a16="http://schemas.microsoft.com/office/drawing/2014/main" id="{5F4CB6EC-3BB3-C9CE-4BB0-7C66CC110353}"/>
+              </a:ext>
+            </a:extLst>
+          </p:cNvPr>
+          <p:cNvCxnSpPr>
+            <a:cxnSpLocks/>
+          </p:cNvCxnSpPr>
+          <p:nvPr/>
+        </p:nvCxnSpPr>
+        <p:spPr>
+          <a:xfrm flipV="1">
+            <a:off x="4663006" y="1567050"/>
+            <a:ext cx="620306" cy="0"/>
+          </a:xfrm>
+          <a:prstGeom prst="straightConnector1">
+            <a:avLst/>
+          </a:prstGeom>
+          <a:ln>
+            <a:solidFill>
+              <a:schemeClr val="accent6">
+                <a:lumMod val="75000"/>
+              </a:schemeClr>
+            </a:solidFill>
+            <a:prstDash val="sysDash"/>
+            <a:tailEnd type="triangle"/>
+          </a:ln>
+        </p:spPr>
+        <p:style>
+          <a:lnRef idx="2">
+            <a:schemeClr val="accent1"/>
+          </a:lnRef>
+          <a:fillRef idx="0">
+            <a:schemeClr val="accent1"/>
+          </a:fillRef>
+          <a:effectRef idx="1">
+            <a:schemeClr val="accent1"/>
+          </a:effectRef>
+          <a:fontRef idx="minor">
+            <a:schemeClr val="tx1"/>
+          </a:fontRef>
+        </p:style>
+      </p:cxnSp>
+      <p:sp>
+        <p:nvSpPr>
+          <p:cNvPr id="143" name="TextBox 142">
+            <a:extLst>
+              <a:ext uri="{FF2B5EF4-FFF2-40B4-BE49-F238E27FC236}">
+                <a16:creationId xmlns:a16="http://schemas.microsoft.com/office/drawing/2014/main" id="{FF26E35C-F07C-D71E-9EE1-21F5BA435C29}"/>
+              </a:ext>
+            </a:extLst>
+          </p:cNvPr>
+          <p:cNvSpPr txBox="1"/>
+          <p:nvPr/>
+        </p:nvSpPr>
+        <p:spPr>
+          <a:xfrm>
+            <a:off x="5330009" y="1421456"/>
+            <a:ext cx="2125740" cy="261610"/>
+          </a:xfrm>
+          <a:prstGeom prst="rect">
+            <a:avLst/>
+          </a:prstGeom>
+          <a:noFill/>
+        </p:spPr>
+        <p:txBody>
+          <a:bodyPr wrap="square" rtlCol="0">
+            <a:spAutoFit/>
+          </a:bodyPr>
+          <a:lstStyle/>
+          <a:p>
+            <a:r>
+              <a:rPr lang="en-SG" sz="1100" b="1" dirty="0">
+                <a:solidFill>
+                  <a:schemeClr val="accent6">
+                    <a:lumMod val="75000"/>
+                  </a:schemeClr>
+                </a:solidFill>
+              </a:rPr>
+              <a:t>MQTT Data Subscribe Request</a:t>
+            </a:r>
+          </a:p>
+        </p:txBody>
+      </p:sp>
+      <p:cxnSp>
+        <p:nvCxnSpPr>
+          <p:cNvPr id="145" name="Straight Arrow Connector 144">
+            <a:extLst>
+              <a:ext uri="{FF2B5EF4-FFF2-40B4-BE49-F238E27FC236}">
+                <a16:creationId xmlns:a16="http://schemas.microsoft.com/office/drawing/2014/main" id="{A1D14FC2-D575-B83B-3310-6F877724A0F1}"/>
+              </a:ext>
+            </a:extLst>
+          </p:cNvPr>
+          <p:cNvCxnSpPr>
+            <a:cxnSpLocks/>
+          </p:cNvCxnSpPr>
+          <p:nvPr/>
+        </p:nvCxnSpPr>
+        <p:spPr>
+          <a:xfrm>
+            <a:off x="4677832" y="1783408"/>
+            <a:ext cx="605480" cy="0"/>
+          </a:xfrm>
+          <a:prstGeom prst="straightConnector1">
+            <a:avLst/>
+          </a:prstGeom>
+          <a:ln>
+            <a:solidFill>
+              <a:schemeClr val="accent2">
+                <a:lumMod val="75000"/>
+              </a:schemeClr>
+            </a:solidFill>
+            <a:prstDash val="sysDash"/>
+            <a:tailEnd type="triangle"/>
+          </a:ln>
+        </p:spPr>
+        <p:style>
+          <a:lnRef idx="2">
+            <a:schemeClr val="dk1"/>
+          </a:lnRef>
+          <a:fillRef idx="0">
+            <a:schemeClr val="dk1"/>
+          </a:fillRef>
+          <a:effectRef idx="1">
+            <a:schemeClr val="dk1"/>
+          </a:effectRef>
+          <a:fontRef idx="minor">
+            <a:schemeClr val="tx1"/>
+          </a:fontRef>
+        </p:style>
+      </p:cxnSp>
+      <p:sp>
+        <p:nvSpPr>
+          <p:cNvPr id="152" name="TextBox 151">
+            <a:extLst>
+              <a:ext uri="{FF2B5EF4-FFF2-40B4-BE49-F238E27FC236}">
+                <a16:creationId xmlns:a16="http://schemas.microsoft.com/office/drawing/2014/main" id="{19BA9486-9630-D344-1BE6-3CA911C992FC}"/>
+              </a:ext>
+            </a:extLst>
+          </p:cNvPr>
+          <p:cNvSpPr txBox="1"/>
+          <p:nvPr/>
+        </p:nvSpPr>
+        <p:spPr>
+          <a:xfrm>
+            <a:off x="5337689" y="1642185"/>
+            <a:ext cx="2125740" cy="261610"/>
+          </a:xfrm>
+          <a:prstGeom prst="rect">
+            <a:avLst/>
+          </a:prstGeom>
+          <a:noFill/>
+        </p:spPr>
+        <p:txBody>
+          <a:bodyPr wrap="square" rtlCol="0">
+            <a:spAutoFit/>
+          </a:bodyPr>
+          <a:lstStyle/>
+          <a:p>
+            <a:r>
+              <a:rPr lang="en-SG" sz="1100" b="1" dirty="0">
+                <a:solidFill>
+                  <a:schemeClr val="accent2">
+                    <a:lumMod val="50000"/>
+                  </a:schemeClr>
+                </a:solidFill>
+              </a:rPr>
+              <a:t>MQTT Data Publish Request</a:t>
+            </a:r>
+          </a:p>
+        </p:txBody>
+      </p:sp>
+      <p:sp>
+        <p:nvSpPr>
+          <p:cNvPr id="2" name="Rectangle 1">
+            <a:extLst>
+              <a:ext uri="{FF2B5EF4-FFF2-40B4-BE49-F238E27FC236}">
+                <a16:creationId xmlns:a16="http://schemas.microsoft.com/office/drawing/2014/main" id="{0503D145-A7A6-19DE-CBAD-F0264A76DE70}"/>
+              </a:ext>
+            </a:extLst>
+          </p:cNvPr>
+          <p:cNvSpPr/>
+          <p:nvPr/>
+        </p:nvSpPr>
+        <p:spPr>
+          <a:xfrm>
+            <a:off x="8128462" y="5218211"/>
+            <a:ext cx="965256" cy="340962"/>
+          </a:xfrm>
+          <a:prstGeom prst="rect">
+            <a:avLst/>
+          </a:prstGeom>
+          <a:solidFill>
+            <a:schemeClr val="accent2"/>
+          </a:solidFill>
+        </p:spPr>
+        <p:style>
+          <a:lnRef idx="2">
+            <a:schemeClr val="accent1">
+              <a:shade val="50000"/>
+            </a:schemeClr>
+          </a:lnRef>
+          <a:fillRef idx="1">
+            <a:schemeClr val="accent1"/>
+          </a:fillRef>
+          <a:effectRef idx="0">
+            <a:schemeClr val="accent1"/>
+          </a:effectRef>
+          <a:fontRef idx="minor">
+            <a:schemeClr val="lt1"/>
+          </a:fontRef>
+        </p:style>
+        <p:txBody>
+          <a:bodyPr rtlCol="0" anchor="ctr"/>
+          <a:lstStyle/>
+          <a:p>
+            <a:r>
+              <a:rPr lang="en-SG" sz="1050" b="1" dirty="0"/>
+              <a:t>MQTT Broker</a:t>
+            </a:r>
+          </a:p>
+        </p:txBody>
+      </p:sp>
+      <p:cxnSp>
+        <p:nvCxnSpPr>
+          <p:cNvPr id="11" name="Connector: Elbow 10">
+            <a:extLst>
+              <a:ext uri="{FF2B5EF4-FFF2-40B4-BE49-F238E27FC236}">
+                <a16:creationId xmlns:a16="http://schemas.microsoft.com/office/drawing/2014/main" id="{4ED4F42A-0BEE-8BF1-BA0B-EF2804695581}"/>
+              </a:ext>
+            </a:extLst>
+          </p:cNvPr>
+          <p:cNvCxnSpPr>
+            <a:cxnSpLocks/>
+            <a:endCxn id="81" idx="1"/>
+          </p:cNvCxnSpPr>
+          <p:nvPr/>
+        </p:nvCxnSpPr>
+        <p:spPr>
+          <a:xfrm rot="5400000" flipH="1" flipV="1">
+            <a:off x="7598276" y="5259499"/>
+            <a:ext cx="830203" cy="210638"/>
+          </a:xfrm>
+          <a:prstGeom prst="bentConnector2">
+            <a:avLst/>
+          </a:prstGeom>
+        </p:spPr>
+        <p:style>
+          <a:lnRef idx="2">
+            <a:schemeClr val="dk1"/>
+          </a:lnRef>
+          <a:fillRef idx="0">
+            <a:schemeClr val="dk1"/>
+          </a:fillRef>
+          <a:effectRef idx="1">
+            <a:schemeClr val="dk1"/>
+          </a:effectRef>
+          <a:fontRef idx="minor">
+            <a:schemeClr val="tx1"/>
+          </a:fontRef>
+        </p:style>
+      </p:cxnSp>
+      <p:cxnSp>
+        <p:nvCxnSpPr>
+          <p:cNvPr id="16" name="Connector: Elbow 15">
+            <a:extLst>
+              <a:ext uri="{FF2B5EF4-FFF2-40B4-BE49-F238E27FC236}">
+                <a16:creationId xmlns:a16="http://schemas.microsoft.com/office/drawing/2014/main" id="{560443A5-3904-604F-97A6-3E8435033BFF}"/>
+              </a:ext>
+            </a:extLst>
+          </p:cNvPr>
+          <p:cNvCxnSpPr>
+            <a:cxnSpLocks/>
+            <a:endCxn id="2" idx="3"/>
+          </p:cNvCxnSpPr>
+          <p:nvPr/>
+        </p:nvCxnSpPr>
+        <p:spPr>
+          <a:xfrm rot="10800000" flipV="1">
+            <a:off x="9093719" y="4866826"/>
+            <a:ext cx="950865" cy="521866"/>
+          </a:xfrm>
+          <a:prstGeom prst="bentConnector3">
+            <a:avLst>
+              <a:gd name="adj1" fmla="val 36537"/>
+            </a:avLst>
+          </a:prstGeom>
+          <a:ln>
+            <a:solidFill>
+              <a:schemeClr val="accent2">
+                <a:lumMod val="75000"/>
+              </a:schemeClr>
+            </a:solidFill>
+            <a:prstDash val="sysDash"/>
+            <a:tailEnd type="triangle"/>
+          </a:ln>
+        </p:spPr>
+        <p:style>
+          <a:lnRef idx="2">
+            <a:schemeClr val="dk1"/>
+          </a:lnRef>
+          <a:fillRef idx="0">
+            <a:schemeClr val="dk1"/>
+          </a:fillRef>
+          <a:effectRef idx="1">
+            <a:schemeClr val="dk1"/>
+          </a:effectRef>
+          <a:fontRef idx="minor">
+            <a:schemeClr val="tx1"/>
+          </a:fontRef>
+        </p:style>
+      </p:cxnSp>
+      <p:sp>
+        <p:nvSpPr>
+          <p:cNvPr id="21" name="TextBox 20">
+            <a:extLst>
+              <a:ext uri="{FF2B5EF4-FFF2-40B4-BE49-F238E27FC236}">
+                <a16:creationId xmlns:a16="http://schemas.microsoft.com/office/drawing/2014/main" id="{C9385657-537C-6196-4B7C-14E3DBFF65FF}"/>
+              </a:ext>
+            </a:extLst>
+          </p:cNvPr>
+          <p:cNvSpPr txBox="1"/>
+          <p:nvPr/>
+        </p:nvSpPr>
+        <p:spPr>
+          <a:xfrm>
+            <a:off x="8682802" y="5692668"/>
+            <a:ext cx="1349727" cy="600164"/>
+          </a:xfrm>
+          <a:prstGeom prst="rect">
+            <a:avLst/>
+          </a:prstGeom>
+          <a:noFill/>
+        </p:spPr>
+        <p:txBody>
+          <a:bodyPr wrap="square" rtlCol="0">
+            <a:spAutoFit/>
+          </a:bodyPr>
+          <a:lstStyle/>
+          <a:p>
+            <a:r>
+              <a:rPr lang="en-SG" sz="1100" b="1" dirty="0">
+                <a:solidFill>
+                  <a:schemeClr val="accent2">
+                    <a:lumMod val="50000"/>
+                  </a:schemeClr>
+                </a:solidFill>
+              </a:rPr>
+              <a:t>Data Publish ( Direct Overwrite control</a:t>
+            </a:r>
+            <a:endParaRPr lang="en-SG" sz="1100" b="1" dirty="0">
+              <a:solidFill>
+                <a:schemeClr val="accent6">
+                  <a:lumMod val="50000"/>
+                </a:schemeClr>
+              </a:solidFill>
+            </a:endParaRPr>
+          </a:p>
+        </p:txBody>
+      </p:sp>
+      <p:pic>
+        <p:nvPicPr>
+          <p:cNvPr id="7" name="Picture 6">
+            <a:extLst>
+              <a:ext uri="{FF2B5EF4-FFF2-40B4-BE49-F238E27FC236}">
+                <a16:creationId xmlns:a16="http://schemas.microsoft.com/office/drawing/2014/main" id="{05DB6C0B-30EB-231C-FF38-13807B49F5C9}"/>
+              </a:ext>
+            </a:extLst>
+          </p:cNvPr>
+          <p:cNvPicPr>
+            <a:picLocks noChangeAspect="1"/>
+          </p:cNvPicPr>
+          <p:nvPr/>
+        </p:nvPicPr>
+        <p:blipFill>
+          <a:blip r:embed="rId4"/>
+          <a:stretch>
+            <a:fillRect/>
+          </a:stretch>
+        </p:blipFill>
+        <p:spPr>
+          <a:xfrm>
+            <a:off x="632278" y="1904256"/>
+            <a:ext cx="3449940" cy="1854343"/>
+          </a:xfrm>
+          <a:prstGeom prst="rect">
+            <a:avLst/>
+          </a:prstGeom>
+          <a:ln w="19050">
+            <a:solidFill>
+              <a:schemeClr val="tx1"/>
+            </a:solidFill>
+          </a:ln>
+        </p:spPr>
+      </p:pic>
+    </p:spTree>
+    <p:extLst>
+      <p:ext uri="{BB962C8B-B14F-4D97-AF65-F5344CB8AC3E}">
+        <p14:creationId xmlns:p14="http://schemas.microsoft.com/office/powerpoint/2010/main" val="1693198638"/>
       </p:ext>
     </p:extLst>
   </p:cSld>

</xml_diff>

<commit_message>
Update the section 5 and section 6.
</commit_message>
<xml_diff>
--- a/2_SystemDesign_Doc/6_Thermal_State_Monitor_Desgin_Img/designDoc.pptx
+++ b/2_SystemDesign_Doc/6_Thermal_State_Monitor_Desgin_Img/designDoc.pptx
@@ -5,13 +5,14 @@
     <p:sldMasterId id="2147483648" r:id="rId1"/>
   </p:sldMasterIdLst>
   <p:notesMasterIdLst>
-    <p:notesMasterId r:id="rId6"/>
+    <p:notesMasterId r:id="rId7"/>
   </p:notesMasterIdLst>
   <p:sldIdLst>
     <p:sldId id="256" r:id="rId2"/>
     <p:sldId id="269" r:id="rId3"/>
     <p:sldId id="270" r:id="rId4"/>
     <p:sldId id="259" r:id="rId5"/>
+    <p:sldId id="271" r:id="rId6"/>
   </p:sldIdLst>
   <p:sldSz cx="12192000" cy="6858000"/>
   <p:notesSz cx="6858000" cy="9144000"/>
@@ -651,6 +652,90 @@
     <p:extLst>
       <p:ext uri="{BB962C8B-B14F-4D97-AF65-F5344CB8AC3E}">
         <p14:creationId xmlns:p14="http://schemas.microsoft.com/office/powerpoint/2010/main" val="3907934090"/>
+      </p:ext>
+    </p:extLst>
+  </p:cSld>
+  <p:clrMapOvr>
+    <a:masterClrMapping/>
+  </p:clrMapOvr>
+</p:notes>
+</file>
+
+<file path=ppt/notesSlides/notesSlide3.xml><?xml version="1.0" encoding="utf-8"?>
+<p:notes xmlns:a="http://schemas.openxmlformats.org/drawingml/2006/main" xmlns:r="http://schemas.openxmlformats.org/officeDocument/2006/relationships" xmlns:p="http://schemas.openxmlformats.org/presentationml/2006/main">
+  <p:cSld>
+    <p:spTree>
+      <p:nvGrpSpPr>
+        <p:cNvPr id="1" name=""/>
+        <p:cNvGrpSpPr/>
+        <p:nvPr/>
+      </p:nvGrpSpPr>
+      <p:grpSpPr>
+        <a:xfrm>
+          <a:off x="0" y="0"/>
+          <a:ext cx="0" cy="0"/>
+          <a:chOff x="0" y="0"/>
+          <a:chExt cx="0" cy="0"/>
+        </a:xfrm>
+      </p:grpSpPr>
+      <p:sp>
+        <p:nvSpPr>
+          <p:cNvPr id="2" name="Slide Image Placeholder 1"/>
+          <p:cNvSpPr>
+            <a:spLocks noGrp="1" noRot="1" noChangeAspect="1"/>
+          </p:cNvSpPr>
+          <p:nvPr>
+            <p:ph type="sldImg"/>
+          </p:nvPr>
+        </p:nvSpPr>
+        <p:spPr/>
+      </p:sp>
+      <p:sp>
+        <p:nvSpPr>
+          <p:cNvPr id="3" name="Notes Placeholder 2"/>
+          <p:cNvSpPr>
+            <a:spLocks noGrp="1"/>
+          </p:cNvSpPr>
+          <p:nvPr>
+            <p:ph type="body" idx="1"/>
+          </p:nvPr>
+        </p:nvSpPr>
+        <p:spPr/>
+        <p:txBody>
+          <a:bodyPr/>
+          <a:lstStyle/>
+          <a:p>
+            <a:endParaRPr lang="en-SG"/>
+          </a:p>
+        </p:txBody>
+      </p:sp>
+      <p:sp>
+        <p:nvSpPr>
+          <p:cNvPr id="4" name="Slide Number Placeholder 3"/>
+          <p:cNvSpPr>
+            <a:spLocks noGrp="1"/>
+          </p:cNvSpPr>
+          <p:nvPr>
+            <p:ph type="sldNum" sz="quarter" idx="5"/>
+          </p:nvPr>
+        </p:nvSpPr>
+        <p:spPr/>
+        <p:txBody>
+          <a:bodyPr/>
+          <a:lstStyle/>
+          <a:p>
+            <a:fld id="{D6D9CFC9-68F1-45DE-BFA9-904F85FD4D8B}" type="slidenum">
+              <a:rPr lang="en-SG" smtClean="0"/>
+              <a:t>5</a:t>
+            </a:fld>
+            <a:endParaRPr lang="en-SG"/>
+          </a:p>
+        </p:txBody>
+      </p:sp>
+    </p:spTree>
+    <p:extLst>
+      <p:ext uri="{BB962C8B-B14F-4D97-AF65-F5344CB8AC3E}">
+        <p14:creationId xmlns:p14="http://schemas.microsoft.com/office/powerpoint/2010/main" val="545896724"/>
       </p:ext>
     </p:extLst>
   </p:cSld>
@@ -15254,6 +15339,2179 @@
     <p:extLst>
       <p:ext uri="{BB962C8B-B14F-4D97-AF65-F5344CB8AC3E}">
         <p14:creationId xmlns:p14="http://schemas.microsoft.com/office/powerpoint/2010/main" val="1693198638"/>
+      </p:ext>
+    </p:extLst>
+  </p:cSld>
+  <p:clrMapOvr>
+    <a:masterClrMapping/>
+  </p:clrMapOvr>
+</p:sld>
+</file>
+
+<file path=ppt/slides/slide5.xml><?xml version="1.0" encoding="utf-8"?>
+<p:sld xmlns:a="http://schemas.openxmlformats.org/drawingml/2006/main" xmlns:r="http://schemas.openxmlformats.org/officeDocument/2006/relationships" xmlns:p="http://schemas.openxmlformats.org/presentationml/2006/main">
+  <p:cSld>
+    <p:spTree>
+      <p:nvGrpSpPr>
+        <p:cNvPr id="1" name=""/>
+        <p:cNvGrpSpPr/>
+        <p:nvPr/>
+      </p:nvGrpSpPr>
+      <p:grpSpPr>
+        <a:xfrm>
+          <a:off x="0" y="0"/>
+          <a:ext cx="0" cy="0"/>
+          <a:chOff x="0" y="0"/>
+          <a:chExt cx="0" cy="0"/>
+        </a:xfrm>
+      </p:grpSpPr>
+      <p:pic>
+        <p:nvPicPr>
+          <p:cNvPr id="41" name="Picture 40">
+            <a:extLst>
+              <a:ext uri="{FF2B5EF4-FFF2-40B4-BE49-F238E27FC236}">
+                <a16:creationId xmlns:a16="http://schemas.microsoft.com/office/drawing/2014/main" id="{38FC5D79-06E9-A9C0-177F-EAE296E672EE}"/>
+              </a:ext>
+            </a:extLst>
+          </p:cNvPr>
+          <p:cNvPicPr>
+            <a:picLocks noChangeAspect="1"/>
+          </p:cNvPicPr>
+          <p:nvPr/>
+        </p:nvPicPr>
+        <p:blipFill>
+          <a:blip r:embed="rId3"/>
+          <a:stretch>
+            <a:fillRect/>
+          </a:stretch>
+        </p:blipFill>
+        <p:spPr>
+          <a:xfrm>
+            <a:off x="3963318" y="3175707"/>
+            <a:ext cx="2595799" cy="1235195"/>
+          </a:xfrm>
+          <a:prstGeom prst="rect">
+            <a:avLst/>
+          </a:prstGeom>
+          <a:ln w="12700">
+            <a:solidFill>
+              <a:schemeClr val="bg1"/>
+            </a:solidFill>
+          </a:ln>
+        </p:spPr>
+      </p:pic>
+      <p:sp>
+        <p:nvSpPr>
+          <p:cNvPr id="42" name="Rectangle 41">
+            <a:extLst>
+              <a:ext uri="{FF2B5EF4-FFF2-40B4-BE49-F238E27FC236}">
+                <a16:creationId xmlns:a16="http://schemas.microsoft.com/office/drawing/2014/main" id="{C213BAC0-887D-1526-1BCB-E903207D4765}"/>
+              </a:ext>
+            </a:extLst>
+          </p:cNvPr>
+          <p:cNvSpPr/>
+          <p:nvPr/>
+        </p:nvSpPr>
+        <p:spPr>
+          <a:xfrm>
+            <a:off x="349924" y="1921230"/>
+            <a:ext cx="1430530" cy="961446"/>
+          </a:xfrm>
+          <a:prstGeom prst="rect">
+            <a:avLst/>
+          </a:prstGeom>
+          <a:solidFill>
+            <a:schemeClr val="accent1">
+              <a:lumMod val="20000"/>
+              <a:lumOff val="80000"/>
+            </a:schemeClr>
+          </a:solidFill>
+        </p:spPr>
+        <p:style>
+          <a:lnRef idx="2">
+            <a:schemeClr val="accent1">
+              <a:shade val="15000"/>
+            </a:schemeClr>
+          </a:lnRef>
+          <a:fillRef idx="1">
+            <a:schemeClr val="accent1"/>
+          </a:fillRef>
+          <a:effectRef idx="0">
+            <a:schemeClr val="accent1"/>
+          </a:effectRef>
+          <a:fontRef idx="minor">
+            <a:schemeClr val="lt1"/>
+          </a:fontRef>
+        </p:style>
+        <p:txBody>
+          <a:bodyPr rtlCol="0" anchor="ctr"/>
+          <a:lstStyle/>
+          <a:p>
+            <a:pPr algn="ctr"/>
+            <a:endParaRPr lang="en-SG" dirty="0"/>
+          </a:p>
+        </p:txBody>
+      </p:sp>
+      <p:sp>
+        <p:nvSpPr>
+          <p:cNvPr id="43" name="TextBox 42">
+            <a:extLst>
+              <a:ext uri="{FF2B5EF4-FFF2-40B4-BE49-F238E27FC236}">
+                <a16:creationId xmlns:a16="http://schemas.microsoft.com/office/drawing/2014/main" id="{CA3E9129-8F48-4918-C730-EB191FA80312}"/>
+              </a:ext>
+            </a:extLst>
+          </p:cNvPr>
+          <p:cNvSpPr txBox="1"/>
+          <p:nvPr/>
+        </p:nvSpPr>
+        <p:spPr>
+          <a:xfrm>
+            <a:off x="383120" y="1921230"/>
+            <a:ext cx="1331611" cy="461665"/>
+          </a:xfrm>
+          <a:prstGeom prst="rect">
+            <a:avLst/>
+          </a:prstGeom>
+          <a:noFill/>
+        </p:spPr>
+        <p:txBody>
+          <a:bodyPr wrap="square" rtlCol="0">
+            <a:spAutoFit/>
+          </a:bodyPr>
+          <a:lstStyle/>
+          <a:p>
+            <a:r>
+              <a:rPr lang="en-US" sz="1200" b="1" dirty="0"/>
+              <a:t>ZBRTT1 Thermal IoT Simulator2</a:t>
+            </a:r>
+            <a:endParaRPr lang="en-SG" sz="1200" b="1" dirty="0"/>
+          </a:p>
+        </p:txBody>
+      </p:sp>
+      <p:sp>
+        <p:nvSpPr>
+          <p:cNvPr id="44" name="Rectangle 43">
+            <a:extLst>
+              <a:ext uri="{FF2B5EF4-FFF2-40B4-BE49-F238E27FC236}">
+                <a16:creationId xmlns:a16="http://schemas.microsoft.com/office/drawing/2014/main" id="{3D7FCF48-B005-3A63-CD44-11B917D66B71}"/>
+              </a:ext>
+            </a:extLst>
+          </p:cNvPr>
+          <p:cNvSpPr/>
+          <p:nvPr/>
+        </p:nvSpPr>
+        <p:spPr>
+          <a:xfrm>
+            <a:off x="583223" y="2396151"/>
+            <a:ext cx="924720" cy="340962"/>
+          </a:xfrm>
+          <a:prstGeom prst="rect">
+            <a:avLst/>
+          </a:prstGeom>
+          <a:solidFill>
+            <a:schemeClr val="accent2"/>
+          </a:solidFill>
+        </p:spPr>
+        <p:style>
+          <a:lnRef idx="2">
+            <a:schemeClr val="accent1">
+              <a:shade val="50000"/>
+            </a:schemeClr>
+          </a:lnRef>
+          <a:fillRef idx="1">
+            <a:schemeClr val="accent1"/>
+          </a:fillRef>
+          <a:effectRef idx="0">
+            <a:schemeClr val="accent1"/>
+          </a:effectRef>
+          <a:fontRef idx="minor">
+            <a:schemeClr val="lt1"/>
+          </a:fontRef>
+        </p:style>
+        <p:txBody>
+          <a:bodyPr rtlCol="0" anchor="ctr"/>
+          <a:lstStyle/>
+          <a:p>
+            <a:r>
+              <a:rPr lang="en-US" sz="1050" b="1" dirty="0"/>
+              <a:t>MQTT Client</a:t>
+            </a:r>
+            <a:endParaRPr lang="en-SG" sz="1050" b="1" dirty="0"/>
+          </a:p>
+        </p:txBody>
+      </p:sp>
+      <p:sp>
+        <p:nvSpPr>
+          <p:cNvPr id="45" name="Rectangle 44">
+            <a:extLst>
+              <a:ext uri="{FF2B5EF4-FFF2-40B4-BE49-F238E27FC236}">
+                <a16:creationId xmlns:a16="http://schemas.microsoft.com/office/drawing/2014/main" id="{48C34148-B37B-F536-C5E7-710A58150310}"/>
+              </a:ext>
+            </a:extLst>
+          </p:cNvPr>
+          <p:cNvSpPr/>
+          <p:nvPr/>
+        </p:nvSpPr>
+        <p:spPr>
+          <a:xfrm>
+            <a:off x="3696481" y="1114188"/>
+            <a:ext cx="4799038" cy="1767848"/>
+          </a:xfrm>
+          <a:prstGeom prst="rect">
+            <a:avLst/>
+          </a:prstGeom>
+          <a:solidFill>
+            <a:schemeClr val="accent6">
+              <a:lumMod val="20000"/>
+              <a:lumOff val="80000"/>
+            </a:schemeClr>
+          </a:solidFill>
+        </p:spPr>
+        <p:style>
+          <a:lnRef idx="2">
+            <a:schemeClr val="accent1">
+              <a:shade val="15000"/>
+            </a:schemeClr>
+          </a:lnRef>
+          <a:fillRef idx="1">
+            <a:schemeClr val="accent1"/>
+          </a:fillRef>
+          <a:effectRef idx="0">
+            <a:schemeClr val="accent1"/>
+          </a:effectRef>
+          <a:fontRef idx="minor">
+            <a:schemeClr val="lt1"/>
+          </a:fontRef>
+        </p:style>
+        <p:txBody>
+          <a:bodyPr rtlCol="0" anchor="ctr"/>
+          <a:lstStyle/>
+          <a:p>
+            <a:pPr algn="ctr"/>
+            <a:endParaRPr lang="en-SG" dirty="0"/>
+          </a:p>
+        </p:txBody>
+      </p:sp>
+      <p:sp>
+        <p:nvSpPr>
+          <p:cNvPr id="46" name="Rectangle 45">
+            <a:extLst>
+              <a:ext uri="{FF2B5EF4-FFF2-40B4-BE49-F238E27FC236}">
+                <a16:creationId xmlns:a16="http://schemas.microsoft.com/office/drawing/2014/main" id="{5B5BD74B-BCAA-DFF6-7B51-DAA5F5E65C14}"/>
+              </a:ext>
+            </a:extLst>
+          </p:cNvPr>
+          <p:cNvSpPr/>
+          <p:nvPr/>
+        </p:nvSpPr>
+        <p:spPr>
+          <a:xfrm>
+            <a:off x="4500347" y="2396151"/>
+            <a:ext cx="1062441" cy="340962"/>
+          </a:xfrm>
+          <a:prstGeom prst="rect">
+            <a:avLst/>
+          </a:prstGeom>
+          <a:solidFill>
+            <a:schemeClr val="accent2"/>
+          </a:solidFill>
+        </p:spPr>
+        <p:style>
+          <a:lnRef idx="2">
+            <a:schemeClr val="accent1">
+              <a:shade val="50000"/>
+            </a:schemeClr>
+          </a:lnRef>
+          <a:fillRef idx="1">
+            <a:schemeClr val="accent1"/>
+          </a:fillRef>
+          <a:effectRef idx="0">
+            <a:schemeClr val="accent1"/>
+          </a:effectRef>
+          <a:fontRef idx="minor">
+            <a:schemeClr val="lt1"/>
+          </a:fontRef>
+        </p:style>
+        <p:txBody>
+          <a:bodyPr rtlCol="0" anchor="ctr"/>
+          <a:lstStyle/>
+          <a:p>
+            <a:r>
+              <a:rPr lang="en-US" sz="1050" b="1" dirty="0"/>
+              <a:t>MQTT Broker</a:t>
+            </a:r>
+            <a:endParaRPr lang="en-SG" sz="1050" b="1" dirty="0"/>
+          </a:p>
+        </p:txBody>
+      </p:sp>
+      <p:sp>
+        <p:nvSpPr>
+          <p:cNvPr id="47" name="TextBox 46">
+            <a:extLst>
+              <a:ext uri="{FF2B5EF4-FFF2-40B4-BE49-F238E27FC236}">
+                <a16:creationId xmlns:a16="http://schemas.microsoft.com/office/drawing/2014/main" id="{33200C06-A5F7-71EC-669E-0CA0A1AEB80D}"/>
+              </a:ext>
+            </a:extLst>
+          </p:cNvPr>
+          <p:cNvSpPr txBox="1"/>
+          <p:nvPr/>
+        </p:nvSpPr>
+        <p:spPr>
+          <a:xfrm>
+            <a:off x="3735914" y="1163236"/>
+            <a:ext cx="1331611" cy="461665"/>
+          </a:xfrm>
+          <a:prstGeom prst="rect">
+            <a:avLst/>
+          </a:prstGeom>
+          <a:noFill/>
+        </p:spPr>
+        <p:txBody>
+          <a:bodyPr wrap="square" rtlCol="0">
+            <a:spAutoFit/>
+          </a:bodyPr>
+          <a:lstStyle/>
+          <a:p>
+            <a:r>
+              <a:rPr lang="en-US" sz="1200" b="1" dirty="0"/>
+              <a:t>IoT Gateway Simulator </a:t>
+            </a:r>
+            <a:endParaRPr lang="en-SG" sz="1200" b="1" dirty="0"/>
+          </a:p>
+        </p:txBody>
+      </p:sp>
+      <p:sp>
+        <p:nvSpPr>
+          <p:cNvPr id="48" name="Cloud 47">
+            <a:extLst>
+              <a:ext uri="{FF2B5EF4-FFF2-40B4-BE49-F238E27FC236}">
+                <a16:creationId xmlns:a16="http://schemas.microsoft.com/office/drawing/2014/main" id="{8B2E012C-2AEC-A255-18B0-7A28027C3B4F}"/>
+              </a:ext>
+            </a:extLst>
+          </p:cNvPr>
+          <p:cNvSpPr/>
+          <p:nvPr/>
+        </p:nvSpPr>
+        <p:spPr>
+          <a:xfrm>
+            <a:off x="2169869" y="1979091"/>
+            <a:ext cx="1254101" cy="732464"/>
+          </a:xfrm>
+          <a:prstGeom prst="cloud">
+            <a:avLst/>
+          </a:prstGeom>
+        </p:spPr>
+        <p:style>
+          <a:lnRef idx="2">
+            <a:schemeClr val="accent1">
+              <a:shade val="15000"/>
+            </a:schemeClr>
+          </a:lnRef>
+          <a:fillRef idx="1">
+            <a:schemeClr val="accent1"/>
+          </a:fillRef>
+          <a:effectRef idx="0">
+            <a:schemeClr val="accent1"/>
+          </a:effectRef>
+          <a:fontRef idx="minor">
+            <a:schemeClr val="lt1"/>
+          </a:fontRef>
+        </p:style>
+        <p:txBody>
+          <a:bodyPr rtlCol="0" anchor="ctr"/>
+          <a:lstStyle/>
+          <a:p>
+            <a:pPr algn="ctr"/>
+            <a:r>
+              <a:rPr lang="en-US" sz="1100" b="1" dirty="0"/>
+              <a:t>2.4G WIFI Network</a:t>
+            </a:r>
+            <a:endParaRPr lang="en-SG" sz="1100" b="1" dirty="0"/>
+          </a:p>
+        </p:txBody>
+      </p:sp>
+      <p:cxnSp>
+        <p:nvCxnSpPr>
+          <p:cNvPr id="51" name="Straight Arrow Connector 50">
+            <a:extLst>
+              <a:ext uri="{FF2B5EF4-FFF2-40B4-BE49-F238E27FC236}">
+                <a16:creationId xmlns:a16="http://schemas.microsoft.com/office/drawing/2014/main" id="{83CAD27B-5E8C-936B-6041-0DFBE13878E5}"/>
+              </a:ext>
+            </a:extLst>
+          </p:cNvPr>
+          <p:cNvCxnSpPr>
+            <a:cxnSpLocks/>
+            <a:endCxn id="46" idx="1"/>
+          </p:cNvCxnSpPr>
+          <p:nvPr/>
+        </p:nvCxnSpPr>
+        <p:spPr>
+          <a:xfrm>
+            <a:off x="1507943" y="2541956"/>
+            <a:ext cx="2992404" cy="0"/>
+          </a:xfrm>
+          <a:prstGeom prst="straightConnector1">
+            <a:avLst/>
+          </a:prstGeom>
+          <a:ln>
+            <a:tailEnd type="triangle"/>
+          </a:ln>
+        </p:spPr>
+        <p:style>
+          <a:lnRef idx="2">
+            <a:schemeClr val="accent1"/>
+          </a:lnRef>
+          <a:fillRef idx="0">
+            <a:schemeClr val="accent1"/>
+          </a:fillRef>
+          <a:effectRef idx="1">
+            <a:schemeClr val="accent1"/>
+          </a:effectRef>
+          <a:fontRef idx="minor">
+            <a:schemeClr val="tx1"/>
+          </a:fontRef>
+        </p:style>
+      </p:cxnSp>
+      <p:sp>
+        <p:nvSpPr>
+          <p:cNvPr id="52" name="TextBox 51">
+            <a:extLst>
+              <a:ext uri="{FF2B5EF4-FFF2-40B4-BE49-F238E27FC236}">
+                <a16:creationId xmlns:a16="http://schemas.microsoft.com/office/drawing/2014/main" id="{02191BCA-C04D-123C-4DE6-DA58076E7D4B}"/>
+              </a:ext>
+            </a:extLst>
+          </p:cNvPr>
+          <p:cNvSpPr txBox="1"/>
+          <p:nvPr/>
+        </p:nvSpPr>
+        <p:spPr>
+          <a:xfrm>
+            <a:off x="1987242" y="1678958"/>
+            <a:ext cx="1709240" cy="276999"/>
+          </a:xfrm>
+          <a:prstGeom prst="rect">
+            <a:avLst/>
+          </a:prstGeom>
+          <a:noFill/>
+        </p:spPr>
+        <p:txBody>
+          <a:bodyPr wrap="square" rtlCol="0">
+            <a:spAutoFit/>
+          </a:bodyPr>
+          <a:lstStyle/>
+          <a:p>
+            <a:r>
+              <a:rPr lang="en-US" sz="1200" b="1" dirty="0"/>
+              <a:t>MQTT Data Publish </a:t>
+            </a:r>
+            <a:endParaRPr lang="en-SG" sz="1200" b="1" dirty="0"/>
+          </a:p>
+        </p:txBody>
+      </p:sp>
+      <p:cxnSp>
+        <p:nvCxnSpPr>
+          <p:cNvPr id="54" name="Straight Arrow Connector 53">
+            <a:extLst>
+              <a:ext uri="{FF2B5EF4-FFF2-40B4-BE49-F238E27FC236}">
+                <a16:creationId xmlns:a16="http://schemas.microsoft.com/office/drawing/2014/main" id="{DC38CC57-646C-87DE-DF09-A05C848F1E0C}"/>
+              </a:ext>
+            </a:extLst>
+          </p:cNvPr>
+          <p:cNvCxnSpPr>
+            <a:cxnSpLocks/>
+          </p:cNvCxnSpPr>
+          <p:nvPr/>
+        </p:nvCxnSpPr>
+        <p:spPr>
+          <a:xfrm flipV="1">
+            <a:off x="4588680" y="2127664"/>
+            <a:ext cx="0" cy="268487"/>
+          </a:xfrm>
+          <a:prstGeom prst="straightConnector1">
+            <a:avLst/>
+          </a:prstGeom>
+          <a:ln>
+            <a:tailEnd type="triangle"/>
+          </a:ln>
+        </p:spPr>
+        <p:style>
+          <a:lnRef idx="2">
+            <a:schemeClr val="accent1"/>
+          </a:lnRef>
+          <a:fillRef idx="0">
+            <a:schemeClr val="accent1"/>
+          </a:fillRef>
+          <a:effectRef idx="1">
+            <a:schemeClr val="accent1"/>
+          </a:effectRef>
+          <a:fontRef idx="minor">
+            <a:schemeClr val="tx1"/>
+          </a:fontRef>
+        </p:style>
+      </p:cxnSp>
+      <p:sp>
+        <p:nvSpPr>
+          <p:cNvPr id="57" name="Rectangle 56">
+            <a:extLst>
+              <a:ext uri="{FF2B5EF4-FFF2-40B4-BE49-F238E27FC236}">
+                <a16:creationId xmlns:a16="http://schemas.microsoft.com/office/drawing/2014/main" id="{EF5F7C99-A1F4-DFBB-2EA8-AC4D0A7C945C}"/>
+              </a:ext>
+            </a:extLst>
+          </p:cNvPr>
+          <p:cNvSpPr/>
+          <p:nvPr/>
+        </p:nvSpPr>
+        <p:spPr>
+          <a:xfrm>
+            <a:off x="3915511" y="1813970"/>
+            <a:ext cx="1273135" cy="295727"/>
+          </a:xfrm>
+          <a:prstGeom prst="rect">
+            <a:avLst/>
+          </a:prstGeom>
+          <a:solidFill>
+            <a:schemeClr val="accent6">
+              <a:lumMod val="75000"/>
+            </a:schemeClr>
+          </a:solidFill>
+          <a:ln>
+            <a:solidFill>
+              <a:schemeClr val="tx1"/>
+            </a:solidFill>
+          </a:ln>
+        </p:spPr>
+        <p:style>
+          <a:lnRef idx="2">
+            <a:schemeClr val="accent1">
+              <a:shade val="50000"/>
+            </a:schemeClr>
+          </a:lnRef>
+          <a:fillRef idx="1">
+            <a:schemeClr val="accent1"/>
+          </a:fillRef>
+          <a:effectRef idx="0">
+            <a:schemeClr val="accent1"/>
+          </a:effectRef>
+          <a:fontRef idx="minor">
+            <a:schemeClr val="lt1"/>
+          </a:fontRef>
+        </p:style>
+        <p:txBody>
+          <a:bodyPr rtlCol="0" anchor="ctr"/>
+          <a:lstStyle/>
+          <a:p>
+            <a:pPr algn="ctr"/>
+            <a:r>
+              <a:rPr lang="en-US" sz="1050" b="1" dirty="0"/>
+              <a:t>Data Decryption</a:t>
+            </a:r>
+            <a:endParaRPr lang="en-SG" sz="1050" b="1" dirty="0"/>
+          </a:p>
+        </p:txBody>
+      </p:sp>
+      <p:sp>
+        <p:nvSpPr>
+          <p:cNvPr id="58" name="Cylinder 57">
+            <a:extLst>
+              <a:ext uri="{FF2B5EF4-FFF2-40B4-BE49-F238E27FC236}">
+                <a16:creationId xmlns:a16="http://schemas.microsoft.com/office/drawing/2014/main" id="{F7D5C1B6-1A38-5955-8B5E-FE9266EB678F}"/>
+              </a:ext>
+            </a:extLst>
+          </p:cNvPr>
+          <p:cNvSpPr/>
+          <p:nvPr/>
+        </p:nvSpPr>
+        <p:spPr>
+          <a:xfrm>
+            <a:off x="4911609" y="1199520"/>
+            <a:ext cx="514924" cy="468643"/>
+          </a:xfrm>
+          <a:prstGeom prst="can">
+            <a:avLst/>
+          </a:prstGeom>
+        </p:spPr>
+        <p:style>
+          <a:lnRef idx="2">
+            <a:schemeClr val="accent1">
+              <a:shade val="15000"/>
+            </a:schemeClr>
+          </a:lnRef>
+          <a:fillRef idx="1">
+            <a:schemeClr val="accent1"/>
+          </a:fillRef>
+          <a:effectRef idx="0">
+            <a:schemeClr val="accent1"/>
+          </a:effectRef>
+          <a:fontRef idx="minor">
+            <a:schemeClr val="lt1"/>
+          </a:fontRef>
+        </p:style>
+        <p:txBody>
+          <a:bodyPr rtlCol="0" anchor="ctr"/>
+          <a:lstStyle/>
+          <a:p>
+            <a:pPr algn="ctr"/>
+            <a:r>
+              <a:rPr lang="en-US" sz="1400" dirty="0"/>
+              <a:t>DB1</a:t>
+            </a:r>
+            <a:endParaRPr lang="en-SG" sz="1400" dirty="0"/>
+          </a:p>
+        </p:txBody>
+      </p:sp>
+      <p:sp>
+        <p:nvSpPr>
+          <p:cNvPr id="59" name="TextBox 58">
+            <a:extLst>
+              <a:ext uri="{FF2B5EF4-FFF2-40B4-BE49-F238E27FC236}">
+                <a16:creationId xmlns:a16="http://schemas.microsoft.com/office/drawing/2014/main" id="{97BCEA57-F9C1-9C69-8529-358DFF8F232F}"/>
+              </a:ext>
+            </a:extLst>
+          </p:cNvPr>
+          <p:cNvSpPr txBox="1"/>
+          <p:nvPr/>
+        </p:nvSpPr>
+        <p:spPr>
+          <a:xfrm>
+            <a:off x="3755446" y="682017"/>
+            <a:ext cx="2042140" cy="276999"/>
+          </a:xfrm>
+          <a:prstGeom prst="rect">
+            <a:avLst/>
+          </a:prstGeom>
+          <a:noFill/>
+        </p:spPr>
+        <p:txBody>
+          <a:bodyPr wrap="square" rtlCol="0">
+            <a:spAutoFit/>
+          </a:bodyPr>
+          <a:lstStyle/>
+          <a:p>
+            <a:r>
+              <a:rPr lang="en-US" sz="1200" b="1" dirty="0"/>
+              <a:t>IoT Key and iv Data Base</a:t>
+            </a:r>
+            <a:endParaRPr lang="en-SG" sz="1200" b="1" dirty="0"/>
+          </a:p>
+        </p:txBody>
+      </p:sp>
+      <p:cxnSp>
+        <p:nvCxnSpPr>
+          <p:cNvPr id="65" name="Connector: Elbow 64">
+            <a:extLst>
+              <a:ext uri="{FF2B5EF4-FFF2-40B4-BE49-F238E27FC236}">
+                <a16:creationId xmlns:a16="http://schemas.microsoft.com/office/drawing/2014/main" id="{3CBD85BA-7257-DB47-F830-49C97C8156D3}"/>
+              </a:ext>
+            </a:extLst>
+          </p:cNvPr>
+          <p:cNvCxnSpPr>
+            <a:cxnSpLocks/>
+            <a:stCxn id="58" idx="2"/>
+          </p:cNvCxnSpPr>
+          <p:nvPr/>
+        </p:nvCxnSpPr>
+        <p:spPr>
+          <a:xfrm rot="10800000" flipV="1">
+            <a:off x="4737809" y="1433842"/>
+            <a:ext cx="173801" cy="359844"/>
+          </a:xfrm>
+          <a:prstGeom prst="bentConnector2">
+            <a:avLst/>
+          </a:prstGeom>
+          <a:ln>
+            <a:tailEnd type="triangle"/>
+          </a:ln>
+        </p:spPr>
+        <p:style>
+          <a:lnRef idx="2">
+            <a:schemeClr val="accent1"/>
+          </a:lnRef>
+          <a:fillRef idx="0">
+            <a:schemeClr val="accent1"/>
+          </a:fillRef>
+          <a:effectRef idx="1">
+            <a:schemeClr val="accent1"/>
+          </a:effectRef>
+          <a:fontRef idx="minor">
+            <a:schemeClr val="tx1"/>
+          </a:fontRef>
+        </p:style>
+      </p:cxnSp>
+      <p:sp>
+        <p:nvSpPr>
+          <p:cNvPr id="69" name="Rectangle 68">
+            <a:extLst>
+              <a:ext uri="{FF2B5EF4-FFF2-40B4-BE49-F238E27FC236}">
+                <a16:creationId xmlns:a16="http://schemas.microsoft.com/office/drawing/2014/main" id="{44011946-F610-2EB5-AEDD-46E9D44710FF}"/>
+              </a:ext>
+            </a:extLst>
+          </p:cNvPr>
+          <p:cNvSpPr/>
+          <p:nvPr/>
+        </p:nvSpPr>
+        <p:spPr>
+          <a:xfrm>
+            <a:off x="5407675" y="1813970"/>
+            <a:ext cx="1151442" cy="295727"/>
+          </a:xfrm>
+          <a:prstGeom prst="rect">
+            <a:avLst/>
+          </a:prstGeom>
+          <a:solidFill>
+            <a:schemeClr val="accent6">
+              <a:lumMod val="75000"/>
+            </a:schemeClr>
+          </a:solidFill>
+          <a:ln>
+            <a:solidFill>
+              <a:schemeClr val="tx1"/>
+            </a:solidFill>
+          </a:ln>
+        </p:spPr>
+        <p:style>
+          <a:lnRef idx="2">
+            <a:schemeClr val="accent1">
+              <a:shade val="50000"/>
+            </a:schemeClr>
+          </a:lnRef>
+          <a:fillRef idx="1">
+            <a:schemeClr val="accent1"/>
+          </a:fillRef>
+          <a:effectRef idx="0">
+            <a:schemeClr val="accent1"/>
+          </a:effectRef>
+          <a:fontRef idx="minor">
+            <a:schemeClr val="lt1"/>
+          </a:fontRef>
+        </p:style>
+        <p:txBody>
+          <a:bodyPr rtlCol="0" anchor="ctr"/>
+          <a:lstStyle/>
+          <a:p>
+            <a:pPr algn="ctr"/>
+            <a:r>
+              <a:rPr lang="en-US" sz="1050" b="1" dirty="0"/>
+              <a:t>Data Combine</a:t>
+            </a:r>
+            <a:endParaRPr lang="en-SG" sz="1050" b="1" dirty="0"/>
+          </a:p>
+        </p:txBody>
+      </p:sp>
+      <p:cxnSp>
+        <p:nvCxnSpPr>
+          <p:cNvPr id="70" name="Straight Arrow Connector 69">
+            <a:extLst>
+              <a:ext uri="{FF2B5EF4-FFF2-40B4-BE49-F238E27FC236}">
+                <a16:creationId xmlns:a16="http://schemas.microsoft.com/office/drawing/2014/main" id="{A83E0896-93D4-3C4A-4620-DFC006F3299B}"/>
+              </a:ext>
+            </a:extLst>
+          </p:cNvPr>
+          <p:cNvCxnSpPr>
+            <a:cxnSpLocks/>
+            <a:stCxn id="57" idx="3"/>
+            <a:endCxn id="69" idx="1"/>
+          </p:cNvCxnSpPr>
+          <p:nvPr/>
+        </p:nvCxnSpPr>
+        <p:spPr>
+          <a:xfrm>
+            <a:off x="5188646" y="1961834"/>
+            <a:ext cx="219029" cy="0"/>
+          </a:xfrm>
+          <a:prstGeom prst="straightConnector1">
+            <a:avLst/>
+          </a:prstGeom>
+          <a:ln>
+            <a:tailEnd type="triangle"/>
+          </a:ln>
+        </p:spPr>
+        <p:style>
+          <a:lnRef idx="2">
+            <a:schemeClr val="accent1"/>
+          </a:lnRef>
+          <a:fillRef idx="0">
+            <a:schemeClr val="accent1"/>
+          </a:fillRef>
+          <a:effectRef idx="1">
+            <a:schemeClr val="accent1"/>
+          </a:effectRef>
+          <a:fontRef idx="minor">
+            <a:schemeClr val="tx1"/>
+          </a:fontRef>
+        </p:style>
+      </p:cxnSp>
+      <p:sp>
+        <p:nvSpPr>
+          <p:cNvPr id="74" name="Rectangle 73">
+            <a:extLst>
+              <a:ext uri="{FF2B5EF4-FFF2-40B4-BE49-F238E27FC236}">
+                <a16:creationId xmlns:a16="http://schemas.microsoft.com/office/drawing/2014/main" id="{5A123A3E-3ADF-8760-30CF-CCD3ACEB0409}"/>
+              </a:ext>
+            </a:extLst>
+          </p:cNvPr>
+          <p:cNvSpPr/>
+          <p:nvPr/>
+        </p:nvSpPr>
+        <p:spPr>
+          <a:xfrm>
+            <a:off x="6785819" y="1214870"/>
+            <a:ext cx="1401378" cy="295727"/>
+          </a:xfrm>
+          <a:prstGeom prst="rect">
+            <a:avLst/>
+          </a:prstGeom>
+          <a:solidFill>
+            <a:schemeClr val="bg2">
+              <a:lumMod val="25000"/>
+            </a:schemeClr>
+          </a:solidFill>
+          <a:ln>
+            <a:solidFill>
+              <a:schemeClr val="tx1"/>
+            </a:solidFill>
+          </a:ln>
+        </p:spPr>
+        <p:style>
+          <a:lnRef idx="2">
+            <a:schemeClr val="accent1">
+              <a:shade val="50000"/>
+            </a:schemeClr>
+          </a:lnRef>
+          <a:fillRef idx="1">
+            <a:schemeClr val="accent1"/>
+          </a:fillRef>
+          <a:effectRef idx="0">
+            <a:schemeClr val="accent1"/>
+          </a:effectRef>
+          <a:fontRef idx="minor">
+            <a:schemeClr val="lt1"/>
+          </a:fontRef>
+        </p:style>
+        <p:txBody>
+          <a:bodyPr rtlCol="0" anchor="ctr"/>
+          <a:lstStyle/>
+          <a:p>
+            <a:pPr algn="ctr"/>
+            <a:r>
+              <a:rPr lang="en-US" sz="1050" b="1" dirty="0" err="1"/>
+              <a:t>AES_Key</a:t>
+            </a:r>
+            <a:r>
+              <a:rPr lang="en-US" sz="1050" b="1" dirty="0"/>
+              <a:t> + </a:t>
+            </a:r>
+            <a:r>
+              <a:rPr lang="en-US" sz="1050" b="1" dirty="0" err="1"/>
+              <a:t>IoT_iv</a:t>
+            </a:r>
+            <a:endParaRPr lang="en-SG" sz="1050" b="1" dirty="0"/>
+          </a:p>
+        </p:txBody>
+      </p:sp>
+      <p:sp>
+        <p:nvSpPr>
+          <p:cNvPr id="75" name="Rectangle 74">
+            <a:extLst>
+              <a:ext uri="{FF2B5EF4-FFF2-40B4-BE49-F238E27FC236}">
+                <a16:creationId xmlns:a16="http://schemas.microsoft.com/office/drawing/2014/main" id="{6EFEEAF9-6F0F-4C55-4336-48558A5F85D3}"/>
+              </a:ext>
+            </a:extLst>
+          </p:cNvPr>
+          <p:cNvSpPr/>
+          <p:nvPr/>
+        </p:nvSpPr>
+        <p:spPr>
+          <a:xfrm>
+            <a:off x="6778146" y="1666106"/>
+            <a:ext cx="1416724" cy="295727"/>
+          </a:xfrm>
+          <a:prstGeom prst="rect">
+            <a:avLst/>
+          </a:prstGeom>
+          <a:solidFill>
+            <a:schemeClr val="accent6">
+              <a:lumMod val="75000"/>
+            </a:schemeClr>
+          </a:solidFill>
+          <a:ln>
+            <a:solidFill>
+              <a:schemeClr val="tx1"/>
+            </a:solidFill>
+          </a:ln>
+        </p:spPr>
+        <p:style>
+          <a:lnRef idx="2">
+            <a:schemeClr val="accent1">
+              <a:shade val="50000"/>
+            </a:schemeClr>
+          </a:lnRef>
+          <a:fillRef idx="1">
+            <a:schemeClr val="accent1"/>
+          </a:fillRef>
+          <a:effectRef idx="0">
+            <a:schemeClr val="accent1"/>
+          </a:effectRef>
+          <a:fontRef idx="minor">
+            <a:schemeClr val="lt1"/>
+          </a:fontRef>
+        </p:style>
+        <p:txBody>
+          <a:bodyPr rtlCol="0" anchor="ctr"/>
+          <a:lstStyle/>
+          <a:p>
+            <a:pPr algn="ctr"/>
+            <a:r>
+              <a:rPr lang="en-US" sz="1050" b="1" dirty="0"/>
+              <a:t>2</a:t>
+            </a:r>
+            <a:r>
+              <a:rPr lang="en-US" sz="1050" b="1" baseline="30000" dirty="0"/>
+              <a:t>nd</a:t>
+            </a:r>
+            <a:r>
+              <a:rPr lang="en-US" sz="1050" b="1" dirty="0"/>
+              <a:t> Data Encryption</a:t>
+            </a:r>
+            <a:endParaRPr lang="en-SG" sz="1050" b="1" dirty="0"/>
+          </a:p>
+        </p:txBody>
+      </p:sp>
+      <p:sp>
+        <p:nvSpPr>
+          <p:cNvPr id="76" name="Rectangle 75">
+            <a:extLst>
+              <a:ext uri="{FF2B5EF4-FFF2-40B4-BE49-F238E27FC236}">
+                <a16:creationId xmlns:a16="http://schemas.microsoft.com/office/drawing/2014/main" id="{235D5481-FD18-96BC-52A5-B63A929019F9}"/>
+              </a:ext>
+            </a:extLst>
+          </p:cNvPr>
+          <p:cNvSpPr/>
+          <p:nvPr/>
+        </p:nvSpPr>
+        <p:spPr>
+          <a:xfrm>
+            <a:off x="6785819" y="2104270"/>
+            <a:ext cx="1494965" cy="295727"/>
+          </a:xfrm>
+          <a:prstGeom prst="rect">
+            <a:avLst/>
+          </a:prstGeom>
+          <a:solidFill>
+            <a:schemeClr val="accent6">
+              <a:lumMod val="75000"/>
+            </a:schemeClr>
+          </a:solidFill>
+          <a:ln>
+            <a:solidFill>
+              <a:schemeClr val="tx1"/>
+            </a:solidFill>
+          </a:ln>
+        </p:spPr>
+        <p:style>
+          <a:lnRef idx="2">
+            <a:schemeClr val="accent1">
+              <a:shade val="50000"/>
+            </a:schemeClr>
+          </a:lnRef>
+          <a:fillRef idx="1">
+            <a:schemeClr val="accent1"/>
+          </a:fillRef>
+          <a:effectRef idx="0">
+            <a:schemeClr val="accent1"/>
+          </a:effectRef>
+          <a:fontRef idx="minor">
+            <a:schemeClr val="lt1"/>
+          </a:fontRef>
+        </p:style>
+        <p:txBody>
+          <a:bodyPr rtlCol="0" anchor="ctr"/>
+          <a:lstStyle/>
+          <a:p>
+            <a:pPr algn="ctr"/>
+            <a:r>
+              <a:rPr lang="en-US" sz="1050" b="1" dirty="0"/>
+              <a:t>MQTT Data Structure</a:t>
+            </a:r>
+            <a:endParaRPr lang="en-SG" sz="1050" b="1" dirty="0"/>
+          </a:p>
+        </p:txBody>
+      </p:sp>
+      <p:cxnSp>
+        <p:nvCxnSpPr>
+          <p:cNvPr id="78" name="Connector: Elbow 77">
+            <a:extLst>
+              <a:ext uri="{FF2B5EF4-FFF2-40B4-BE49-F238E27FC236}">
+                <a16:creationId xmlns:a16="http://schemas.microsoft.com/office/drawing/2014/main" id="{3E67243B-49B6-697C-70AD-11961F66227E}"/>
+              </a:ext>
+            </a:extLst>
+          </p:cNvPr>
+          <p:cNvCxnSpPr>
+            <a:stCxn id="69" idx="3"/>
+            <a:endCxn id="75" idx="1"/>
+          </p:cNvCxnSpPr>
+          <p:nvPr/>
+        </p:nvCxnSpPr>
+        <p:spPr>
+          <a:xfrm flipV="1">
+            <a:off x="6559117" y="1813970"/>
+            <a:ext cx="219029" cy="147864"/>
+          </a:xfrm>
+          <a:prstGeom prst="bentConnector3">
+            <a:avLst/>
+          </a:prstGeom>
+          <a:ln>
+            <a:tailEnd type="triangle"/>
+          </a:ln>
+        </p:spPr>
+        <p:style>
+          <a:lnRef idx="2">
+            <a:schemeClr val="accent1"/>
+          </a:lnRef>
+          <a:fillRef idx="0">
+            <a:schemeClr val="accent1"/>
+          </a:fillRef>
+          <a:effectRef idx="1">
+            <a:schemeClr val="accent1"/>
+          </a:effectRef>
+          <a:fontRef idx="minor">
+            <a:schemeClr val="tx1"/>
+          </a:fontRef>
+        </p:style>
+      </p:cxnSp>
+      <p:cxnSp>
+        <p:nvCxnSpPr>
+          <p:cNvPr id="79" name="Straight Arrow Connector 78">
+            <a:extLst>
+              <a:ext uri="{FF2B5EF4-FFF2-40B4-BE49-F238E27FC236}">
+                <a16:creationId xmlns:a16="http://schemas.microsoft.com/office/drawing/2014/main" id="{D4D842D9-15B2-5453-2729-B486D5B10051}"/>
+              </a:ext>
+            </a:extLst>
+          </p:cNvPr>
+          <p:cNvCxnSpPr>
+            <a:cxnSpLocks/>
+            <a:stCxn id="74" idx="2"/>
+            <a:endCxn id="75" idx="0"/>
+          </p:cNvCxnSpPr>
+          <p:nvPr/>
+        </p:nvCxnSpPr>
+        <p:spPr>
+          <a:xfrm>
+            <a:off x="7486508" y="1510597"/>
+            <a:ext cx="0" cy="155509"/>
+          </a:xfrm>
+          <a:prstGeom prst="straightConnector1">
+            <a:avLst/>
+          </a:prstGeom>
+          <a:ln>
+            <a:tailEnd type="triangle"/>
+          </a:ln>
+        </p:spPr>
+        <p:style>
+          <a:lnRef idx="2">
+            <a:schemeClr val="accent1"/>
+          </a:lnRef>
+          <a:fillRef idx="0">
+            <a:schemeClr val="accent1"/>
+          </a:fillRef>
+          <a:effectRef idx="1">
+            <a:schemeClr val="accent1"/>
+          </a:effectRef>
+          <a:fontRef idx="minor">
+            <a:schemeClr val="tx1"/>
+          </a:fontRef>
+        </p:style>
+      </p:cxnSp>
+      <p:cxnSp>
+        <p:nvCxnSpPr>
+          <p:cNvPr id="83" name="Straight Arrow Connector 82">
+            <a:extLst>
+              <a:ext uri="{FF2B5EF4-FFF2-40B4-BE49-F238E27FC236}">
+                <a16:creationId xmlns:a16="http://schemas.microsoft.com/office/drawing/2014/main" id="{1636B286-0A55-56CE-4EB6-0E45011F4857}"/>
+              </a:ext>
+            </a:extLst>
+          </p:cNvPr>
+          <p:cNvCxnSpPr>
+            <a:cxnSpLocks/>
+          </p:cNvCxnSpPr>
+          <p:nvPr/>
+        </p:nvCxnSpPr>
+        <p:spPr>
+          <a:xfrm>
+            <a:off x="7480289" y="1972155"/>
+            <a:ext cx="0" cy="155509"/>
+          </a:xfrm>
+          <a:prstGeom prst="straightConnector1">
+            <a:avLst/>
+          </a:prstGeom>
+          <a:ln>
+            <a:tailEnd type="triangle"/>
+          </a:ln>
+        </p:spPr>
+        <p:style>
+          <a:lnRef idx="2">
+            <a:schemeClr val="accent1"/>
+          </a:lnRef>
+          <a:fillRef idx="0">
+            <a:schemeClr val="accent1"/>
+          </a:fillRef>
+          <a:effectRef idx="1">
+            <a:schemeClr val="accent1"/>
+          </a:effectRef>
+          <a:fontRef idx="minor">
+            <a:schemeClr val="tx1"/>
+          </a:fontRef>
+        </p:style>
+      </p:cxnSp>
+      <p:cxnSp>
+        <p:nvCxnSpPr>
+          <p:cNvPr id="84" name="Connector: Elbow 83">
+            <a:extLst>
+              <a:ext uri="{FF2B5EF4-FFF2-40B4-BE49-F238E27FC236}">
+                <a16:creationId xmlns:a16="http://schemas.microsoft.com/office/drawing/2014/main" id="{9CC74832-AF04-7038-D533-6C88417B9C54}"/>
+              </a:ext>
+            </a:extLst>
+          </p:cNvPr>
+          <p:cNvCxnSpPr>
+            <a:cxnSpLocks/>
+            <a:stCxn id="76" idx="1"/>
+            <a:endCxn id="46" idx="0"/>
+          </p:cNvCxnSpPr>
+          <p:nvPr/>
+        </p:nvCxnSpPr>
+        <p:spPr>
+          <a:xfrm rot="10800000" flipV="1">
+            <a:off x="5031569" y="2252133"/>
+            <a:ext cx="1754251" cy="144017"/>
+          </a:xfrm>
+          <a:prstGeom prst="bentConnector2">
+            <a:avLst/>
+          </a:prstGeom>
+          <a:ln>
+            <a:tailEnd type="triangle"/>
+          </a:ln>
+        </p:spPr>
+        <p:style>
+          <a:lnRef idx="2">
+            <a:schemeClr val="accent1"/>
+          </a:lnRef>
+          <a:fillRef idx="0">
+            <a:schemeClr val="accent1"/>
+          </a:fillRef>
+          <a:effectRef idx="1">
+            <a:schemeClr val="accent1"/>
+          </a:effectRef>
+          <a:fontRef idx="minor">
+            <a:schemeClr val="tx1"/>
+          </a:fontRef>
+        </p:style>
+      </p:cxnSp>
+      <p:sp>
+        <p:nvSpPr>
+          <p:cNvPr id="4" name="Cloud 3">
+            <a:extLst>
+              <a:ext uri="{FF2B5EF4-FFF2-40B4-BE49-F238E27FC236}">
+                <a16:creationId xmlns:a16="http://schemas.microsoft.com/office/drawing/2014/main" id="{64F04FDE-92F1-F4F0-4C57-CCC7A8F9B973}"/>
+              </a:ext>
+            </a:extLst>
+          </p:cNvPr>
+          <p:cNvSpPr/>
+          <p:nvPr/>
+        </p:nvSpPr>
+        <p:spPr>
+          <a:xfrm>
+            <a:off x="8644452" y="1948466"/>
+            <a:ext cx="1185569" cy="732464"/>
+          </a:xfrm>
+          <a:prstGeom prst="cloud">
+            <a:avLst/>
+          </a:prstGeom>
+        </p:spPr>
+        <p:style>
+          <a:lnRef idx="2">
+            <a:schemeClr val="accent1">
+              <a:shade val="15000"/>
+            </a:schemeClr>
+          </a:lnRef>
+          <a:fillRef idx="1">
+            <a:schemeClr val="accent1"/>
+          </a:fillRef>
+          <a:effectRef idx="0">
+            <a:schemeClr val="accent1"/>
+          </a:effectRef>
+          <a:fontRef idx="minor">
+            <a:schemeClr val="lt1"/>
+          </a:fontRef>
+        </p:style>
+        <p:txBody>
+          <a:bodyPr rtlCol="0" anchor="ctr"/>
+          <a:lstStyle/>
+          <a:p>
+            <a:pPr algn="ctr"/>
+            <a:r>
+              <a:rPr lang="en-US" sz="1100" b="1" dirty="0"/>
+              <a:t>5G Network</a:t>
+            </a:r>
+            <a:endParaRPr lang="en-SG" sz="1100" b="1" dirty="0"/>
+          </a:p>
+        </p:txBody>
+      </p:sp>
+      <p:sp>
+        <p:nvSpPr>
+          <p:cNvPr id="6" name="Rectangle 5">
+            <a:extLst>
+              <a:ext uri="{FF2B5EF4-FFF2-40B4-BE49-F238E27FC236}">
+                <a16:creationId xmlns:a16="http://schemas.microsoft.com/office/drawing/2014/main" id="{CC96FA81-4C9F-AC0C-B978-498855791389}"/>
+              </a:ext>
+            </a:extLst>
+          </p:cNvPr>
+          <p:cNvSpPr/>
+          <p:nvPr/>
+        </p:nvSpPr>
+        <p:spPr>
+          <a:xfrm>
+            <a:off x="9901873" y="1072033"/>
+            <a:ext cx="1468250" cy="1767848"/>
+          </a:xfrm>
+          <a:prstGeom prst="rect">
+            <a:avLst/>
+          </a:prstGeom>
+          <a:solidFill>
+            <a:schemeClr val="accent2">
+              <a:lumMod val="20000"/>
+              <a:lumOff val="80000"/>
+            </a:schemeClr>
+          </a:solidFill>
+        </p:spPr>
+        <p:style>
+          <a:lnRef idx="2">
+            <a:schemeClr val="accent1">
+              <a:shade val="15000"/>
+            </a:schemeClr>
+          </a:lnRef>
+          <a:fillRef idx="1">
+            <a:schemeClr val="accent1"/>
+          </a:fillRef>
+          <a:effectRef idx="0">
+            <a:schemeClr val="accent1"/>
+          </a:effectRef>
+          <a:fontRef idx="minor">
+            <a:schemeClr val="lt1"/>
+          </a:fontRef>
+        </p:style>
+        <p:txBody>
+          <a:bodyPr rtlCol="0" anchor="ctr"/>
+          <a:lstStyle/>
+          <a:p>
+            <a:pPr algn="ctr"/>
+            <a:endParaRPr lang="en-SG" dirty="0"/>
+          </a:p>
+        </p:txBody>
+      </p:sp>
+      <p:sp>
+        <p:nvSpPr>
+          <p:cNvPr id="8" name="Rectangle 7">
+            <a:extLst>
+              <a:ext uri="{FF2B5EF4-FFF2-40B4-BE49-F238E27FC236}">
+                <a16:creationId xmlns:a16="http://schemas.microsoft.com/office/drawing/2014/main" id="{E6B5C939-79BB-1F0A-D825-69A1876AE264}"/>
+              </a:ext>
+            </a:extLst>
+          </p:cNvPr>
+          <p:cNvSpPr/>
+          <p:nvPr/>
+        </p:nvSpPr>
+        <p:spPr>
+          <a:xfrm>
+            <a:off x="10150165" y="2324141"/>
+            <a:ext cx="1025540" cy="340962"/>
+          </a:xfrm>
+          <a:prstGeom prst="rect">
+            <a:avLst/>
+          </a:prstGeom>
+          <a:solidFill>
+            <a:schemeClr val="accent2"/>
+          </a:solidFill>
+        </p:spPr>
+        <p:style>
+          <a:lnRef idx="2">
+            <a:schemeClr val="accent1">
+              <a:shade val="50000"/>
+            </a:schemeClr>
+          </a:lnRef>
+          <a:fillRef idx="1">
+            <a:schemeClr val="accent1"/>
+          </a:fillRef>
+          <a:effectRef idx="0">
+            <a:schemeClr val="accent1"/>
+          </a:effectRef>
+          <a:fontRef idx="minor">
+            <a:schemeClr val="lt1"/>
+          </a:fontRef>
+        </p:style>
+        <p:txBody>
+          <a:bodyPr rtlCol="0" anchor="ctr"/>
+          <a:lstStyle/>
+          <a:p>
+            <a:r>
+              <a:rPr lang="en-SG" sz="1050" b="1" dirty="0"/>
+              <a:t>MQTT Client</a:t>
+            </a:r>
+          </a:p>
+        </p:txBody>
+      </p:sp>
+      <p:cxnSp>
+        <p:nvCxnSpPr>
+          <p:cNvPr id="91" name="Straight Arrow Connector 90">
+            <a:extLst>
+              <a:ext uri="{FF2B5EF4-FFF2-40B4-BE49-F238E27FC236}">
+                <a16:creationId xmlns:a16="http://schemas.microsoft.com/office/drawing/2014/main" id="{0F019580-ACE8-A02D-5E2F-A71BCC00F30E}"/>
+              </a:ext>
+            </a:extLst>
+          </p:cNvPr>
+          <p:cNvCxnSpPr>
+            <a:cxnSpLocks/>
+          </p:cNvCxnSpPr>
+          <p:nvPr/>
+        </p:nvCxnSpPr>
+        <p:spPr>
+          <a:xfrm>
+            <a:off x="5562788" y="2541956"/>
+            <a:ext cx="4550476" cy="0"/>
+          </a:xfrm>
+          <a:prstGeom prst="straightConnector1">
+            <a:avLst/>
+          </a:prstGeom>
+          <a:ln>
+            <a:tailEnd type="triangle"/>
+          </a:ln>
+        </p:spPr>
+        <p:style>
+          <a:lnRef idx="2">
+            <a:schemeClr val="accent1"/>
+          </a:lnRef>
+          <a:fillRef idx="0">
+            <a:schemeClr val="accent1"/>
+          </a:fillRef>
+          <a:effectRef idx="1">
+            <a:schemeClr val="accent1"/>
+          </a:effectRef>
+          <a:fontRef idx="minor">
+            <a:schemeClr val="tx1"/>
+          </a:fontRef>
+        </p:style>
+      </p:cxnSp>
+      <p:sp>
+        <p:nvSpPr>
+          <p:cNvPr id="9" name="TextBox 8">
+            <a:extLst>
+              <a:ext uri="{FF2B5EF4-FFF2-40B4-BE49-F238E27FC236}">
+                <a16:creationId xmlns:a16="http://schemas.microsoft.com/office/drawing/2014/main" id="{A136A87C-07EF-5D97-CA3E-A9139E064498}"/>
+              </a:ext>
+            </a:extLst>
+          </p:cNvPr>
+          <p:cNvSpPr txBox="1"/>
+          <p:nvPr/>
+        </p:nvSpPr>
+        <p:spPr>
+          <a:xfrm>
+            <a:off x="9941826" y="1126686"/>
+            <a:ext cx="1151442" cy="461665"/>
+          </a:xfrm>
+          <a:prstGeom prst="rect">
+            <a:avLst/>
+          </a:prstGeom>
+          <a:noFill/>
+        </p:spPr>
+        <p:txBody>
+          <a:bodyPr wrap="square" rtlCol="0">
+            <a:spAutoFit/>
+          </a:bodyPr>
+          <a:lstStyle/>
+          <a:p>
+            <a:r>
+              <a:rPr lang="en-US" sz="1200" b="1" dirty="0"/>
+              <a:t>Power Grid OCC HMI </a:t>
+            </a:r>
+            <a:endParaRPr lang="en-SG" sz="1200" b="1" dirty="0"/>
+          </a:p>
+        </p:txBody>
+      </p:sp>
+      <p:sp>
+        <p:nvSpPr>
+          <p:cNvPr id="10" name="Rectangle 9">
+            <a:extLst>
+              <a:ext uri="{FF2B5EF4-FFF2-40B4-BE49-F238E27FC236}">
+                <a16:creationId xmlns:a16="http://schemas.microsoft.com/office/drawing/2014/main" id="{BE735ABF-94A9-94CA-BAEC-5D8310700E19}"/>
+              </a:ext>
+            </a:extLst>
+          </p:cNvPr>
+          <p:cNvSpPr/>
+          <p:nvPr/>
+        </p:nvSpPr>
+        <p:spPr>
+          <a:xfrm>
+            <a:off x="3347282" y="3321535"/>
+            <a:ext cx="1025540" cy="340962"/>
+          </a:xfrm>
+          <a:prstGeom prst="rect">
+            <a:avLst/>
+          </a:prstGeom>
+          <a:solidFill>
+            <a:schemeClr val="accent2"/>
+          </a:solidFill>
+        </p:spPr>
+        <p:style>
+          <a:lnRef idx="2">
+            <a:schemeClr val="accent1">
+              <a:shade val="50000"/>
+            </a:schemeClr>
+          </a:lnRef>
+          <a:fillRef idx="1">
+            <a:schemeClr val="accent1"/>
+          </a:fillRef>
+          <a:effectRef idx="0">
+            <a:schemeClr val="accent1"/>
+          </a:effectRef>
+          <a:fontRef idx="minor">
+            <a:schemeClr val="lt1"/>
+          </a:fontRef>
+        </p:style>
+        <p:txBody>
+          <a:bodyPr rtlCol="0" anchor="ctr"/>
+          <a:lstStyle/>
+          <a:p>
+            <a:r>
+              <a:rPr lang="en-SG" sz="1050" b="1" dirty="0"/>
+              <a:t>MQTT Client</a:t>
+            </a:r>
+          </a:p>
+        </p:txBody>
+      </p:sp>
+      <p:cxnSp>
+        <p:nvCxnSpPr>
+          <p:cNvPr id="12" name="Connector: Elbow 11">
+            <a:extLst>
+              <a:ext uri="{FF2B5EF4-FFF2-40B4-BE49-F238E27FC236}">
+                <a16:creationId xmlns:a16="http://schemas.microsoft.com/office/drawing/2014/main" id="{AD1012A0-9E48-4361-04DA-A0BACE10335E}"/>
+              </a:ext>
+            </a:extLst>
+          </p:cNvPr>
+          <p:cNvCxnSpPr>
+            <a:cxnSpLocks/>
+            <a:stCxn id="10" idx="1"/>
+          </p:cNvCxnSpPr>
+          <p:nvPr/>
+        </p:nvCxnSpPr>
+        <p:spPr>
+          <a:xfrm rot="10800000" flipH="1">
+            <a:off x="3347281" y="2686854"/>
+            <a:ext cx="1139129" cy="805162"/>
+          </a:xfrm>
+          <a:prstGeom prst="bentConnector3">
+            <a:avLst>
+              <a:gd name="adj1" fmla="val -85088"/>
+            </a:avLst>
+          </a:prstGeom>
+          <a:ln>
+            <a:tailEnd type="triangle"/>
+          </a:ln>
+        </p:spPr>
+        <p:style>
+          <a:lnRef idx="2">
+            <a:schemeClr val="accent1"/>
+          </a:lnRef>
+          <a:fillRef idx="0">
+            <a:schemeClr val="accent1"/>
+          </a:fillRef>
+          <a:effectRef idx="1">
+            <a:schemeClr val="accent1"/>
+          </a:effectRef>
+          <a:fontRef idx="minor">
+            <a:schemeClr val="tx1"/>
+          </a:fontRef>
+        </p:style>
+      </p:cxnSp>
+      <p:sp>
+        <p:nvSpPr>
+          <p:cNvPr id="16" name="TextBox 15">
+            <a:extLst>
+              <a:ext uri="{FF2B5EF4-FFF2-40B4-BE49-F238E27FC236}">
+                <a16:creationId xmlns:a16="http://schemas.microsoft.com/office/drawing/2014/main" id="{40CA6291-0FB1-11CA-3D0E-7CABD0D8974D}"/>
+              </a:ext>
+            </a:extLst>
+          </p:cNvPr>
+          <p:cNvSpPr txBox="1"/>
+          <p:nvPr/>
+        </p:nvSpPr>
+        <p:spPr>
+          <a:xfrm>
+            <a:off x="3968493" y="2898708"/>
+            <a:ext cx="1616046" cy="276999"/>
+          </a:xfrm>
+          <a:prstGeom prst="rect">
+            <a:avLst/>
+          </a:prstGeom>
+          <a:noFill/>
+        </p:spPr>
+        <p:txBody>
+          <a:bodyPr wrap="square" rtlCol="0">
+            <a:spAutoFit/>
+          </a:bodyPr>
+          <a:lstStyle/>
+          <a:p>
+            <a:r>
+              <a:rPr lang="en-US" sz="1200" b="1" dirty="0"/>
+              <a:t>Local Monitor HMI </a:t>
+            </a:r>
+            <a:endParaRPr lang="en-SG" sz="1200" b="1" dirty="0"/>
+          </a:p>
+        </p:txBody>
+      </p:sp>
+      <p:cxnSp>
+        <p:nvCxnSpPr>
+          <p:cNvPr id="7" name="Straight Arrow Connector 6">
+            <a:extLst>
+              <a:ext uri="{FF2B5EF4-FFF2-40B4-BE49-F238E27FC236}">
+                <a16:creationId xmlns:a16="http://schemas.microsoft.com/office/drawing/2014/main" id="{6DF825B6-D809-D973-5A66-6E264E34D93D}"/>
+              </a:ext>
+            </a:extLst>
+          </p:cNvPr>
+          <p:cNvCxnSpPr>
+            <a:cxnSpLocks/>
+          </p:cNvCxnSpPr>
+          <p:nvPr/>
+        </p:nvCxnSpPr>
+        <p:spPr>
+          <a:xfrm>
+            <a:off x="5161773" y="921299"/>
+            <a:ext cx="0" cy="256193"/>
+          </a:xfrm>
+          <a:prstGeom prst="straightConnector1">
+            <a:avLst/>
+          </a:prstGeom>
+          <a:ln>
+            <a:tailEnd type="triangle"/>
+          </a:ln>
+        </p:spPr>
+        <p:style>
+          <a:lnRef idx="2">
+            <a:schemeClr val="dk1"/>
+          </a:lnRef>
+          <a:fillRef idx="0">
+            <a:schemeClr val="dk1"/>
+          </a:fillRef>
+          <a:effectRef idx="1">
+            <a:schemeClr val="dk1"/>
+          </a:effectRef>
+          <a:fontRef idx="minor">
+            <a:schemeClr val="tx1"/>
+          </a:fontRef>
+        </p:style>
+      </p:cxnSp>
+      <p:sp>
+        <p:nvSpPr>
+          <p:cNvPr id="13" name="Cylinder 12">
+            <a:extLst>
+              <a:ext uri="{FF2B5EF4-FFF2-40B4-BE49-F238E27FC236}">
+                <a16:creationId xmlns:a16="http://schemas.microsoft.com/office/drawing/2014/main" id="{35835D16-5A69-8542-06D4-08D7AFD6F184}"/>
+              </a:ext>
+            </a:extLst>
+          </p:cNvPr>
+          <p:cNvSpPr/>
+          <p:nvPr/>
+        </p:nvSpPr>
+        <p:spPr>
+          <a:xfrm>
+            <a:off x="5798059" y="1177492"/>
+            <a:ext cx="514924" cy="468643"/>
+          </a:xfrm>
+          <a:prstGeom prst="can">
+            <a:avLst>
+              <a:gd name="adj" fmla="val 38773"/>
+            </a:avLst>
+          </a:prstGeom>
+        </p:spPr>
+        <p:style>
+          <a:lnRef idx="2">
+            <a:schemeClr val="accent1">
+              <a:shade val="15000"/>
+            </a:schemeClr>
+          </a:lnRef>
+          <a:fillRef idx="1">
+            <a:schemeClr val="accent1"/>
+          </a:fillRef>
+          <a:effectRef idx="0">
+            <a:schemeClr val="accent1"/>
+          </a:effectRef>
+          <a:fontRef idx="minor">
+            <a:schemeClr val="lt1"/>
+          </a:fontRef>
+        </p:style>
+        <p:txBody>
+          <a:bodyPr rtlCol="0" anchor="ctr"/>
+          <a:lstStyle/>
+          <a:p>
+            <a:pPr algn="ctr"/>
+            <a:r>
+              <a:rPr lang="en-US" sz="1400" dirty="0"/>
+              <a:t>DB2</a:t>
+            </a:r>
+            <a:endParaRPr lang="en-SG" sz="1400" dirty="0"/>
+          </a:p>
+        </p:txBody>
+      </p:sp>
+      <p:cxnSp>
+        <p:nvCxnSpPr>
+          <p:cNvPr id="15" name="Straight Arrow Connector 14">
+            <a:extLst>
+              <a:ext uri="{FF2B5EF4-FFF2-40B4-BE49-F238E27FC236}">
+                <a16:creationId xmlns:a16="http://schemas.microsoft.com/office/drawing/2014/main" id="{D7B6FCD6-1773-3B83-C532-E038E1A3353C}"/>
+              </a:ext>
+            </a:extLst>
+          </p:cNvPr>
+          <p:cNvCxnSpPr>
+            <a:cxnSpLocks/>
+            <a:stCxn id="69" idx="0"/>
+          </p:cNvCxnSpPr>
+          <p:nvPr/>
+        </p:nvCxnSpPr>
+        <p:spPr>
+          <a:xfrm flipV="1">
+            <a:off x="5983396" y="1644695"/>
+            <a:ext cx="0" cy="169275"/>
+          </a:xfrm>
+          <a:prstGeom prst="straightConnector1">
+            <a:avLst/>
+          </a:prstGeom>
+          <a:ln>
+            <a:tailEnd type="triangle"/>
+          </a:ln>
+        </p:spPr>
+        <p:style>
+          <a:lnRef idx="2">
+            <a:schemeClr val="accent1"/>
+          </a:lnRef>
+          <a:fillRef idx="0">
+            <a:schemeClr val="accent1"/>
+          </a:fillRef>
+          <a:effectRef idx="1">
+            <a:schemeClr val="accent1"/>
+          </a:effectRef>
+          <a:fontRef idx="minor">
+            <a:schemeClr val="tx1"/>
+          </a:fontRef>
+        </p:style>
+      </p:cxnSp>
+      <p:cxnSp>
+        <p:nvCxnSpPr>
+          <p:cNvPr id="20" name="Straight Arrow Connector 19">
+            <a:extLst>
+              <a:ext uri="{FF2B5EF4-FFF2-40B4-BE49-F238E27FC236}">
+                <a16:creationId xmlns:a16="http://schemas.microsoft.com/office/drawing/2014/main" id="{AB5F39E7-20B6-E049-FDC7-B2583DDE364A}"/>
+              </a:ext>
+            </a:extLst>
+          </p:cNvPr>
+          <p:cNvCxnSpPr>
+            <a:cxnSpLocks/>
+          </p:cNvCxnSpPr>
+          <p:nvPr/>
+        </p:nvCxnSpPr>
+        <p:spPr>
+          <a:xfrm>
+            <a:off x="6096000" y="942675"/>
+            <a:ext cx="0" cy="211249"/>
+          </a:xfrm>
+          <a:prstGeom prst="straightConnector1">
+            <a:avLst/>
+          </a:prstGeom>
+          <a:ln>
+            <a:tailEnd type="triangle"/>
+          </a:ln>
+        </p:spPr>
+        <p:style>
+          <a:lnRef idx="2">
+            <a:schemeClr val="dk1"/>
+          </a:lnRef>
+          <a:fillRef idx="0">
+            <a:schemeClr val="dk1"/>
+          </a:fillRef>
+          <a:effectRef idx="1">
+            <a:schemeClr val="dk1"/>
+          </a:effectRef>
+          <a:fontRef idx="minor">
+            <a:schemeClr val="tx1"/>
+          </a:fontRef>
+        </p:style>
+      </p:cxnSp>
+      <p:sp>
+        <p:nvSpPr>
+          <p:cNvPr id="21" name="TextBox 20">
+            <a:extLst>
+              <a:ext uri="{FF2B5EF4-FFF2-40B4-BE49-F238E27FC236}">
+                <a16:creationId xmlns:a16="http://schemas.microsoft.com/office/drawing/2014/main" id="{E02F1C5F-7A9C-D848-0FFB-905FAE72D37D}"/>
+              </a:ext>
+            </a:extLst>
+          </p:cNvPr>
+          <p:cNvSpPr txBox="1"/>
+          <p:nvPr/>
+        </p:nvSpPr>
+        <p:spPr>
+          <a:xfrm>
+            <a:off x="5936727" y="673114"/>
+            <a:ext cx="2707725" cy="276999"/>
+          </a:xfrm>
+          <a:prstGeom prst="rect">
+            <a:avLst/>
+          </a:prstGeom>
+          <a:noFill/>
+        </p:spPr>
+        <p:txBody>
+          <a:bodyPr wrap="square" rtlCol="0">
+            <a:spAutoFit/>
+          </a:bodyPr>
+          <a:lstStyle/>
+          <a:p>
+            <a:r>
+              <a:rPr lang="en-US" sz="1200" b="1" dirty="0"/>
+              <a:t>Local Historian Archive Data Base </a:t>
+            </a:r>
+            <a:endParaRPr lang="en-SG" sz="1200" b="1" dirty="0"/>
+          </a:p>
+        </p:txBody>
+      </p:sp>
+      <p:sp>
+        <p:nvSpPr>
+          <p:cNvPr id="25" name="Rectangle 24">
+            <a:extLst>
+              <a:ext uri="{FF2B5EF4-FFF2-40B4-BE49-F238E27FC236}">
+                <a16:creationId xmlns:a16="http://schemas.microsoft.com/office/drawing/2014/main" id="{99B18E4D-2AE3-FE65-78A4-B19FD724CAFF}"/>
+              </a:ext>
+            </a:extLst>
+          </p:cNvPr>
+          <p:cNvSpPr/>
+          <p:nvPr/>
+        </p:nvSpPr>
+        <p:spPr>
+          <a:xfrm>
+            <a:off x="383120" y="3237842"/>
+            <a:ext cx="1430530" cy="961446"/>
+          </a:xfrm>
+          <a:prstGeom prst="rect">
+            <a:avLst/>
+          </a:prstGeom>
+          <a:solidFill>
+            <a:schemeClr val="accent1">
+              <a:lumMod val="20000"/>
+              <a:lumOff val="80000"/>
+            </a:schemeClr>
+          </a:solidFill>
+        </p:spPr>
+        <p:style>
+          <a:lnRef idx="2">
+            <a:schemeClr val="accent1">
+              <a:shade val="15000"/>
+            </a:schemeClr>
+          </a:lnRef>
+          <a:fillRef idx="1">
+            <a:schemeClr val="accent1"/>
+          </a:fillRef>
+          <a:effectRef idx="0">
+            <a:schemeClr val="accent1"/>
+          </a:effectRef>
+          <a:fontRef idx="minor">
+            <a:schemeClr val="lt1"/>
+          </a:fontRef>
+        </p:style>
+        <p:txBody>
+          <a:bodyPr rtlCol="0" anchor="ctr"/>
+          <a:lstStyle/>
+          <a:p>
+            <a:pPr algn="ctr"/>
+            <a:endParaRPr lang="en-SG" dirty="0"/>
+          </a:p>
+        </p:txBody>
+      </p:sp>
+      <p:sp>
+        <p:nvSpPr>
+          <p:cNvPr id="26" name="TextBox 25">
+            <a:extLst>
+              <a:ext uri="{FF2B5EF4-FFF2-40B4-BE49-F238E27FC236}">
+                <a16:creationId xmlns:a16="http://schemas.microsoft.com/office/drawing/2014/main" id="{527F36D7-437C-CC9E-7ABB-6A073AA21AE7}"/>
+              </a:ext>
+            </a:extLst>
+          </p:cNvPr>
+          <p:cNvSpPr txBox="1"/>
+          <p:nvPr/>
+        </p:nvSpPr>
+        <p:spPr>
+          <a:xfrm>
+            <a:off x="416316" y="3237842"/>
+            <a:ext cx="1331611" cy="461665"/>
+          </a:xfrm>
+          <a:prstGeom prst="rect">
+            <a:avLst/>
+          </a:prstGeom>
+          <a:noFill/>
+        </p:spPr>
+        <p:txBody>
+          <a:bodyPr wrap="square" rtlCol="0">
+            <a:spAutoFit/>
+          </a:bodyPr>
+          <a:lstStyle/>
+          <a:p>
+            <a:r>
+              <a:rPr lang="en-US" sz="1200" b="1" dirty="0"/>
+              <a:t>ZBRTT1 Thermal IoT Simulator-N</a:t>
+            </a:r>
+            <a:endParaRPr lang="en-SG" sz="1200" b="1" dirty="0"/>
+          </a:p>
+        </p:txBody>
+      </p:sp>
+      <p:sp>
+        <p:nvSpPr>
+          <p:cNvPr id="27" name="Rectangle 26">
+            <a:extLst>
+              <a:ext uri="{FF2B5EF4-FFF2-40B4-BE49-F238E27FC236}">
+                <a16:creationId xmlns:a16="http://schemas.microsoft.com/office/drawing/2014/main" id="{FB53590E-345E-4377-6985-DEF4AAF87269}"/>
+              </a:ext>
+            </a:extLst>
+          </p:cNvPr>
+          <p:cNvSpPr/>
+          <p:nvPr/>
+        </p:nvSpPr>
+        <p:spPr>
+          <a:xfrm>
+            <a:off x="616419" y="3712763"/>
+            <a:ext cx="924720" cy="340962"/>
+          </a:xfrm>
+          <a:prstGeom prst="rect">
+            <a:avLst/>
+          </a:prstGeom>
+          <a:solidFill>
+            <a:schemeClr val="accent2"/>
+          </a:solidFill>
+        </p:spPr>
+        <p:style>
+          <a:lnRef idx="2">
+            <a:schemeClr val="accent1">
+              <a:shade val="50000"/>
+            </a:schemeClr>
+          </a:lnRef>
+          <a:fillRef idx="1">
+            <a:schemeClr val="accent1"/>
+          </a:fillRef>
+          <a:effectRef idx="0">
+            <a:schemeClr val="accent1"/>
+          </a:effectRef>
+          <a:fontRef idx="minor">
+            <a:schemeClr val="lt1"/>
+          </a:fontRef>
+        </p:style>
+        <p:txBody>
+          <a:bodyPr rtlCol="0" anchor="ctr"/>
+          <a:lstStyle/>
+          <a:p>
+            <a:r>
+              <a:rPr lang="en-US" sz="1050" b="1" dirty="0"/>
+              <a:t>MQTT Client</a:t>
+            </a:r>
+            <a:endParaRPr lang="en-SG" sz="1050" b="1" dirty="0"/>
+          </a:p>
+        </p:txBody>
+      </p:sp>
+      <p:sp>
+        <p:nvSpPr>
+          <p:cNvPr id="28" name="Rectangle 27">
+            <a:extLst>
+              <a:ext uri="{FF2B5EF4-FFF2-40B4-BE49-F238E27FC236}">
+                <a16:creationId xmlns:a16="http://schemas.microsoft.com/office/drawing/2014/main" id="{B8CF051A-5E21-BEF6-87F3-8C39FFA75A7F}"/>
+              </a:ext>
+            </a:extLst>
+          </p:cNvPr>
+          <p:cNvSpPr/>
+          <p:nvPr/>
+        </p:nvSpPr>
+        <p:spPr>
+          <a:xfrm>
+            <a:off x="336557" y="817468"/>
+            <a:ext cx="1430530" cy="961446"/>
+          </a:xfrm>
+          <a:prstGeom prst="rect">
+            <a:avLst/>
+          </a:prstGeom>
+          <a:solidFill>
+            <a:schemeClr val="accent1">
+              <a:lumMod val="20000"/>
+              <a:lumOff val="80000"/>
+            </a:schemeClr>
+          </a:solidFill>
+        </p:spPr>
+        <p:style>
+          <a:lnRef idx="2">
+            <a:schemeClr val="accent1">
+              <a:shade val="15000"/>
+            </a:schemeClr>
+          </a:lnRef>
+          <a:fillRef idx="1">
+            <a:schemeClr val="accent1"/>
+          </a:fillRef>
+          <a:effectRef idx="0">
+            <a:schemeClr val="accent1"/>
+          </a:effectRef>
+          <a:fontRef idx="minor">
+            <a:schemeClr val="lt1"/>
+          </a:fontRef>
+        </p:style>
+        <p:txBody>
+          <a:bodyPr rtlCol="0" anchor="ctr"/>
+          <a:lstStyle/>
+          <a:p>
+            <a:pPr algn="ctr"/>
+            <a:endParaRPr lang="en-SG" dirty="0"/>
+          </a:p>
+        </p:txBody>
+      </p:sp>
+      <p:sp>
+        <p:nvSpPr>
+          <p:cNvPr id="29" name="TextBox 28">
+            <a:extLst>
+              <a:ext uri="{FF2B5EF4-FFF2-40B4-BE49-F238E27FC236}">
+                <a16:creationId xmlns:a16="http://schemas.microsoft.com/office/drawing/2014/main" id="{3C34AE7D-DB0D-173B-0F43-3AF139783994}"/>
+              </a:ext>
+            </a:extLst>
+          </p:cNvPr>
+          <p:cNvSpPr txBox="1"/>
+          <p:nvPr/>
+        </p:nvSpPr>
+        <p:spPr>
+          <a:xfrm>
+            <a:off x="369753" y="817468"/>
+            <a:ext cx="1331611" cy="461665"/>
+          </a:xfrm>
+          <a:prstGeom prst="rect">
+            <a:avLst/>
+          </a:prstGeom>
+          <a:noFill/>
+        </p:spPr>
+        <p:txBody>
+          <a:bodyPr wrap="square" rtlCol="0">
+            <a:spAutoFit/>
+          </a:bodyPr>
+          <a:lstStyle/>
+          <a:p>
+            <a:r>
+              <a:rPr lang="en-US" sz="1200" b="1" dirty="0"/>
+              <a:t>ZBRTT1 Thermal IoT Simulator1</a:t>
+            </a:r>
+            <a:endParaRPr lang="en-SG" sz="1200" b="1" dirty="0"/>
+          </a:p>
+        </p:txBody>
+      </p:sp>
+      <p:sp>
+        <p:nvSpPr>
+          <p:cNvPr id="30" name="Rectangle 29">
+            <a:extLst>
+              <a:ext uri="{FF2B5EF4-FFF2-40B4-BE49-F238E27FC236}">
+                <a16:creationId xmlns:a16="http://schemas.microsoft.com/office/drawing/2014/main" id="{CD39509A-0E0C-0200-2523-3567ADB3374A}"/>
+              </a:ext>
+            </a:extLst>
+          </p:cNvPr>
+          <p:cNvSpPr/>
+          <p:nvPr/>
+        </p:nvSpPr>
+        <p:spPr>
+          <a:xfrm>
+            <a:off x="569856" y="1292389"/>
+            <a:ext cx="924720" cy="340962"/>
+          </a:xfrm>
+          <a:prstGeom prst="rect">
+            <a:avLst/>
+          </a:prstGeom>
+          <a:solidFill>
+            <a:schemeClr val="accent2"/>
+          </a:solidFill>
+        </p:spPr>
+        <p:style>
+          <a:lnRef idx="2">
+            <a:schemeClr val="accent1">
+              <a:shade val="50000"/>
+            </a:schemeClr>
+          </a:lnRef>
+          <a:fillRef idx="1">
+            <a:schemeClr val="accent1"/>
+          </a:fillRef>
+          <a:effectRef idx="0">
+            <a:schemeClr val="accent1"/>
+          </a:effectRef>
+          <a:fontRef idx="minor">
+            <a:schemeClr val="lt1"/>
+          </a:fontRef>
+        </p:style>
+        <p:txBody>
+          <a:bodyPr rtlCol="0" anchor="ctr"/>
+          <a:lstStyle/>
+          <a:p>
+            <a:r>
+              <a:rPr lang="en-US" sz="1050" b="1" dirty="0"/>
+              <a:t>MQTT Client</a:t>
+            </a:r>
+            <a:endParaRPr lang="en-SG" sz="1050" b="1" dirty="0"/>
+          </a:p>
+        </p:txBody>
+      </p:sp>
+      <p:sp>
+        <p:nvSpPr>
+          <p:cNvPr id="31" name="TextBox 30">
+            <a:extLst>
+              <a:ext uri="{FF2B5EF4-FFF2-40B4-BE49-F238E27FC236}">
+                <a16:creationId xmlns:a16="http://schemas.microsoft.com/office/drawing/2014/main" id="{61CDF7D5-593C-F1BF-6C2B-D02ACF5CF963}"/>
+              </a:ext>
+            </a:extLst>
+          </p:cNvPr>
+          <p:cNvSpPr txBox="1"/>
+          <p:nvPr/>
+        </p:nvSpPr>
+        <p:spPr>
+          <a:xfrm>
+            <a:off x="875657" y="2898707"/>
+            <a:ext cx="445456" cy="276999"/>
+          </a:xfrm>
+          <a:prstGeom prst="rect">
+            <a:avLst/>
+          </a:prstGeom>
+          <a:noFill/>
+        </p:spPr>
+        <p:txBody>
+          <a:bodyPr wrap="square" rtlCol="0">
+            <a:spAutoFit/>
+          </a:bodyPr>
+          <a:lstStyle/>
+          <a:p>
+            <a:r>
+              <a:rPr lang="en-US" sz="1200" b="1" dirty="0"/>
+              <a:t>…</a:t>
+            </a:r>
+            <a:endParaRPr lang="en-SG" sz="1200" b="1" dirty="0"/>
+          </a:p>
+        </p:txBody>
+      </p:sp>
+      <p:cxnSp>
+        <p:nvCxnSpPr>
+          <p:cNvPr id="40" name="Connector: Elbow 39">
+            <a:extLst>
+              <a:ext uri="{FF2B5EF4-FFF2-40B4-BE49-F238E27FC236}">
+                <a16:creationId xmlns:a16="http://schemas.microsoft.com/office/drawing/2014/main" id="{79D5420F-6E50-A0C9-7486-8CF44A369CA8}"/>
+              </a:ext>
+            </a:extLst>
+          </p:cNvPr>
+          <p:cNvCxnSpPr>
+            <a:cxnSpLocks/>
+            <a:stCxn id="28" idx="3"/>
+            <a:endCxn id="25" idx="3"/>
+          </p:cNvCxnSpPr>
+          <p:nvPr/>
+        </p:nvCxnSpPr>
+        <p:spPr>
+          <a:xfrm>
+            <a:off x="1767087" y="1298191"/>
+            <a:ext cx="46563" cy="2420374"/>
+          </a:xfrm>
+          <a:prstGeom prst="bentConnector3">
+            <a:avLst>
+              <a:gd name="adj1" fmla="val 590948"/>
+            </a:avLst>
+          </a:prstGeom>
+        </p:spPr>
+        <p:style>
+          <a:lnRef idx="2">
+            <a:schemeClr val="accent1"/>
+          </a:lnRef>
+          <a:fillRef idx="0">
+            <a:schemeClr val="accent1"/>
+          </a:fillRef>
+          <a:effectRef idx="1">
+            <a:schemeClr val="accent1"/>
+          </a:effectRef>
+          <a:fontRef idx="minor">
+            <a:schemeClr val="tx1"/>
+          </a:fontRef>
+        </p:style>
+      </p:cxnSp>
+      <p:sp>
+        <p:nvSpPr>
+          <p:cNvPr id="50" name="TextBox 49">
+            <a:extLst>
+              <a:ext uri="{FF2B5EF4-FFF2-40B4-BE49-F238E27FC236}">
+                <a16:creationId xmlns:a16="http://schemas.microsoft.com/office/drawing/2014/main" id="{4E4DB77B-B61C-AB43-FCAE-FB7E13F0AFD7}"/>
+              </a:ext>
+            </a:extLst>
+          </p:cNvPr>
+          <p:cNvSpPr txBox="1"/>
+          <p:nvPr/>
+        </p:nvSpPr>
+        <p:spPr>
+          <a:xfrm>
+            <a:off x="8634270" y="1459565"/>
+            <a:ext cx="1468250" cy="461665"/>
+          </a:xfrm>
+          <a:prstGeom prst="rect">
+            <a:avLst/>
+          </a:prstGeom>
+          <a:noFill/>
+        </p:spPr>
+        <p:txBody>
+          <a:bodyPr wrap="square" rtlCol="0">
+            <a:spAutoFit/>
+          </a:bodyPr>
+          <a:lstStyle/>
+          <a:p>
+            <a:r>
+              <a:rPr lang="en-US" sz="1200" b="1" dirty="0"/>
+              <a:t>MQTT Data subscribe </a:t>
+            </a:r>
+            <a:endParaRPr lang="en-SG" sz="1200" b="1" dirty="0"/>
+          </a:p>
+        </p:txBody>
+      </p:sp>
+      <p:sp>
+        <p:nvSpPr>
+          <p:cNvPr id="53" name="TextBox 52">
+            <a:extLst>
+              <a:ext uri="{FF2B5EF4-FFF2-40B4-BE49-F238E27FC236}">
+                <a16:creationId xmlns:a16="http://schemas.microsoft.com/office/drawing/2014/main" id="{EB5858FD-C830-288A-A455-1C13315FF5EA}"/>
+              </a:ext>
+            </a:extLst>
+          </p:cNvPr>
+          <p:cNvSpPr txBox="1"/>
+          <p:nvPr/>
+        </p:nvSpPr>
+        <p:spPr>
+          <a:xfrm>
+            <a:off x="2418155" y="2981193"/>
+            <a:ext cx="1468250" cy="461665"/>
+          </a:xfrm>
+          <a:prstGeom prst="rect">
+            <a:avLst/>
+          </a:prstGeom>
+          <a:noFill/>
+        </p:spPr>
+        <p:txBody>
+          <a:bodyPr wrap="square" rtlCol="0">
+            <a:spAutoFit/>
+          </a:bodyPr>
+          <a:lstStyle/>
+          <a:p>
+            <a:r>
+              <a:rPr lang="en-US" sz="1200" b="1" dirty="0"/>
+              <a:t>MQTT Data subscribe </a:t>
+            </a:r>
+            <a:endParaRPr lang="en-SG" sz="1200" b="1" dirty="0"/>
+          </a:p>
+        </p:txBody>
+      </p:sp>
+    </p:spTree>
+    <p:extLst>
+      <p:ext uri="{BB962C8B-B14F-4D97-AF65-F5344CB8AC3E}">
+        <p14:creationId xmlns:p14="http://schemas.microsoft.com/office/powerpoint/2010/main" val="1642225583"/>
       </p:ext>
     </p:extLst>
   </p:cSld>

</xml_diff>

<commit_message>
update the section 7
</commit_message>
<xml_diff>
--- a/2_SystemDesign_Doc/6_Thermal_State_Monitor_Desgin_Img/designDoc.pptx
+++ b/2_SystemDesign_Doc/6_Thermal_State_Monitor_Desgin_Img/designDoc.pptx
@@ -5,7 +5,7 @@
     <p:sldMasterId id="2147483648" r:id="rId1"/>
   </p:sldMasterIdLst>
   <p:notesMasterIdLst>
-    <p:notesMasterId r:id="rId7"/>
+    <p:notesMasterId r:id="rId8"/>
   </p:notesMasterIdLst>
   <p:sldIdLst>
     <p:sldId id="256" r:id="rId2"/>
@@ -13,6 +13,7 @@
     <p:sldId id="270" r:id="rId4"/>
     <p:sldId id="259" r:id="rId5"/>
     <p:sldId id="271" r:id="rId6"/>
+    <p:sldId id="272" r:id="rId7"/>
   </p:sldIdLst>
   <p:sldSz cx="12192000" cy="6858000"/>
   <p:notesSz cx="6858000" cy="9144000"/>
@@ -201,7 +202,7 @@
           <a:p>
             <a:fld id="{BF2FBF22-D265-4007-B382-98D1AEF44D2E}" type="datetimeFigureOut">
               <a:rPr lang="en-SG" smtClean="0"/>
-              <a:t>20/6/2026</a:t>
+              <a:t>21/6/2026</a:t>
             </a:fld>
             <a:endParaRPr lang="en-SG"/>
           </a:p>
@@ -894,7 +895,7 @@
           <a:p>
             <a:fld id="{236E59C2-7C94-434E-8336-162F25205750}" type="datetimeFigureOut">
               <a:rPr lang="en-SG" smtClean="0"/>
-              <a:t>20/6/2026</a:t>
+              <a:t>21/6/2026</a:t>
             </a:fld>
             <a:endParaRPr lang="en-SG"/>
           </a:p>
@@ -1094,7 +1095,7 @@
           <a:p>
             <a:fld id="{236E59C2-7C94-434E-8336-162F25205750}" type="datetimeFigureOut">
               <a:rPr lang="en-SG" smtClean="0"/>
-              <a:t>20/6/2026</a:t>
+              <a:t>21/6/2026</a:t>
             </a:fld>
             <a:endParaRPr lang="en-SG"/>
           </a:p>
@@ -1304,7 +1305,7 @@
           <a:p>
             <a:fld id="{236E59C2-7C94-434E-8336-162F25205750}" type="datetimeFigureOut">
               <a:rPr lang="en-SG" smtClean="0"/>
-              <a:t>20/6/2026</a:t>
+              <a:t>21/6/2026</a:t>
             </a:fld>
             <a:endParaRPr lang="en-SG"/>
           </a:p>
@@ -1504,7 +1505,7 @@
           <a:p>
             <a:fld id="{236E59C2-7C94-434E-8336-162F25205750}" type="datetimeFigureOut">
               <a:rPr lang="en-SG" smtClean="0"/>
-              <a:t>20/6/2026</a:t>
+              <a:t>21/6/2026</a:t>
             </a:fld>
             <a:endParaRPr lang="en-SG"/>
           </a:p>
@@ -1780,7 +1781,7 @@
           <a:p>
             <a:fld id="{236E59C2-7C94-434E-8336-162F25205750}" type="datetimeFigureOut">
               <a:rPr lang="en-SG" smtClean="0"/>
-              <a:t>20/6/2026</a:t>
+              <a:t>21/6/2026</a:t>
             </a:fld>
             <a:endParaRPr lang="en-SG"/>
           </a:p>
@@ -2048,7 +2049,7 @@
           <a:p>
             <a:fld id="{236E59C2-7C94-434E-8336-162F25205750}" type="datetimeFigureOut">
               <a:rPr lang="en-SG" smtClean="0"/>
-              <a:t>20/6/2026</a:t>
+              <a:t>21/6/2026</a:t>
             </a:fld>
             <a:endParaRPr lang="en-SG"/>
           </a:p>
@@ -2463,7 +2464,7 @@
           <a:p>
             <a:fld id="{236E59C2-7C94-434E-8336-162F25205750}" type="datetimeFigureOut">
               <a:rPr lang="en-SG" smtClean="0"/>
-              <a:t>20/6/2026</a:t>
+              <a:t>21/6/2026</a:t>
             </a:fld>
             <a:endParaRPr lang="en-SG"/>
           </a:p>
@@ -2605,7 +2606,7 @@
           <a:p>
             <a:fld id="{236E59C2-7C94-434E-8336-162F25205750}" type="datetimeFigureOut">
               <a:rPr lang="en-SG" smtClean="0"/>
-              <a:t>20/6/2026</a:t>
+              <a:t>21/6/2026</a:t>
             </a:fld>
             <a:endParaRPr lang="en-SG"/>
           </a:p>
@@ -2718,7 +2719,7 @@
           <a:p>
             <a:fld id="{236E59C2-7C94-434E-8336-162F25205750}" type="datetimeFigureOut">
               <a:rPr lang="en-SG" smtClean="0"/>
-              <a:t>20/6/2026</a:t>
+              <a:t>21/6/2026</a:t>
             </a:fld>
             <a:endParaRPr lang="en-SG"/>
           </a:p>
@@ -3031,7 +3032,7 @@
           <a:p>
             <a:fld id="{236E59C2-7C94-434E-8336-162F25205750}" type="datetimeFigureOut">
               <a:rPr lang="en-SG" smtClean="0"/>
-              <a:t>20/6/2026</a:t>
+              <a:t>21/6/2026</a:t>
             </a:fld>
             <a:endParaRPr lang="en-SG"/>
           </a:p>
@@ -3320,7 +3321,7 @@
           <a:p>
             <a:fld id="{236E59C2-7C94-434E-8336-162F25205750}" type="datetimeFigureOut">
               <a:rPr lang="en-SG" smtClean="0"/>
-              <a:t>20/6/2026</a:t>
+              <a:t>21/6/2026</a:t>
             </a:fld>
             <a:endParaRPr lang="en-SG"/>
           </a:p>
@@ -3563,7 +3564,7 @@
           <a:p>
             <a:fld id="{236E59C2-7C94-434E-8336-162F25205750}" type="datetimeFigureOut">
               <a:rPr lang="en-SG" smtClean="0"/>
-              <a:t>20/6/2026</a:t>
+              <a:t>21/6/2026</a:t>
             </a:fld>
             <a:endParaRPr lang="en-SG"/>
           </a:p>
@@ -17512,6 +17513,1398 @@
     <p:extLst>
       <p:ext uri="{BB962C8B-B14F-4D97-AF65-F5344CB8AC3E}">
         <p14:creationId xmlns:p14="http://schemas.microsoft.com/office/powerpoint/2010/main" val="1642225583"/>
+      </p:ext>
+    </p:extLst>
+  </p:cSld>
+  <p:clrMapOvr>
+    <a:masterClrMapping/>
+  </p:clrMapOvr>
+</p:sld>
+</file>
+
+<file path=ppt/slides/slide6.xml><?xml version="1.0" encoding="utf-8"?>
+<p:sld xmlns:a="http://schemas.openxmlformats.org/drawingml/2006/main" xmlns:r="http://schemas.openxmlformats.org/officeDocument/2006/relationships" xmlns:p="http://schemas.openxmlformats.org/presentationml/2006/main">
+  <p:cSld>
+    <p:spTree>
+      <p:nvGrpSpPr>
+        <p:cNvPr id="1" name=""/>
+        <p:cNvGrpSpPr/>
+        <p:nvPr/>
+      </p:nvGrpSpPr>
+      <p:grpSpPr>
+        <a:xfrm>
+          <a:off x="0" y="0"/>
+          <a:ext cx="0" cy="0"/>
+          <a:chOff x="0" y="0"/>
+          <a:chExt cx="0" cy="0"/>
+        </a:xfrm>
+      </p:grpSpPr>
+      <p:sp>
+        <p:nvSpPr>
+          <p:cNvPr id="4" name="Rectangle 3">
+            <a:extLst>
+              <a:ext uri="{FF2B5EF4-FFF2-40B4-BE49-F238E27FC236}">
+                <a16:creationId xmlns:a16="http://schemas.microsoft.com/office/drawing/2014/main" id="{07228B72-C4AC-B3C7-64C0-FBA1505526B8}"/>
+              </a:ext>
+            </a:extLst>
+          </p:cNvPr>
+          <p:cNvSpPr/>
+          <p:nvPr/>
+        </p:nvSpPr>
+        <p:spPr>
+          <a:xfrm>
+            <a:off x="4768662" y="952824"/>
+            <a:ext cx="1468193" cy="1499920"/>
+          </a:xfrm>
+          <a:prstGeom prst="rect">
+            <a:avLst/>
+          </a:prstGeom>
+          <a:solidFill>
+            <a:schemeClr val="accent6">
+              <a:lumMod val="20000"/>
+              <a:lumOff val="80000"/>
+            </a:schemeClr>
+          </a:solidFill>
+        </p:spPr>
+        <p:style>
+          <a:lnRef idx="2">
+            <a:schemeClr val="accent1">
+              <a:shade val="15000"/>
+            </a:schemeClr>
+          </a:lnRef>
+          <a:fillRef idx="1">
+            <a:schemeClr val="accent1"/>
+          </a:fillRef>
+          <a:effectRef idx="0">
+            <a:schemeClr val="accent1"/>
+          </a:effectRef>
+          <a:fontRef idx="minor">
+            <a:schemeClr val="lt1"/>
+          </a:fontRef>
+        </p:style>
+        <p:txBody>
+          <a:bodyPr rtlCol="0" anchor="ctr"/>
+          <a:lstStyle/>
+          <a:p>
+            <a:pPr algn="ctr"/>
+            <a:endParaRPr lang="en-SG" dirty="0"/>
+          </a:p>
+        </p:txBody>
+      </p:sp>
+      <p:sp>
+        <p:nvSpPr>
+          <p:cNvPr id="5" name="Rectangle 4">
+            <a:extLst>
+              <a:ext uri="{FF2B5EF4-FFF2-40B4-BE49-F238E27FC236}">
+                <a16:creationId xmlns:a16="http://schemas.microsoft.com/office/drawing/2014/main" id="{751F3066-C3AC-5C44-D469-4404958752B1}"/>
+              </a:ext>
+            </a:extLst>
+          </p:cNvPr>
+          <p:cNvSpPr/>
+          <p:nvPr/>
+        </p:nvSpPr>
+        <p:spPr>
+          <a:xfrm>
+            <a:off x="4956691" y="1999008"/>
+            <a:ext cx="1062441" cy="340962"/>
+          </a:xfrm>
+          <a:prstGeom prst="rect">
+            <a:avLst/>
+          </a:prstGeom>
+          <a:solidFill>
+            <a:schemeClr val="accent2"/>
+          </a:solidFill>
+        </p:spPr>
+        <p:style>
+          <a:lnRef idx="2">
+            <a:schemeClr val="accent1">
+              <a:shade val="50000"/>
+            </a:schemeClr>
+          </a:lnRef>
+          <a:fillRef idx="1">
+            <a:schemeClr val="accent1"/>
+          </a:fillRef>
+          <a:effectRef idx="0">
+            <a:schemeClr val="accent1"/>
+          </a:effectRef>
+          <a:fontRef idx="minor">
+            <a:schemeClr val="lt1"/>
+          </a:fontRef>
+        </p:style>
+        <p:txBody>
+          <a:bodyPr rtlCol="0" anchor="ctr"/>
+          <a:lstStyle/>
+          <a:p>
+            <a:r>
+              <a:rPr lang="en-US" sz="1050" b="1" dirty="0"/>
+              <a:t>MQTT Broker</a:t>
+            </a:r>
+            <a:endParaRPr lang="en-SG" sz="1050" b="1" dirty="0"/>
+          </a:p>
+        </p:txBody>
+      </p:sp>
+      <p:sp>
+        <p:nvSpPr>
+          <p:cNvPr id="6" name="TextBox 5">
+            <a:extLst>
+              <a:ext uri="{FF2B5EF4-FFF2-40B4-BE49-F238E27FC236}">
+                <a16:creationId xmlns:a16="http://schemas.microsoft.com/office/drawing/2014/main" id="{86133C87-FCC0-6ECC-E057-D6BD89B4F367}"/>
+              </a:ext>
+            </a:extLst>
+          </p:cNvPr>
+          <p:cNvSpPr txBox="1"/>
+          <p:nvPr/>
+        </p:nvSpPr>
+        <p:spPr>
+          <a:xfrm>
+            <a:off x="4879823" y="965197"/>
+            <a:ext cx="1139309" cy="954107"/>
+          </a:xfrm>
+          <a:prstGeom prst="rect">
+            <a:avLst/>
+          </a:prstGeom>
+          <a:noFill/>
+        </p:spPr>
+        <p:txBody>
+          <a:bodyPr wrap="square" rtlCol="0">
+            <a:spAutoFit/>
+          </a:bodyPr>
+          <a:lstStyle/>
+          <a:p>
+            <a:r>
+              <a:rPr lang="en-US" sz="1400" b="1" dirty="0"/>
+              <a:t>Power Generation Area IoT Gateway </a:t>
+            </a:r>
+            <a:endParaRPr lang="en-SG" sz="1400" b="1" dirty="0"/>
+          </a:p>
+        </p:txBody>
+      </p:sp>
+      <p:sp>
+        <p:nvSpPr>
+          <p:cNvPr id="7" name="Rectangle 6">
+            <a:extLst>
+              <a:ext uri="{FF2B5EF4-FFF2-40B4-BE49-F238E27FC236}">
+                <a16:creationId xmlns:a16="http://schemas.microsoft.com/office/drawing/2014/main" id="{5A3A3E61-FBB0-73A1-A8D0-C9A7B4384E4A}"/>
+              </a:ext>
+            </a:extLst>
+          </p:cNvPr>
+          <p:cNvSpPr/>
+          <p:nvPr/>
+        </p:nvSpPr>
+        <p:spPr>
+          <a:xfrm>
+            <a:off x="4768662" y="2778209"/>
+            <a:ext cx="1468193" cy="1499920"/>
+          </a:xfrm>
+          <a:prstGeom prst="rect">
+            <a:avLst/>
+          </a:prstGeom>
+          <a:solidFill>
+            <a:schemeClr val="accent6">
+              <a:lumMod val="20000"/>
+              <a:lumOff val="80000"/>
+            </a:schemeClr>
+          </a:solidFill>
+        </p:spPr>
+        <p:style>
+          <a:lnRef idx="2">
+            <a:schemeClr val="accent1">
+              <a:shade val="15000"/>
+            </a:schemeClr>
+          </a:lnRef>
+          <a:fillRef idx="1">
+            <a:schemeClr val="accent1"/>
+          </a:fillRef>
+          <a:effectRef idx="0">
+            <a:schemeClr val="accent1"/>
+          </a:effectRef>
+          <a:fontRef idx="minor">
+            <a:schemeClr val="lt1"/>
+          </a:fontRef>
+        </p:style>
+        <p:txBody>
+          <a:bodyPr rtlCol="0" anchor="ctr"/>
+          <a:lstStyle/>
+          <a:p>
+            <a:pPr algn="ctr"/>
+            <a:endParaRPr lang="en-SG" dirty="0"/>
+          </a:p>
+        </p:txBody>
+      </p:sp>
+      <p:sp>
+        <p:nvSpPr>
+          <p:cNvPr id="8" name="Rectangle 7">
+            <a:extLst>
+              <a:ext uri="{FF2B5EF4-FFF2-40B4-BE49-F238E27FC236}">
+                <a16:creationId xmlns:a16="http://schemas.microsoft.com/office/drawing/2014/main" id="{907E8018-BC85-1BA2-A10D-63D5FD7F754A}"/>
+              </a:ext>
+            </a:extLst>
+          </p:cNvPr>
+          <p:cNvSpPr/>
+          <p:nvPr/>
+        </p:nvSpPr>
+        <p:spPr>
+          <a:xfrm>
+            <a:off x="4956691" y="3824393"/>
+            <a:ext cx="1062441" cy="340962"/>
+          </a:xfrm>
+          <a:prstGeom prst="rect">
+            <a:avLst/>
+          </a:prstGeom>
+          <a:solidFill>
+            <a:schemeClr val="accent2"/>
+          </a:solidFill>
+        </p:spPr>
+        <p:style>
+          <a:lnRef idx="2">
+            <a:schemeClr val="accent1">
+              <a:shade val="50000"/>
+            </a:schemeClr>
+          </a:lnRef>
+          <a:fillRef idx="1">
+            <a:schemeClr val="accent1"/>
+          </a:fillRef>
+          <a:effectRef idx="0">
+            <a:schemeClr val="accent1"/>
+          </a:effectRef>
+          <a:fontRef idx="minor">
+            <a:schemeClr val="lt1"/>
+          </a:fontRef>
+        </p:style>
+        <p:txBody>
+          <a:bodyPr rtlCol="0" anchor="ctr"/>
+          <a:lstStyle/>
+          <a:p>
+            <a:r>
+              <a:rPr lang="en-US" sz="1050" b="1" dirty="0"/>
+              <a:t>MQTT Broker</a:t>
+            </a:r>
+            <a:endParaRPr lang="en-SG" sz="1050" b="1" dirty="0"/>
+          </a:p>
+        </p:txBody>
+      </p:sp>
+      <p:sp>
+        <p:nvSpPr>
+          <p:cNvPr id="9" name="TextBox 8">
+            <a:extLst>
+              <a:ext uri="{FF2B5EF4-FFF2-40B4-BE49-F238E27FC236}">
+                <a16:creationId xmlns:a16="http://schemas.microsoft.com/office/drawing/2014/main" id="{64FC9071-7C2F-0BD8-EE11-E778CD1E4353}"/>
+              </a:ext>
+            </a:extLst>
+          </p:cNvPr>
+          <p:cNvSpPr txBox="1"/>
+          <p:nvPr/>
+        </p:nvSpPr>
+        <p:spPr>
+          <a:xfrm>
+            <a:off x="4879823" y="2790582"/>
+            <a:ext cx="1327339" cy="954107"/>
+          </a:xfrm>
+          <a:prstGeom prst="rect">
+            <a:avLst/>
+          </a:prstGeom>
+          <a:noFill/>
+        </p:spPr>
+        <p:txBody>
+          <a:bodyPr wrap="square" rtlCol="0">
+            <a:spAutoFit/>
+          </a:bodyPr>
+          <a:lstStyle/>
+          <a:p>
+            <a:r>
+              <a:rPr lang="en-US" sz="1400" b="1" dirty="0"/>
+              <a:t>Power Transmission Area IoT Gateway </a:t>
+            </a:r>
+            <a:endParaRPr lang="en-SG" sz="1400" b="1" dirty="0"/>
+          </a:p>
+        </p:txBody>
+      </p:sp>
+      <p:sp>
+        <p:nvSpPr>
+          <p:cNvPr id="10" name="Rectangle 9">
+            <a:extLst>
+              <a:ext uri="{FF2B5EF4-FFF2-40B4-BE49-F238E27FC236}">
+                <a16:creationId xmlns:a16="http://schemas.microsoft.com/office/drawing/2014/main" id="{756331CB-5CFE-9975-BEAC-DC7F07DC312C}"/>
+              </a:ext>
+            </a:extLst>
+          </p:cNvPr>
+          <p:cNvSpPr/>
+          <p:nvPr/>
+        </p:nvSpPr>
+        <p:spPr>
+          <a:xfrm>
+            <a:off x="4802500" y="4533719"/>
+            <a:ext cx="1445941" cy="1499920"/>
+          </a:xfrm>
+          <a:prstGeom prst="rect">
+            <a:avLst/>
+          </a:prstGeom>
+          <a:solidFill>
+            <a:schemeClr val="accent6">
+              <a:lumMod val="20000"/>
+              <a:lumOff val="80000"/>
+            </a:schemeClr>
+          </a:solidFill>
+        </p:spPr>
+        <p:style>
+          <a:lnRef idx="2">
+            <a:schemeClr val="accent1">
+              <a:shade val="15000"/>
+            </a:schemeClr>
+          </a:lnRef>
+          <a:fillRef idx="1">
+            <a:schemeClr val="accent1"/>
+          </a:fillRef>
+          <a:effectRef idx="0">
+            <a:schemeClr val="accent1"/>
+          </a:effectRef>
+          <a:fontRef idx="minor">
+            <a:schemeClr val="lt1"/>
+          </a:fontRef>
+        </p:style>
+        <p:txBody>
+          <a:bodyPr rtlCol="0" anchor="ctr"/>
+          <a:lstStyle/>
+          <a:p>
+            <a:pPr algn="ctr"/>
+            <a:endParaRPr lang="en-SG" dirty="0"/>
+          </a:p>
+        </p:txBody>
+      </p:sp>
+      <p:sp>
+        <p:nvSpPr>
+          <p:cNvPr id="11" name="Rectangle 10">
+            <a:extLst>
+              <a:ext uri="{FF2B5EF4-FFF2-40B4-BE49-F238E27FC236}">
+                <a16:creationId xmlns:a16="http://schemas.microsoft.com/office/drawing/2014/main" id="{4126C1E8-F18B-92CD-486F-EB6C7E1405C9}"/>
+              </a:ext>
+            </a:extLst>
+          </p:cNvPr>
+          <p:cNvSpPr/>
+          <p:nvPr/>
+        </p:nvSpPr>
+        <p:spPr>
+          <a:xfrm>
+            <a:off x="4956691" y="5579903"/>
+            <a:ext cx="1062441" cy="340962"/>
+          </a:xfrm>
+          <a:prstGeom prst="rect">
+            <a:avLst/>
+          </a:prstGeom>
+          <a:solidFill>
+            <a:schemeClr val="accent2"/>
+          </a:solidFill>
+        </p:spPr>
+        <p:style>
+          <a:lnRef idx="2">
+            <a:schemeClr val="accent1">
+              <a:shade val="50000"/>
+            </a:schemeClr>
+          </a:lnRef>
+          <a:fillRef idx="1">
+            <a:schemeClr val="accent1"/>
+          </a:fillRef>
+          <a:effectRef idx="0">
+            <a:schemeClr val="accent1"/>
+          </a:effectRef>
+          <a:fontRef idx="minor">
+            <a:schemeClr val="lt1"/>
+          </a:fontRef>
+        </p:style>
+        <p:txBody>
+          <a:bodyPr rtlCol="0" anchor="ctr"/>
+          <a:lstStyle/>
+          <a:p>
+            <a:r>
+              <a:rPr lang="en-US" sz="1050" b="1" dirty="0"/>
+              <a:t>MQTT Broker</a:t>
+            </a:r>
+            <a:endParaRPr lang="en-SG" sz="1050" b="1" dirty="0"/>
+          </a:p>
+        </p:txBody>
+      </p:sp>
+      <p:sp>
+        <p:nvSpPr>
+          <p:cNvPr id="12" name="TextBox 11">
+            <a:extLst>
+              <a:ext uri="{FF2B5EF4-FFF2-40B4-BE49-F238E27FC236}">
+                <a16:creationId xmlns:a16="http://schemas.microsoft.com/office/drawing/2014/main" id="{706A6973-1E6D-D5F4-A4E8-60D04F37A7F7}"/>
+              </a:ext>
+            </a:extLst>
+          </p:cNvPr>
+          <p:cNvSpPr txBox="1"/>
+          <p:nvPr/>
+        </p:nvSpPr>
+        <p:spPr>
+          <a:xfrm>
+            <a:off x="4879823" y="4546092"/>
+            <a:ext cx="1327339" cy="954107"/>
+          </a:xfrm>
+          <a:prstGeom prst="rect">
+            <a:avLst/>
+          </a:prstGeom>
+          <a:noFill/>
+        </p:spPr>
+        <p:txBody>
+          <a:bodyPr wrap="square" rtlCol="0">
+            <a:spAutoFit/>
+          </a:bodyPr>
+          <a:lstStyle/>
+          <a:p>
+            <a:r>
+              <a:rPr lang="en-US" sz="1400" b="1" dirty="0"/>
+              <a:t>Power Distribution Area IoT Gateway </a:t>
+            </a:r>
+            <a:endParaRPr lang="en-SG" sz="1400" b="1" dirty="0"/>
+          </a:p>
+        </p:txBody>
+      </p:sp>
+      <p:sp>
+        <p:nvSpPr>
+          <p:cNvPr id="15" name="Cloud 14">
+            <a:extLst>
+              <a:ext uri="{FF2B5EF4-FFF2-40B4-BE49-F238E27FC236}">
+                <a16:creationId xmlns:a16="http://schemas.microsoft.com/office/drawing/2014/main" id="{CC15022D-AF90-3986-D9E3-9F3E3A1A81B2}"/>
+              </a:ext>
+            </a:extLst>
+          </p:cNvPr>
+          <p:cNvSpPr/>
+          <p:nvPr/>
+        </p:nvSpPr>
+        <p:spPr>
+          <a:xfrm>
+            <a:off x="3463073" y="5283679"/>
+            <a:ext cx="1185569" cy="732464"/>
+          </a:xfrm>
+          <a:prstGeom prst="cloud">
+            <a:avLst/>
+          </a:prstGeom>
+        </p:spPr>
+        <p:style>
+          <a:lnRef idx="2">
+            <a:schemeClr val="accent1">
+              <a:shade val="15000"/>
+            </a:schemeClr>
+          </a:lnRef>
+          <a:fillRef idx="1">
+            <a:schemeClr val="accent1"/>
+          </a:fillRef>
+          <a:effectRef idx="0">
+            <a:schemeClr val="accent1"/>
+          </a:effectRef>
+          <a:fontRef idx="minor">
+            <a:schemeClr val="lt1"/>
+          </a:fontRef>
+        </p:style>
+        <p:txBody>
+          <a:bodyPr rtlCol="0" anchor="ctr"/>
+          <a:lstStyle/>
+          <a:p>
+            <a:pPr algn="ctr"/>
+            <a:r>
+              <a:rPr lang="en-US" sz="1100" b="1" dirty="0"/>
+              <a:t>WIFI Network</a:t>
+            </a:r>
+            <a:endParaRPr lang="en-SG" sz="1100" b="1" dirty="0"/>
+          </a:p>
+        </p:txBody>
+      </p:sp>
+      <p:pic>
+        <p:nvPicPr>
+          <p:cNvPr id="17" name="Picture 16">
+            <a:extLst>
+              <a:ext uri="{FF2B5EF4-FFF2-40B4-BE49-F238E27FC236}">
+                <a16:creationId xmlns:a16="http://schemas.microsoft.com/office/drawing/2014/main" id="{6AA2AD1C-4558-F4A7-59E9-49B92D807408}"/>
+              </a:ext>
+            </a:extLst>
+          </p:cNvPr>
+          <p:cNvPicPr>
+            <a:picLocks noChangeAspect="1"/>
+          </p:cNvPicPr>
+          <p:nvPr/>
+        </p:nvPicPr>
+        <p:blipFill>
+          <a:blip r:embed="rId2">
+            <a:extLst>
+              <a:ext uri="{28A0092B-C50C-407E-A947-70E740481C1C}">
+                <a14:useLocalDpi xmlns:a14="http://schemas.microsoft.com/office/drawing/2010/main" val="0"/>
+              </a:ext>
+            </a:extLst>
+          </a:blip>
+          <a:stretch>
+            <a:fillRect/>
+          </a:stretch>
+        </p:blipFill>
+        <p:spPr>
+          <a:xfrm>
+            <a:off x="1313987" y="933462"/>
+            <a:ext cx="2158778" cy="985842"/>
+          </a:xfrm>
+          <a:prstGeom prst="rect">
+            <a:avLst/>
+          </a:prstGeom>
+        </p:spPr>
+      </p:pic>
+      <p:sp>
+        <p:nvSpPr>
+          <p:cNvPr id="18" name="Rectangle 17">
+            <a:extLst>
+              <a:ext uri="{FF2B5EF4-FFF2-40B4-BE49-F238E27FC236}">
+                <a16:creationId xmlns:a16="http://schemas.microsoft.com/office/drawing/2014/main" id="{1E9227BA-39A9-5868-A7BF-6CE3D3A38D68}"/>
+              </a:ext>
+            </a:extLst>
+          </p:cNvPr>
+          <p:cNvSpPr/>
+          <p:nvPr/>
+        </p:nvSpPr>
+        <p:spPr>
+          <a:xfrm>
+            <a:off x="1824836" y="1702784"/>
+            <a:ext cx="924720" cy="340962"/>
+          </a:xfrm>
+          <a:prstGeom prst="rect">
+            <a:avLst/>
+          </a:prstGeom>
+          <a:solidFill>
+            <a:schemeClr val="accent2"/>
+          </a:solidFill>
+        </p:spPr>
+        <p:style>
+          <a:lnRef idx="2">
+            <a:schemeClr val="accent1">
+              <a:shade val="50000"/>
+            </a:schemeClr>
+          </a:lnRef>
+          <a:fillRef idx="1">
+            <a:schemeClr val="accent1"/>
+          </a:fillRef>
+          <a:effectRef idx="0">
+            <a:schemeClr val="accent1"/>
+          </a:effectRef>
+          <a:fontRef idx="minor">
+            <a:schemeClr val="lt1"/>
+          </a:fontRef>
+        </p:style>
+        <p:txBody>
+          <a:bodyPr rtlCol="0" anchor="ctr"/>
+          <a:lstStyle/>
+          <a:p>
+            <a:r>
+              <a:rPr lang="en-US" sz="1050" b="1" dirty="0"/>
+              <a:t>MQTT Client</a:t>
+            </a:r>
+            <a:endParaRPr lang="en-SG" sz="1050" b="1" dirty="0"/>
+          </a:p>
+        </p:txBody>
+      </p:sp>
+      <p:cxnSp>
+        <p:nvCxnSpPr>
+          <p:cNvPr id="20" name="Connector: Elbow 19">
+            <a:extLst>
+              <a:ext uri="{FF2B5EF4-FFF2-40B4-BE49-F238E27FC236}">
+                <a16:creationId xmlns:a16="http://schemas.microsoft.com/office/drawing/2014/main" id="{ED4CFEDC-7F31-A092-AD37-0C5D659E6703}"/>
+              </a:ext>
+            </a:extLst>
+          </p:cNvPr>
+          <p:cNvCxnSpPr>
+            <a:cxnSpLocks/>
+            <a:stCxn id="18" idx="2"/>
+            <a:endCxn id="5" idx="1"/>
+          </p:cNvCxnSpPr>
+          <p:nvPr/>
+        </p:nvCxnSpPr>
+        <p:spPr>
+          <a:xfrm rot="16200000" flipH="1">
+            <a:off x="3559072" y="771869"/>
+            <a:ext cx="125743" cy="2669495"/>
+          </a:xfrm>
+          <a:prstGeom prst="bentConnector2">
+            <a:avLst/>
+          </a:prstGeom>
+          <a:ln>
+            <a:tailEnd type="triangle"/>
+          </a:ln>
+        </p:spPr>
+        <p:style>
+          <a:lnRef idx="2">
+            <a:schemeClr val="accent1"/>
+          </a:lnRef>
+          <a:fillRef idx="0">
+            <a:schemeClr val="accent1"/>
+          </a:fillRef>
+          <a:effectRef idx="1">
+            <a:schemeClr val="accent1"/>
+          </a:effectRef>
+          <a:fontRef idx="minor">
+            <a:schemeClr val="tx1"/>
+          </a:fontRef>
+        </p:style>
+      </p:cxnSp>
+      <p:sp>
+        <p:nvSpPr>
+          <p:cNvPr id="13" name="Cloud 12">
+            <a:extLst>
+              <a:ext uri="{FF2B5EF4-FFF2-40B4-BE49-F238E27FC236}">
+                <a16:creationId xmlns:a16="http://schemas.microsoft.com/office/drawing/2014/main" id="{A4B6D679-37A5-6B32-3D9D-7D2CC937CB83}"/>
+              </a:ext>
+            </a:extLst>
+          </p:cNvPr>
+          <p:cNvSpPr/>
+          <p:nvPr/>
+        </p:nvSpPr>
+        <p:spPr>
+          <a:xfrm>
+            <a:off x="3472765" y="1702784"/>
+            <a:ext cx="1185569" cy="732464"/>
+          </a:xfrm>
+          <a:prstGeom prst="cloud">
+            <a:avLst/>
+          </a:prstGeom>
+        </p:spPr>
+        <p:style>
+          <a:lnRef idx="2">
+            <a:schemeClr val="accent1">
+              <a:shade val="15000"/>
+            </a:schemeClr>
+          </a:lnRef>
+          <a:fillRef idx="1">
+            <a:schemeClr val="accent1"/>
+          </a:fillRef>
+          <a:effectRef idx="0">
+            <a:schemeClr val="accent1"/>
+          </a:effectRef>
+          <a:fontRef idx="minor">
+            <a:schemeClr val="lt1"/>
+          </a:fontRef>
+        </p:style>
+        <p:txBody>
+          <a:bodyPr rtlCol="0" anchor="ctr"/>
+          <a:lstStyle/>
+          <a:p>
+            <a:pPr algn="ctr"/>
+            <a:r>
+              <a:rPr lang="en-US" sz="1100" b="1" dirty="0"/>
+              <a:t>WIFI Network</a:t>
+            </a:r>
+            <a:endParaRPr lang="en-SG" sz="1100" b="1" dirty="0"/>
+          </a:p>
+        </p:txBody>
+      </p:sp>
+      <p:pic>
+        <p:nvPicPr>
+          <p:cNvPr id="24" name="Picture 23">
+            <a:extLst>
+              <a:ext uri="{FF2B5EF4-FFF2-40B4-BE49-F238E27FC236}">
+                <a16:creationId xmlns:a16="http://schemas.microsoft.com/office/drawing/2014/main" id="{E4B31E91-1C17-6F5D-4405-167E52E04A3E}"/>
+              </a:ext>
+            </a:extLst>
+          </p:cNvPr>
+          <p:cNvPicPr>
+            <a:picLocks noChangeAspect="1"/>
+          </p:cNvPicPr>
+          <p:nvPr/>
+        </p:nvPicPr>
+        <p:blipFill>
+          <a:blip r:embed="rId2">
+            <a:extLst>
+              <a:ext uri="{28A0092B-C50C-407E-A947-70E740481C1C}">
+                <a14:useLocalDpi xmlns:a14="http://schemas.microsoft.com/office/drawing/2010/main" val="0"/>
+              </a:ext>
+            </a:extLst>
+          </a:blip>
+          <a:stretch>
+            <a:fillRect/>
+          </a:stretch>
+        </p:blipFill>
+        <p:spPr>
+          <a:xfrm>
+            <a:off x="1313987" y="2618843"/>
+            <a:ext cx="2158778" cy="985842"/>
+          </a:xfrm>
+          <a:prstGeom prst="rect">
+            <a:avLst/>
+          </a:prstGeom>
+        </p:spPr>
+      </p:pic>
+      <p:sp>
+        <p:nvSpPr>
+          <p:cNvPr id="25" name="Rectangle 24">
+            <a:extLst>
+              <a:ext uri="{FF2B5EF4-FFF2-40B4-BE49-F238E27FC236}">
+                <a16:creationId xmlns:a16="http://schemas.microsoft.com/office/drawing/2014/main" id="{742E354E-16F6-F758-F748-B154F1AED4C0}"/>
+              </a:ext>
+            </a:extLst>
+          </p:cNvPr>
+          <p:cNvSpPr/>
+          <p:nvPr/>
+        </p:nvSpPr>
+        <p:spPr>
+          <a:xfrm>
+            <a:off x="1935164" y="3309648"/>
+            <a:ext cx="924720" cy="340962"/>
+          </a:xfrm>
+          <a:prstGeom prst="rect">
+            <a:avLst/>
+          </a:prstGeom>
+          <a:solidFill>
+            <a:schemeClr val="accent2"/>
+          </a:solidFill>
+        </p:spPr>
+        <p:style>
+          <a:lnRef idx="2">
+            <a:schemeClr val="accent1">
+              <a:shade val="50000"/>
+            </a:schemeClr>
+          </a:lnRef>
+          <a:fillRef idx="1">
+            <a:schemeClr val="accent1"/>
+          </a:fillRef>
+          <a:effectRef idx="0">
+            <a:schemeClr val="accent1"/>
+          </a:effectRef>
+          <a:fontRef idx="minor">
+            <a:schemeClr val="lt1"/>
+          </a:fontRef>
+        </p:style>
+        <p:txBody>
+          <a:bodyPr rtlCol="0" anchor="ctr"/>
+          <a:lstStyle/>
+          <a:p>
+            <a:r>
+              <a:rPr lang="en-US" sz="1050" b="1" dirty="0"/>
+              <a:t>MQTT Client</a:t>
+            </a:r>
+            <a:endParaRPr lang="en-SG" sz="1050" b="1" dirty="0"/>
+          </a:p>
+        </p:txBody>
+      </p:sp>
+      <p:cxnSp>
+        <p:nvCxnSpPr>
+          <p:cNvPr id="26" name="Connector: Elbow 25">
+            <a:extLst>
+              <a:ext uri="{FF2B5EF4-FFF2-40B4-BE49-F238E27FC236}">
+                <a16:creationId xmlns:a16="http://schemas.microsoft.com/office/drawing/2014/main" id="{0A6182EB-4D64-4CB2-B941-2C039CC71605}"/>
+              </a:ext>
+            </a:extLst>
+          </p:cNvPr>
+          <p:cNvCxnSpPr>
+            <a:cxnSpLocks/>
+            <a:stCxn id="25" idx="2"/>
+            <a:endCxn id="8" idx="1"/>
+          </p:cNvCxnSpPr>
+          <p:nvPr/>
+        </p:nvCxnSpPr>
+        <p:spPr>
+          <a:xfrm rot="16200000" flipH="1">
+            <a:off x="3504975" y="2543158"/>
+            <a:ext cx="344264" cy="2559167"/>
+          </a:xfrm>
+          <a:prstGeom prst="bentConnector2">
+            <a:avLst/>
+          </a:prstGeom>
+          <a:ln>
+            <a:tailEnd type="triangle"/>
+          </a:ln>
+        </p:spPr>
+        <p:style>
+          <a:lnRef idx="2">
+            <a:schemeClr val="accent1"/>
+          </a:lnRef>
+          <a:fillRef idx="0">
+            <a:schemeClr val="accent1"/>
+          </a:fillRef>
+          <a:effectRef idx="1">
+            <a:schemeClr val="accent1"/>
+          </a:effectRef>
+          <a:fontRef idx="minor">
+            <a:schemeClr val="tx1"/>
+          </a:fontRef>
+        </p:style>
+      </p:cxnSp>
+      <p:sp>
+        <p:nvSpPr>
+          <p:cNvPr id="14" name="Cloud 13">
+            <a:extLst>
+              <a:ext uri="{FF2B5EF4-FFF2-40B4-BE49-F238E27FC236}">
+                <a16:creationId xmlns:a16="http://schemas.microsoft.com/office/drawing/2014/main" id="{3CAC9361-7866-0F77-1EDA-88B17A754663}"/>
+              </a:ext>
+            </a:extLst>
+          </p:cNvPr>
+          <p:cNvSpPr/>
+          <p:nvPr/>
+        </p:nvSpPr>
+        <p:spPr>
+          <a:xfrm>
+            <a:off x="3463074" y="3484042"/>
+            <a:ext cx="1185569" cy="732464"/>
+          </a:xfrm>
+          <a:prstGeom prst="cloud">
+            <a:avLst/>
+          </a:prstGeom>
+        </p:spPr>
+        <p:style>
+          <a:lnRef idx="2">
+            <a:schemeClr val="accent1">
+              <a:shade val="15000"/>
+            </a:schemeClr>
+          </a:lnRef>
+          <a:fillRef idx="1">
+            <a:schemeClr val="accent1"/>
+          </a:fillRef>
+          <a:effectRef idx="0">
+            <a:schemeClr val="accent1"/>
+          </a:effectRef>
+          <a:fontRef idx="minor">
+            <a:schemeClr val="lt1"/>
+          </a:fontRef>
+        </p:style>
+        <p:txBody>
+          <a:bodyPr rtlCol="0" anchor="ctr"/>
+          <a:lstStyle/>
+          <a:p>
+            <a:pPr algn="ctr"/>
+            <a:r>
+              <a:rPr lang="en-US" sz="1100" b="1" dirty="0"/>
+              <a:t>WIFI Network</a:t>
+            </a:r>
+            <a:endParaRPr lang="en-SG" sz="1100" b="1" dirty="0"/>
+          </a:p>
+        </p:txBody>
+      </p:sp>
+      <p:pic>
+        <p:nvPicPr>
+          <p:cNvPr id="29" name="Picture 28">
+            <a:extLst>
+              <a:ext uri="{FF2B5EF4-FFF2-40B4-BE49-F238E27FC236}">
+                <a16:creationId xmlns:a16="http://schemas.microsoft.com/office/drawing/2014/main" id="{8F081894-E666-B905-7D64-6CEFB609508E}"/>
+              </a:ext>
+            </a:extLst>
+          </p:cNvPr>
+          <p:cNvPicPr>
+            <a:picLocks noChangeAspect="1"/>
+          </p:cNvPicPr>
+          <p:nvPr/>
+        </p:nvPicPr>
+        <p:blipFill>
+          <a:blip r:embed="rId2">
+            <a:extLst>
+              <a:ext uri="{28A0092B-C50C-407E-A947-70E740481C1C}">
+                <a14:useLocalDpi xmlns:a14="http://schemas.microsoft.com/office/drawing/2010/main" val="0"/>
+              </a:ext>
+            </a:extLst>
+          </a:blip>
+          <a:stretch>
+            <a:fillRect/>
+          </a:stretch>
+        </p:blipFill>
+        <p:spPr>
+          <a:xfrm>
+            <a:off x="1313987" y="4391553"/>
+            <a:ext cx="2158778" cy="985842"/>
+          </a:xfrm>
+          <a:prstGeom prst="rect">
+            <a:avLst/>
+          </a:prstGeom>
+        </p:spPr>
+      </p:pic>
+      <p:sp>
+        <p:nvSpPr>
+          <p:cNvPr id="30" name="Rectangle 29">
+            <a:extLst>
+              <a:ext uri="{FF2B5EF4-FFF2-40B4-BE49-F238E27FC236}">
+                <a16:creationId xmlns:a16="http://schemas.microsoft.com/office/drawing/2014/main" id="{93310BE0-CBF8-D1D7-B126-A3E3E0B1EB6E}"/>
+              </a:ext>
+            </a:extLst>
+          </p:cNvPr>
+          <p:cNvSpPr/>
+          <p:nvPr/>
+        </p:nvSpPr>
+        <p:spPr>
+          <a:xfrm>
+            <a:off x="1828983" y="5064812"/>
+            <a:ext cx="924720" cy="340962"/>
+          </a:xfrm>
+          <a:prstGeom prst="rect">
+            <a:avLst/>
+          </a:prstGeom>
+          <a:solidFill>
+            <a:schemeClr val="accent2"/>
+          </a:solidFill>
+        </p:spPr>
+        <p:style>
+          <a:lnRef idx="2">
+            <a:schemeClr val="accent1">
+              <a:shade val="50000"/>
+            </a:schemeClr>
+          </a:lnRef>
+          <a:fillRef idx="1">
+            <a:schemeClr val="accent1"/>
+          </a:fillRef>
+          <a:effectRef idx="0">
+            <a:schemeClr val="accent1"/>
+          </a:effectRef>
+          <a:fontRef idx="minor">
+            <a:schemeClr val="lt1"/>
+          </a:fontRef>
+        </p:style>
+        <p:txBody>
+          <a:bodyPr rtlCol="0" anchor="ctr"/>
+          <a:lstStyle/>
+          <a:p>
+            <a:r>
+              <a:rPr lang="en-US" sz="1050" b="1" dirty="0"/>
+              <a:t>MQTT Client</a:t>
+            </a:r>
+            <a:endParaRPr lang="en-SG" sz="1050" b="1" dirty="0"/>
+          </a:p>
+        </p:txBody>
+      </p:sp>
+      <p:cxnSp>
+        <p:nvCxnSpPr>
+          <p:cNvPr id="31" name="Connector: Elbow 30">
+            <a:extLst>
+              <a:ext uri="{FF2B5EF4-FFF2-40B4-BE49-F238E27FC236}">
+                <a16:creationId xmlns:a16="http://schemas.microsoft.com/office/drawing/2014/main" id="{6E8FB664-1B7B-494B-512B-4FDD4DB64C20}"/>
+              </a:ext>
+            </a:extLst>
+          </p:cNvPr>
+          <p:cNvCxnSpPr>
+            <a:cxnSpLocks/>
+            <a:stCxn id="30" idx="2"/>
+          </p:cNvCxnSpPr>
+          <p:nvPr/>
+        </p:nvCxnSpPr>
+        <p:spPr>
+          <a:xfrm rot="16200000" flipH="1">
+            <a:off x="3441750" y="4255367"/>
+            <a:ext cx="364534" cy="2665348"/>
+          </a:xfrm>
+          <a:prstGeom prst="bentConnector2">
+            <a:avLst/>
+          </a:prstGeom>
+          <a:ln>
+            <a:tailEnd type="triangle"/>
+          </a:ln>
+        </p:spPr>
+        <p:style>
+          <a:lnRef idx="2">
+            <a:schemeClr val="accent1"/>
+          </a:lnRef>
+          <a:fillRef idx="0">
+            <a:schemeClr val="accent1"/>
+          </a:fillRef>
+          <a:effectRef idx="1">
+            <a:schemeClr val="accent1"/>
+          </a:effectRef>
+          <a:fontRef idx="minor">
+            <a:schemeClr val="tx1"/>
+          </a:fontRef>
+        </p:style>
+      </p:cxnSp>
+      <p:sp>
+        <p:nvSpPr>
+          <p:cNvPr id="33" name="TextBox 32">
+            <a:extLst>
+              <a:ext uri="{FF2B5EF4-FFF2-40B4-BE49-F238E27FC236}">
+                <a16:creationId xmlns:a16="http://schemas.microsoft.com/office/drawing/2014/main" id="{A5DE7D68-B227-7670-DD22-AC68CAED9B50}"/>
+              </a:ext>
+            </a:extLst>
+          </p:cNvPr>
+          <p:cNvSpPr txBox="1"/>
+          <p:nvPr/>
+        </p:nvSpPr>
+        <p:spPr>
+          <a:xfrm>
+            <a:off x="1313987" y="642186"/>
+            <a:ext cx="3259578" cy="307777"/>
+          </a:xfrm>
+          <a:prstGeom prst="rect">
+            <a:avLst/>
+          </a:prstGeom>
+          <a:noFill/>
+        </p:spPr>
+        <p:txBody>
+          <a:bodyPr wrap="square" rtlCol="0">
+            <a:spAutoFit/>
+          </a:bodyPr>
+          <a:lstStyle/>
+          <a:p>
+            <a:r>
+              <a:rPr lang="en-US" sz="1400" b="1" dirty="0"/>
+              <a:t>Power Plant Thermal Monitor HMI</a:t>
+            </a:r>
+            <a:endParaRPr lang="en-SG" sz="1400" b="1" dirty="0"/>
+          </a:p>
+        </p:txBody>
+      </p:sp>
+      <p:sp>
+        <p:nvSpPr>
+          <p:cNvPr id="34" name="TextBox 33">
+            <a:extLst>
+              <a:ext uri="{FF2B5EF4-FFF2-40B4-BE49-F238E27FC236}">
+                <a16:creationId xmlns:a16="http://schemas.microsoft.com/office/drawing/2014/main" id="{A39948D7-B810-5C11-6E25-C3389F0711F4}"/>
+              </a:ext>
+            </a:extLst>
+          </p:cNvPr>
+          <p:cNvSpPr txBox="1"/>
+          <p:nvPr/>
+        </p:nvSpPr>
+        <p:spPr>
+          <a:xfrm>
+            <a:off x="1202038" y="2374668"/>
+            <a:ext cx="3600462" cy="307777"/>
+          </a:xfrm>
+          <a:prstGeom prst="rect">
+            <a:avLst/>
+          </a:prstGeom>
+          <a:noFill/>
+        </p:spPr>
+        <p:txBody>
+          <a:bodyPr wrap="square" rtlCol="0">
+            <a:spAutoFit/>
+          </a:bodyPr>
+          <a:lstStyle/>
+          <a:p>
+            <a:r>
+              <a:rPr lang="en-US" sz="1400" b="1" dirty="0"/>
+              <a:t>Transmission Tower Thermal Monitor HMI</a:t>
+            </a:r>
+            <a:endParaRPr lang="en-SG" sz="1400" b="1" dirty="0"/>
+          </a:p>
+        </p:txBody>
+      </p:sp>
+      <p:sp>
+        <p:nvSpPr>
+          <p:cNvPr id="35" name="TextBox 34">
+            <a:extLst>
+              <a:ext uri="{FF2B5EF4-FFF2-40B4-BE49-F238E27FC236}">
+                <a16:creationId xmlns:a16="http://schemas.microsoft.com/office/drawing/2014/main" id="{44A480A9-1789-3659-4146-48713C7BE749}"/>
+              </a:ext>
+            </a:extLst>
+          </p:cNvPr>
+          <p:cNvSpPr txBox="1"/>
+          <p:nvPr/>
+        </p:nvSpPr>
+        <p:spPr>
+          <a:xfrm>
+            <a:off x="1240927" y="4156589"/>
+            <a:ext cx="3600462" cy="307777"/>
+          </a:xfrm>
+          <a:prstGeom prst="rect">
+            <a:avLst/>
+          </a:prstGeom>
+          <a:noFill/>
+        </p:spPr>
+        <p:txBody>
+          <a:bodyPr wrap="square" rtlCol="0">
+            <a:spAutoFit/>
+          </a:bodyPr>
+          <a:lstStyle/>
+          <a:p>
+            <a:r>
+              <a:rPr lang="en-US" sz="1400" b="1" dirty="0"/>
+              <a:t>Power Station Thermal Monitor HMI</a:t>
+            </a:r>
+            <a:endParaRPr lang="en-SG" sz="1400" b="1" dirty="0"/>
+          </a:p>
+        </p:txBody>
+      </p:sp>
+      <p:sp>
+        <p:nvSpPr>
+          <p:cNvPr id="37" name="Cloud 36">
+            <a:extLst>
+              <a:ext uri="{FF2B5EF4-FFF2-40B4-BE49-F238E27FC236}">
+                <a16:creationId xmlns:a16="http://schemas.microsoft.com/office/drawing/2014/main" id="{90A3FFBD-1B13-3A53-4EE9-C751497BCDC0}"/>
+              </a:ext>
+            </a:extLst>
+          </p:cNvPr>
+          <p:cNvSpPr/>
+          <p:nvPr/>
+        </p:nvSpPr>
+        <p:spPr>
+          <a:xfrm>
+            <a:off x="6783379" y="3545665"/>
+            <a:ext cx="1185569" cy="732464"/>
+          </a:xfrm>
+          <a:prstGeom prst="cloud">
+            <a:avLst/>
+          </a:prstGeom>
+        </p:spPr>
+        <p:style>
+          <a:lnRef idx="2">
+            <a:schemeClr val="accent1">
+              <a:shade val="15000"/>
+            </a:schemeClr>
+          </a:lnRef>
+          <a:fillRef idx="1">
+            <a:schemeClr val="accent1"/>
+          </a:fillRef>
+          <a:effectRef idx="0">
+            <a:schemeClr val="accent1"/>
+          </a:effectRef>
+          <a:fontRef idx="minor">
+            <a:schemeClr val="lt1"/>
+          </a:fontRef>
+        </p:style>
+        <p:txBody>
+          <a:bodyPr rtlCol="0" anchor="ctr"/>
+          <a:lstStyle/>
+          <a:p>
+            <a:pPr algn="ctr"/>
+            <a:r>
+              <a:rPr lang="en-US" sz="1100" b="1" dirty="0"/>
+              <a:t>5G Network</a:t>
+            </a:r>
+            <a:endParaRPr lang="en-SG" sz="1100" b="1" dirty="0"/>
+          </a:p>
+        </p:txBody>
+      </p:sp>
+      <p:cxnSp>
+        <p:nvCxnSpPr>
+          <p:cNvPr id="39" name="Connector: Elbow 38">
+            <a:extLst>
+              <a:ext uri="{FF2B5EF4-FFF2-40B4-BE49-F238E27FC236}">
+                <a16:creationId xmlns:a16="http://schemas.microsoft.com/office/drawing/2014/main" id="{F5ECF4E1-1A49-34D0-538A-0AE83E275A8C}"/>
+              </a:ext>
+            </a:extLst>
+          </p:cNvPr>
+          <p:cNvCxnSpPr>
+            <a:cxnSpLocks/>
+            <a:stCxn id="37" idx="3"/>
+            <a:endCxn id="5" idx="3"/>
+          </p:cNvCxnSpPr>
+          <p:nvPr/>
+        </p:nvCxnSpPr>
+        <p:spPr>
+          <a:xfrm rot="16200000" flipV="1">
+            <a:off x="5988621" y="2200001"/>
+            <a:ext cx="1418055" cy="1357032"/>
+          </a:xfrm>
+          <a:prstGeom prst="bentConnector2">
+            <a:avLst/>
+          </a:prstGeom>
+          <a:ln>
+            <a:tailEnd type="triangle"/>
+          </a:ln>
+        </p:spPr>
+        <p:style>
+          <a:lnRef idx="2">
+            <a:schemeClr val="accent1"/>
+          </a:lnRef>
+          <a:fillRef idx="0">
+            <a:schemeClr val="accent1"/>
+          </a:fillRef>
+          <a:effectRef idx="1">
+            <a:schemeClr val="accent1"/>
+          </a:effectRef>
+          <a:fontRef idx="minor">
+            <a:schemeClr val="tx1"/>
+          </a:fontRef>
+        </p:style>
+      </p:cxnSp>
+      <p:cxnSp>
+        <p:nvCxnSpPr>
+          <p:cNvPr id="44" name="Straight Arrow Connector 43">
+            <a:extLst>
+              <a:ext uri="{FF2B5EF4-FFF2-40B4-BE49-F238E27FC236}">
+                <a16:creationId xmlns:a16="http://schemas.microsoft.com/office/drawing/2014/main" id="{31179AC1-EF14-34B9-C781-242DF1041DBD}"/>
+              </a:ext>
+            </a:extLst>
+          </p:cNvPr>
+          <p:cNvCxnSpPr>
+            <a:cxnSpLocks/>
+            <a:endCxn id="8" idx="3"/>
+          </p:cNvCxnSpPr>
+          <p:nvPr/>
+        </p:nvCxnSpPr>
+        <p:spPr>
+          <a:xfrm flipH="1" flipV="1">
+            <a:off x="6019132" y="3994874"/>
+            <a:ext cx="851658" cy="0"/>
+          </a:xfrm>
+          <a:prstGeom prst="straightConnector1">
+            <a:avLst/>
+          </a:prstGeom>
+          <a:ln>
+            <a:tailEnd type="triangle"/>
+          </a:ln>
+        </p:spPr>
+        <p:style>
+          <a:lnRef idx="2">
+            <a:schemeClr val="accent1"/>
+          </a:lnRef>
+          <a:fillRef idx="0">
+            <a:schemeClr val="accent1"/>
+          </a:fillRef>
+          <a:effectRef idx="1">
+            <a:schemeClr val="accent1"/>
+          </a:effectRef>
+          <a:fontRef idx="minor">
+            <a:schemeClr val="tx1"/>
+          </a:fontRef>
+        </p:style>
+      </p:cxnSp>
+      <p:cxnSp>
+        <p:nvCxnSpPr>
+          <p:cNvPr id="46" name="Connector: Elbow 45">
+            <a:extLst>
+              <a:ext uri="{FF2B5EF4-FFF2-40B4-BE49-F238E27FC236}">
+                <a16:creationId xmlns:a16="http://schemas.microsoft.com/office/drawing/2014/main" id="{C41CF3CB-02CD-7769-4B3F-985A00BAB0BE}"/>
+              </a:ext>
+            </a:extLst>
+          </p:cNvPr>
+          <p:cNvCxnSpPr>
+            <a:cxnSpLocks/>
+            <a:stCxn id="37" idx="1"/>
+            <a:endCxn id="11" idx="3"/>
+          </p:cNvCxnSpPr>
+          <p:nvPr/>
+        </p:nvCxnSpPr>
+        <p:spPr>
+          <a:xfrm rot="5400000">
+            <a:off x="5961131" y="4335350"/>
+            <a:ext cx="1473035" cy="1357032"/>
+          </a:xfrm>
+          <a:prstGeom prst="bentConnector2">
+            <a:avLst/>
+          </a:prstGeom>
+          <a:ln>
+            <a:tailEnd type="triangle"/>
+          </a:ln>
+        </p:spPr>
+        <p:style>
+          <a:lnRef idx="2">
+            <a:schemeClr val="accent1"/>
+          </a:lnRef>
+          <a:fillRef idx="0">
+            <a:schemeClr val="accent1"/>
+          </a:fillRef>
+          <a:effectRef idx="1">
+            <a:schemeClr val="accent1"/>
+          </a:effectRef>
+          <a:fontRef idx="minor">
+            <a:schemeClr val="tx1"/>
+          </a:fontRef>
+        </p:style>
+      </p:cxnSp>
+      <p:pic>
+        <p:nvPicPr>
+          <p:cNvPr id="50" name="Picture 49">
+            <a:extLst>
+              <a:ext uri="{FF2B5EF4-FFF2-40B4-BE49-F238E27FC236}">
+                <a16:creationId xmlns:a16="http://schemas.microsoft.com/office/drawing/2014/main" id="{A22815E9-F477-4C71-3EC3-6AC619CA966E}"/>
+              </a:ext>
+            </a:extLst>
+          </p:cNvPr>
+          <p:cNvPicPr>
+            <a:picLocks noChangeAspect="1"/>
+          </p:cNvPicPr>
+          <p:nvPr/>
+        </p:nvPicPr>
+        <p:blipFill>
+          <a:blip r:embed="rId3">
+            <a:extLst>
+              <a:ext uri="{28A0092B-C50C-407E-A947-70E740481C1C}">
+                <a14:useLocalDpi xmlns:a14="http://schemas.microsoft.com/office/drawing/2010/main" val="0"/>
+              </a:ext>
+            </a:extLst>
+          </a:blip>
+          <a:stretch>
+            <a:fillRect/>
+          </a:stretch>
+        </p:blipFill>
+        <p:spPr>
+          <a:xfrm>
+            <a:off x="7532752" y="1098080"/>
+            <a:ext cx="3975271" cy="2142816"/>
+          </a:xfrm>
+          <a:prstGeom prst="rect">
+            <a:avLst/>
+          </a:prstGeom>
+        </p:spPr>
+      </p:pic>
+      <p:cxnSp>
+        <p:nvCxnSpPr>
+          <p:cNvPr id="52" name="Connector: Elbow 51">
+            <a:extLst>
+              <a:ext uri="{FF2B5EF4-FFF2-40B4-BE49-F238E27FC236}">
+                <a16:creationId xmlns:a16="http://schemas.microsoft.com/office/drawing/2014/main" id="{86634AE7-4104-8991-FFC2-E31CABF49C72}"/>
+              </a:ext>
+            </a:extLst>
+          </p:cNvPr>
+          <p:cNvCxnSpPr>
+            <a:stCxn id="50" idx="2"/>
+            <a:endCxn id="37" idx="0"/>
+          </p:cNvCxnSpPr>
+          <p:nvPr/>
+        </p:nvCxnSpPr>
+        <p:spPr>
+          <a:xfrm rot="5400000">
+            <a:off x="8408674" y="2800182"/>
+            <a:ext cx="671001" cy="1552428"/>
+          </a:xfrm>
+          <a:prstGeom prst="bentConnector2">
+            <a:avLst/>
+          </a:prstGeom>
+          <a:ln>
+            <a:tailEnd type="triangle"/>
+          </a:ln>
+        </p:spPr>
+        <p:style>
+          <a:lnRef idx="2">
+            <a:schemeClr val="accent1"/>
+          </a:lnRef>
+          <a:fillRef idx="0">
+            <a:schemeClr val="accent1"/>
+          </a:fillRef>
+          <a:effectRef idx="1">
+            <a:schemeClr val="accent1"/>
+          </a:effectRef>
+          <a:fontRef idx="minor">
+            <a:schemeClr val="tx1"/>
+          </a:fontRef>
+        </p:style>
+      </p:cxnSp>
+      <p:sp>
+        <p:nvSpPr>
+          <p:cNvPr id="53" name="TextBox 52">
+            <a:extLst>
+              <a:ext uri="{FF2B5EF4-FFF2-40B4-BE49-F238E27FC236}">
+                <a16:creationId xmlns:a16="http://schemas.microsoft.com/office/drawing/2014/main" id="{54807396-F6F6-8494-36DA-979765C9D933}"/>
+              </a:ext>
+            </a:extLst>
+          </p:cNvPr>
+          <p:cNvSpPr txBox="1"/>
+          <p:nvPr/>
+        </p:nvSpPr>
+        <p:spPr>
+          <a:xfrm>
+            <a:off x="7532751" y="811308"/>
+            <a:ext cx="3975271" cy="307777"/>
+          </a:xfrm>
+          <a:prstGeom prst="rect">
+            <a:avLst/>
+          </a:prstGeom>
+          <a:noFill/>
+        </p:spPr>
+        <p:txBody>
+          <a:bodyPr wrap="square" rtlCol="0">
+            <a:spAutoFit/>
+          </a:bodyPr>
+          <a:lstStyle/>
+          <a:p>
+            <a:r>
+              <a:rPr lang="en-US" sz="1400" b="1" dirty="0"/>
+              <a:t>OCC Power Grid Thermal State Monitor HMI</a:t>
+            </a:r>
+            <a:endParaRPr lang="en-SG" sz="1400" b="1" dirty="0"/>
+          </a:p>
+        </p:txBody>
+      </p:sp>
+    </p:spTree>
+    <p:extLst>
+      <p:ext uri="{BB962C8B-B14F-4D97-AF65-F5344CB8AC3E}">
+        <p14:creationId xmlns:p14="http://schemas.microsoft.com/office/powerpoint/2010/main" val="40138501"/>
       </p:ext>
     </p:extLst>
   </p:cSld>

</xml_diff>